<commit_message>
feat(soutenance): ajoute la diapositive des bibliotheques utilisees
Troisieme diapositive des deux supports (HTML et PowerPoint) : pandas,
NumPy, Matplotlib et scikit-learn, chacun justifie face a l alternative
ecartee (Polars, Seaborn, Plotly). La note de bas de diapositive porte le
gain de memoire obtenu par les types compacts, 3,2 Go ramenes a 1,0 Go.

Corrige au passage l absence de declaration d encodage dans
soutenance.html : sans <meta charset="utf-8">, les accents se degradaient
selon le contexte d ouverture.

Co-Authored-By: Claude Opus 5 <noreply@anthropic.com>
</commit_message>
<xml_diff>
--- a/02_projet/soutenance.pptx
+++ b/02_projet/soutenance.pptx
@@ -10,6 +10,7 @@
   <p:sldIdLst>
     <p:sldId id="256" r:id="rId2"/>
     <p:sldId id="257" r:id="rId3"/>
+    <p:sldId id="274" r:id="rId22"/>
     <p:sldId id="258" r:id="rId4"/>
     <p:sldId id="259" r:id="rId5"/>
     <p:sldId id="260" r:id="rId6"/>
@@ -874,6 +875,93 @@
         <p14:creationId xmlns:p14="http://schemas.microsoft.com/office/powerpoint/2010/main" val="1024086991"/>
       </p:ext>
     </p:extLst>
+  </p:cSld>
+  <p:clrMapOvr>
+    <a:masterClrMapping/>
+  </p:clrMapOvr>
+</p:notes>
+</file>
+
+<file path=ppt/notesSlides/notesSlide16.xml><?xml version="1.0" encoding="utf-8"?>
+<p:notes xmlns:a="http://schemas.openxmlformats.org/drawingml/2006/main" xmlns:p="http://schemas.openxmlformats.org/presentationml/2006/main" xmlns:r="http://schemas.openxmlformats.org/officeDocument/2006/relationships">
+  <p:cSld>
+    <p:spTree>
+      <p:nvGrpSpPr>
+        <p:cNvPr id="1" name=""/>
+        <p:cNvGrpSpPr/>
+        <p:nvPr/>
+      </p:nvGrpSpPr>
+      <p:grpSpPr>
+        <a:xfrm>
+          <a:off x="0" y="0"/>
+          <a:ext cx="0" cy="0"/>
+          <a:chOff x="0" y="0"/>
+          <a:chExt cx="0" cy="0"/>
+        </a:xfrm>
+      </p:grpSpPr>
+      <p:sp>
+        <p:nvSpPr>
+          <p:cNvPr id="2" name="Slide Image Placeholder 1"/>
+          <p:cNvSpPr>
+            <a:spLocks noGrp="1" noRot="1" noChangeAspect="1"/>
+          </p:cNvSpPr>
+          <p:nvPr>
+            <p:ph type="sldImg"/>
+          </p:nvPr>
+        </p:nvSpPr>
+        <p:spPr/>
+      </p:sp>
+      <p:sp>
+        <p:nvSpPr>
+          <p:cNvPr id="3" name="Notes Placeholder 2"/>
+          <p:cNvSpPr>
+            <a:spLocks noGrp="1"/>
+          </p:cNvSpPr>
+          <p:nvPr>
+            <p:ph type="body" idx="1"/>
+          </p:nvPr>
+        </p:nvSpPr>
+        <p:spPr/>
+        <p:txBody>
+          <a:bodyPr/>
+          <a:lstStyle/>
+          <a:p>
+            <a:r>
+              <a:rPr lang="fr-FR"/>
+              <a:t>AVEC QUOI — 40 secondes.
+Cette diapositive répond à une question que le jury posera de toute façon. Ne lisez pas les quatre cases : donnez la logique. « Chaque bibliothèque a été choisie contre une alternative, pas prise par défaut. »
+LE POINT À FAIRE ENTENDRE : Matplotlib plutôt que Seaborn est un choix coûteux — davantage de lignes de code — mais c'est lui qui nous a permis de retirer chaque ornement inutile. Sans ce contrôle, la promesse d'un graphique lisible ne tenait pas.
+LE CHIFFRE À CITER : 3,2 Go ramenés à 1,0 Go en imposant les types. Par défaut pandas met tout entier en int64, huit octets par valeur ; un jour de semaine en occupe un seul. Sur 32 millions de lignes, cet écart décide de la faisabilité.
+SI ON DEMANDE POURQUOI PAS POLARS : plus rapide, mais moins répandu. Ce code est fait pour être relu et repris — nous avons préféré le standard à la performance.
+SI ON DEMANDE POURQUOI PAS UNE BASE DE DONNÉES : une fois typées, les cinq tables tiennent en mémoire. Un SGBD n'aurait rien apporté et aurait ajouté une dépendance à installer.</a:t>
+            </a:r>
+          </a:p>
+        </p:txBody>
+      </p:sp>
+      <p:sp>
+        <p:nvSpPr>
+          <p:cNvPr id="4" name="Slide Number Placeholder 3"/>
+          <p:cNvSpPr>
+            <a:spLocks noGrp="1"/>
+          </p:cNvSpPr>
+          <p:nvPr>
+            <p:ph type="sldNum" sz="quarter" idx="10"/>
+          </p:nvPr>
+        </p:nvSpPr>
+        <p:spPr/>
+        <p:txBody>
+          <a:bodyPr/>
+          <a:lstStyle/>
+          <a:p>
+            <a:fld id="{F7021451-1387-4CA6-816F-3879F97B5CBC}" type="slidenum">
+              <a:rPr lang="en-US"/>
+              <a:t>2</a:t>
+            </a:fld>
+            <a:endParaRPr lang="en-US"/>
+          </a:p>
+        </p:txBody>
+      </p:sp>
+    </p:spTree>
   </p:cSld>
   <p:clrMapOvr>
     <a:masterClrMapping/>
@@ -2090,6 +2178,334 @@
 
 <file path=ppt/slides/slide10.xml><?xml version="1.0" encoding="utf-8"?>
 <p:sld xmlns:a="http://schemas.openxmlformats.org/drawingml/2006/main" xmlns:r="http://schemas.openxmlformats.org/officeDocument/2006/relationships" xmlns:p="http://schemas.openxmlformats.org/presentationml/2006/main">
+  <p:cSld name="Slide 9">
+    <p:bg>
+      <p:bgPr>
+        <a:solidFill>
+          <a:srgbClr val="FFFFFF"/>
+        </a:solidFill>
+        <a:effectLst/>
+      </p:bgPr>
+    </p:bg>
+    <p:spTree>
+      <p:nvGrpSpPr>
+        <p:cNvPr id="1" name=""/>
+        <p:cNvGrpSpPr/>
+        <p:nvPr/>
+      </p:nvGrpSpPr>
+      <p:grpSpPr>
+        <a:xfrm>
+          <a:off x="0" y="0"/>
+          <a:ext cx="0" cy="0"/>
+          <a:chOff x="0" y="0"/>
+          <a:chExt cx="0" cy="0"/>
+        </a:xfrm>
+      </p:grpSpPr>
+      <p:sp>
+        <p:nvSpPr>
+          <p:cNvPr id="2" name="Text 0"/>
+          <p:cNvSpPr txBox="1"/>
+          <p:nvPr/>
+        </p:nvSpPr>
+        <p:spPr>
+          <a:xfrm>
+            <a:off x="594360" y="182880"/>
+            <a:ext cx="10972800" cy="219456"/>
+          </a:xfrm>
+          <a:prstGeom prst="rect">
+            <a:avLst/>
+          </a:prstGeom>
+          <a:noFill/>
+          <a:ln/>
+        </p:spPr>
+        <p:txBody>
+          <a:bodyPr wrap="square" lIns="0" tIns="0" rIns="0" bIns="0" rtlCol="0" anchor="ctr"/>
+          <a:lstStyle/>
+          <a:p>
+            <a:pPr marL="0" indent="0">
+              <a:buNone/>
+            </a:pPr>
+            <a:r>
+              <a:rPr lang="en-US" sz="1050" b="1" kern="0" spc="160" dirty="0">
+                <a:solidFill>
+                  <a:srgbClr val="0E7C86"/>
+                </a:solidFill>
+                <a:latin typeface="Calibri" pitchFamily="34" charset="0"/>
+                <a:ea typeface="Calibri" pitchFamily="34" charset="-122"/>
+                <a:cs typeface="Calibri" pitchFamily="34" charset="-120"/>
+              </a:rPr>
+              <a:t>DÉMONSTRATION 6</a:t>
+            </a:r>
+            <a:endParaRPr lang="en-US" sz="1050" dirty="0"/>
+          </a:p>
+        </p:txBody>
+      </p:sp>
+      <p:sp>
+        <p:nvSpPr>
+          <p:cNvPr id="3" name="Text 1"/>
+          <p:cNvSpPr txBox="1"/>
+          <p:nvPr/>
+        </p:nvSpPr>
+        <p:spPr>
+          <a:xfrm>
+            <a:off x="594360" y="384048"/>
+            <a:ext cx="10972800" cy="658368"/>
+          </a:xfrm>
+          <a:prstGeom prst="rect">
+            <a:avLst/>
+          </a:prstGeom>
+          <a:noFill/>
+          <a:ln/>
+        </p:spPr>
+        <p:txBody>
+          <a:bodyPr wrap="square" lIns="0" tIns="0" rIns="0" bIns="0" rtlCol="0" anchor="ctr"/>
+          <a:lstStyle/>
+          <a:p>
+            <a:pPr marL="0" indent="0">
+              <a:buNone/>
+            </a:pPr>
+            <a:r>
+              <a:rPr lang="en-US" sz="2700" b="1" dirty="0">
+                <a:solidFill>
+                  <a:srgbClr val="16232B"/>
+                </a:solidFill>
+                <a:latin typeface="Cambria" pitchFamily="34" charset="0"/>
+                <a:ea typeface="Cambria" pitchFamily="34" charset="-122"/>
+                <a:cs typeface="Cambria" pitchFamily="34" charset="-120"/>
+              </a:rPr>
+              <a:t>Le week-end ne gonfle pas les paniers, il les déplace</a:t>
+            </a:r>
+            <a:endParaRPr lang="en-US" sz="2700" dirty="0"/>
+          </a:p>
+        </p:txBody>
+      </p:sp>
+      <p:pic>
+        <p:nvPicPr>
+          <p:cNvPr id="4" name="Image 0" descr="02_projet\_ppt\fig06.png"/>
+          <p:cNvPicPr>
+            <a:picLocks noChangeAspect="1"/>
+          </p:cNvPicPr>
+          <p:nvPr/>
+        </p:nvPicPr>
+        <p:blipFill>
+          <a:blip r:embed="rId3"/>
+          <a:stretch>
+            <a:fillRect/>
+          </a:stretch>
+        </p:blipFill>
+        <p:spPr>
+          <a:xfrm>
+            <a:off x="594360" y="1481726"/>
+            <a:ext cx="6903720" cy="3565364"/>
+          </a:xfrm>
+          <a:prstGeom prst="rect">
+            <a:avLst/>
+          </a:prstGeom>
+        </p:spPr>
+      </p:pic>
+      <p:sp>
+        <p:nvSpPr>
+          <p:cNvPr id="5" name="Text 2"/>
+          <p:cNvSpPr txBox="1"/>
+          <p:nvPr/>
+        </p:nvSpPr>
+        <p:spPr>
+          <a:xfrm>
+            <a:off x="594360" y="5440680"/>
+            <a:ext cx="6903720" cy="457200"/>
+          </a:xfrm>
+          <a:prstGeom prst="rect">
+            <a:avLst/>
+          </a:prstGeom>
+          <a:noFill/>
+          <a:ln/>
+        </p:spPr>
+        <p:txBody>
+          <a:bodyPr wrap="square" lIns="0" tIns="0" rIns="0" bIns="0" rtlCol="0" anchor="t"/>
+          <a:lstStyle/>
+          <a:p>
+            <a:pPr marL="0" indent="0">
+              <a:buNone/>
+            </a:pPr>
+            <a:r>
+              <a:rPr lang="en-US" sz="1100" i="1" dirty="0">
+                <a:solidFill>
+                  <a:srgbClr val="5D6B75"/>
+                </a:solidFill>
+                <a:latin typeface="Calibri" pitchFamily="34" charset="0"/>
+                <a:ea typeface="Calibri" pitchFamily="34" charset="-122"/>
+                <a:cs typeface="Calibri" pitchFamily="34" charset="-120"/>
+              </a:rPr>
+              <a:t>Les petits paniers reculent de 7 points au profit des gros.</a:t>
+            </a:r>
+            <a:endParaRPr lang="en-US" sz="1100" dirty="0"/>
+          </a:p>
+        </p:txBody>
+      </p:sp>
+      <p:sp>
+        <p:nvSpPr>
+          <p:cNvPr id="6" name="Shape 3"/>
+          <p:cNvSpPr/>
+          <p:nvPr/>
+        </p:nvSpPr>
+        <p:spPr>
+          <a:xfrm>
+            <a:off x="7818120" y="1207008"/>
+            <a:ext cx="3749040" cy="3200400"/>
+          </a:xfrm>
+          <a:prstGeom prst="roundRect">
+            <a:avLst>
+              <a:gd name="adj" fmla="val 1714"/>
+            </a:avLst>
+          </a:prstGeom>
+          <a:solidFill>
+            <a:srgbClr val="EAF3F4"/>
+          </a:solidFill>
+          <a:ln w="12700">
+            <a:solidFill>
+              <a:srgbClr val="D3E5E7"/>
+            </a:solidFill>
+            <a:prstDash val="solid"/>
+          </a:ln>
+        </p:spPr>
+        <p:txBody>
+          <a:bodyPr/>
+          <a:lstStyle/>
+          <a:p>
+            <a:endParaRPr lang="fr-FR"/>
+          </a:p>
+        </p:txBody>
+      </p:sp>
+      <p:sp>
+        <p:nvSpPr>
+          <p:cNvPr id="7" name="Text 4"/>
+          <p:cNvSpPr txBox="1"/>
+          <p:nvPr/>
+        </p:nvSpPr>
+        <p:spPr>
+          <a:xfrm>
+            <a:off x="8074152" y="1389888"/>
+            <a:ext cx="3236976" cy="219456"/>
+          </a:xfrm>
+          <a:prstGeom prst="rect">
+            <a:avLst/>
+          </a:prstGeom>
+          <a:noFill/>
+          <a:ln/>
+        </p:spPr>
+        <p:txBody>
+          <a:bodyPr wrap="square" lIns="0" tIns="0" rIns="0" bIns="0" rtlCol="0" anchor="ctr"/>
+          <a:lstStyle/>
+          <a:p>
+            <a:pPr marL="0" indent="0">
+              <a:buNone/>
+            </a:pPr>
+            <a:r>
+              <a:rPr lang="en-US" sz="950" b="1" kern="0" spc="120" dirty="0">
+                <a:solidFill>
+                  <a:srgbClr val="0E7C86"/>
+                </a:solidFill>
+                <a:latin typeface="Calibri" pitchFamily="34" charset="0"/>
+                <a:ea typeface="Calibri" pitchFamily="34" charset="-122"/>
+                <a:cs typeface="Calibri" pitchFamily="34" charset="-120"/>
+              </a:rPr>
+              <a:t>CE QUE NOUS PROPOSONS</a:t>
+            </a:r>
+            <a:endParaRPr lang="en-US" sz="950" dirty="0"/>
+          </a:p>
+        </p:txBody>
+      </p:sp>
+      <p:sp>
+        <p:nvSpPr>
+          <p:cNvPr id="8" name="Text 5"/>
+          <p:cNvSpPr txBox="1"/>
+          <p:nvPr/>
+        </p:nvSpPr>
+        <p:spPr>
+          <a:xfrm>
+            <a:off x="8074152" y="1682496"/>
+            <a:ext cx="3236976" cy="2505456"/>
+          </a:xfrm>
+          <a:prstGeom prst="rect">
+            <a:avLst/>
+          </a:prstGeom>
+          <a:noFill/>
+          <a:ln/>
+        </p:spPr>
+        <p:txBody>
+          <a:bodyPr wrap="square" lIns="0" tIns="0" rIns="0" bIns="0" rtlCol="0" anchor="t"/>
+          <a:lstStyle/>
+          <a:p>
+            <a:pPr marL="0" indent="0">
+              <a:lnSpc>
+                <a:spcPct val="110000"/>
+              </a:lnSpc>
+              <a:buNone/>
+            </a:pPr>
+            <a:r>
+              <a:rPr lang="en-US" sz="1300" dirty="0">
+                <a:solidFill>
+                  <a:srgbClr val="16232B"/>
+                </a:solidFill>
+                <a:latin typeface="Calibri" pitchFamily="34" charset="0"/>
+                <a:ea typeface="Calibri" pitchFamily="34" charset="-122"/>
+                <a:cs typeface="Calibri" pitchFamily="34" charset="-120"/>
+              </a:rPr>
+              <a:t>Placer les offres à seuil — « livraison offerte dès X articles » — le week-end, où les gros paniers sont déjà la norme.</a:t>
+            </a:r>
+            <a:endParaRPr lang="en-US" sz="1300" dirty="0"/>
+          </a:p>
+        </p:txBody>
+      </p:sp>
+      <p:sp>
+        <p:nvSpPr>
+          <p:cNvPr id="9" name="Text 6"/>
+          <p:cNvSpPr txBox="1"/>
+          <p:nvPr/>
+        </p:nvSpPr>
+        <p:spPr>
+          <a:xfrm>
+            <a:off x="7818120" y="4663440"/>
+            <a:ext cx="548640" cy="548640"/>
+          </a:xfrm>
+          <a:prstGeom prst="rect">
+            <a:avLst/>
+          </a:prstGeom>
+          <a:noFill/>
+          <a:ln/>
+        </p:spPr>
+        <p:txBody>
+          <a:bodyPr wrap="square" lIns="0" tIns="0" rIns="0" bIns="0" rtlCol="0" anchor="ctr"/>
+          <a:lstStyle/>
+          <a:p>
+            <a:pPr marL="0" indent="0">
+              <a:buNone/>
+            </a:pPr>
+            <a:r>
+              <a:rPr lang="en-US" sz="3400" b="1" dirty="0">
+                <a:solidFill>
+                  <a:srgbClr val="D8E4E6"/>
+                </a:solidFill>
+                <a:latin typeface="Cambria" pitchFamily="34" charset="0"/>
+                <a:ea typeface="Cambria" pitchFamily="34" charset="-122"/>
+                <a:cs typeface="Cambria" pitchFamily="34" charset="-120"/>
+              </a:rPr>
+              <a:t>6</a:t>
+            </a:r>
+            <a:endParaRPr lang="en-US" sz="3400" dirty="0"/>
+          </a:p>
+        </p:txBody>
+      </p:sp>
+    </p:spTree>
+  </p:cSld>
+  <p:clrMapOvr>
+    <a:masterClrMapping/>
+  </p:clrMapOvr>
+</p:sld>
+</file>
+
+<file path=ppt/slides/slide11.xml><?xml version="1.0" encoding="utf-8"?>
+<p:sld xmlns:a="http://schemas.openxmlformats.org/drawingml/2006/main" xmlns:r="http://schemas.openxmlformats.org/officeDocument/2006/relationships" xmlns:p="http://schemas.openxmlformats.org/presentationml/2006/main">
   <p:cSld name="Slide 10">
     <p:bg>
       <p:bgPr>
@@ -2416,7 +2832,7 @@
 </p:sld>
 </file>
 
-<file path=ppt/slides/slide11.xml><?xml version="1.0" encoding="utf-8"?>
+<file path=ppt/slides/slide12.xml><?xml version="1.0" encoding="utf-8"?>
 <p:sld xmlns:a="http://schemas.openxmlformats.org/drawingml/2006/main" xmlns:r="http://schemas.openxmlformats.org/officeDocument/2006/relationships" xmlns:p="http://schemas.openxmlformats.org/presentationml/2006/main">
   <p:cSld name="Slide 11">
     <p:bg>
@@ -2744,7 +3160,7 @@
 </p:sld>
 </file>
 
-<file path=ppt/slides/slide12.xml><?xml version="1.0" encoding="utf-8"?>
+<file path=ppt/slides/slide13.xml><?xml version="1.0" encoding="utf-8"?>
 <p:sld xmlns:a="http://schemas.openxmlformats.org/drawingml/2006/main" xmlns:r="http://schemas.openxmlformats.org/officeDocument/2006/relationships" xmlns:p="http://schemas.openxmlformats.org/presentationml/2006/main">
   <p:cSld name="Slide 12">
     <p:bg>
@@ -3072,7 +3488,7 @@
 </p:sld>
 </file>
 
-<file path=ppt/slides/slide13.xml><?xml version="1.0" encoding="utf-8"?>
+<file path=ppt/slides/slide14.xml><?xml version="1.0" encoding="utf-8"?>
 <p:sld xmlns:a="http://schemas.openxmlformats.org/drawingml/2006/main" xmlns:r="http://schemas.openxmlformats.org/officeDocument/2006/relationships" xmlns:p="http://schemas.openxmlformats.org/presentationml/2006/main">
   <p:cSld name="Slide 13">
     <p:bg>
@@ -3400,7 +3816,7 @@
 </p:sld>
 </file>
 
-<file path=ppt/slides/slide14.xml><?xml version="1.0" encoding="utf-8"?>
+<file path=ppt/slides/slide15.xml><?xml version="1.0" encoding="utf-8"?>
 <p:sld xmlns:a="http://schemas.openxmlformats.org/drawingml/2006/main" xmlns:r="http://schemas.openxmlformats.org/officeDocument/2006/relationships" xmlns:p="http://schemas.openxmlformats.org/presentationml/2006/main">
   <p:cSld name="Slide 14">
     <p:bg>
@@ -4119,7 +4535,7 @@
 </p:sld>
 </file>
 
-<file path=ppt/slides/slide15.xml><?xml version="1.0" encoding="utf-8"?>
+<file path=ppt/slides/slide16.xml><?xml version="1.0" encoding="utf-8"?>
 <p:sld xmlns:a="http://schemas.openxmlformats.org/drawingml/2006/main" xmlns:r="http://schemas.openxmlformats.org/officeDocument/2006/relationships" xmlns:p="http://schemas.openxmlformats.org/presentationml/2006/main">
   <p:cSld name="Slide 18">
     <p:bg>
@@ -4908,6 +5324,767 @@
 </file>
 
 <file path=ppt/slides/slide3.xml><?xml version="1.0" encoding="utf-8"?>
+<p:sld xmlns:a="http://schemas.openxmlformats.org/drawingml/2006/main" xmlns:p="http://schemas.openxmlformats.org/presentationml/2006/main" xmlns:r="http://schemas.openxmlformats.org/officeDocument/2006/relationships">
+  <p:cSld>
+    <p:bg>
+      <p:bgPr>
+        <a:solidFill>
+          <a:srgbClr val="FFFFFF"/>
+        </a:solidFill>
+        <a:effectLst/>
+      </p:bgPr>
+    </p:bg>
+    <p:spTree>
+      <p:nvGrpSpPr>
+        <p:cNvPr id="1" name=""/>
+        <p:cNvGrpSpPr/>
+        <p:nvPr/>
+      </p:nvGrpSpPr>
+      <p:grpSpPr/>
+      <p:sp>
+        <p:nvSpPr>
+          <p:cNvPr id="2" name="Text 0"/>
+          <p:cNvSpPr txBox="1"/>
+          <p:nvPr/>
+        </p:nvSpPr>
+        <p:spPr>
+          <a:xfrm>
+            <a:off x="594360" y="182880"/>
+            <a:ext cx="10972800" cy="219456"/>
+          </a:xfrm>
+          <a:prstGeom prst="rect">
+            <a:avLst/>
+          </a:prstGeom>
+          <a:noFill/>
+        </p:spPr>
+        <p:txBody>
+          <a:bodyPr wrap="square" anchor="ctr" lIns="0" rIns="0" tIns="0" bIns="0">
+            <a:spAutoFit/>
+          </a:bodyPr>
+          <a:lstStyle/>
+          <a:p>
+            <a:r>
+              <a:rPr sz="1050" b="1" spc="160">
+                <a:solidFill>
+                  <a:srgbClr val="0E7C86"/>
+                </a:solidFill>
+                <a:latin typeface="Calibri"/>
+              </a:rPr>
+              <a:t>AVEC QUOI NOUS AVONS TRAVAILLÉ</a:t>
+            </a:r>
+          </a:p>
+        </p:txBody>
+      </p:sp>
+      <p:sp>
+        <p:nvSpPr>
+          <p:cNvPr id="3" name="Text 1"/>
+          <p:cNvSpPr txBox="1"/>
+          <p:nvPr/>
+        </p:nvSpPr>
+        <p:spPr>
+          <a:xfrm>
+            <a:off x="594360" y="384048"/>
+            <a:ext cx="10972800" cy="658368"/>
+          </a:xfrm>
+          <a:prstGeom prst="rect">
+            <a:avLst/>
+          </a:prstGeom>
+          <a:noFill/>
+        </p:spPr>
+        <p:txBody>
+          <a:bodyPr wrap="square" anchor="ctr" lIns="0" rIns="0" tIns="0" bIns="0">
+            <a:spAutoFit/>
+          </a:bodyPr>
+          <a:lstStyle/>
+          <a:p>
+            <a:r>
+              <a:rPr sz="2700" b="1">
+                <a:solidFill>
+                  <a:srgbClr val="16232B"/>
+                </a:solidFill>
+                <a:latin typeface="Cambria"/>
+              </a:rPr>
+              <a:t>Quatre bibliothèques, un choix assumé pour chacune</a:t>
+            </a:r>
+          </a:p>
+        </p:txBody>
+      </p:sp>
+      <p:sp>
+        <p:nvSpPr>
+          <p:cNvPr id="4" name="Shape 0"/>
+          <p:cNvSpPr/>
+          <p:nvPr/>
+        </p:nvSpPr>
+        <p:spPr>
+          <a:xfrm>
+            <a:off x="594360" y="1325880"/>
+            <a:ext cx="5358384" cy="1938528"/>
+          </a:xfrm>
+          <a:prstGeom prst="roundRect">
+            <a:avLst>
+              <a:gd name="adj" fmla="val 2800"/>
+            </a:avLst>
+          </a:prstGeom>
+          <a:solidFill>
+            <a:srgbClr val="FFFFFF"/>
+          </a:solidFill>
+          <a:ln w="12700">
+            <a:solidFill>
+              <a:srgbClr val="DFE6EA"/>
+            </a:solidFill>
+          </a:ln>
+          <a:effectLst/>
+        </p:spPr>
+        <p:style>
+          <a:lnRef idx="1">
+            <a:schemeClr val="accent1"/>
+          </a:lnRef>
+          <a:fillRef idx="3">
+            <a:schemeClr val="accent1"/>
+          </a:fillRef>
+          <a:effectRef idx="2">
+            <a:schemeClr val="accent1"/>
+          </a:effectRef>
+          <a:fontRef idx="minor">
+            <a:schemeClr val="lt1"/>
+          </a:fontRef>
+        </p:style>
+        <p:txBody>
+          <a:bodyPr rtlCol="0" anchor="ctr"/>
+          <a:lstStyle/>
+          <a:p>
+            <a:pPr algn="ctr"/>
+          </a:p>
+        </p:txBody>
+      </p:sp>
+      <p:sp>
+        <p:nvSpPr>
+          <p:cNvPr id="5" name="Text 2"/>
+          <p:cNvSpPr txBox="1"/>
+          <p:nvPr/>
+        </p:nvSpPr>
+        <p:spPr>
+          <a:xfrm>
+            <a:off x="868680" y="1508760"/>
+            <a:ext cx="4809744" cy="365760"/>
+          </a:xfrm>
+          <a:prstGeom prst="rect">
+            <a:avLst/>
+          </a:prstGeom>
+          <a:noFill/>
+        </p:spPr>
+        <p:txBody>
+          <a:bodyPr wrap="square" anchor="t" lIns="0" rIns="0" tIns="0" bIns="0">
+            <a:spAutoFit/>
+          </a:bodyPr>
+          <a:lstStyle/>
+          <a:p>
+            <a:r>
+              <a:rPr sz="1800" b="1">
+                <a:solidFill>
+                  <a:srgbClr val="0E7C86"/>
+                </a:solidFill>
+                <a:latin typeface="Cambria"/>
+              </a:rPr>
+              <a:t>pandas</a:t>
+            </a:r>
+            <a:r>
+              <a:rPr sz="1050" b="0">
+                <a:solidFill>
+                  <a:srgbClr val="5D6B75"/>
+                </a:solidFill>
+                <a:latin typeface="Calibri"/>
+              </a:rPr>
+              <a:t>   3.0</a:t>
+            </a:r>
+          </a:p>
+        </p:txBody>
+      </p:sp>
+      <p:sp>
+        <p:nvSpPr>
+          <p:cNvPr id="6" name="Text 3"/>
+          <p:cNvSpPr txBox="1"/>
+          <p:nvPr/>
+        </p:nvSpPr>
+        <p:spPr>
+          <a:xfrm>
+            <a:off x="868680" y="1965960"/>
+            <a:ext cx="4809744" cy="1069848"/>
+          </a:xfrm>
+          <a:prstGeom prst="rect">
+            <a:avLst/>
+          </a:prstGeom>
+          <a:noFill/>
+        </p:spPr>
+        <p:txBody>
+          <a:bodyPr wrap="square" anchor="t" lIns="0" rIns="0" tIns="0" bIns="0">
+            <a:spAutoFit/>
+          </a:bodyPr>
+          <a:lstStyle/>
+          <a:p>
+            <a:pPr>
+              <a:lnSpc>
+                <a:spcPct val="118000"/>
+              </a:lnSpc>
+            </a:pPr>
+            <a:r>
+              <a:rPr sz="1150" b="0">
+                <a:solidFill>
+                  <a:srgbClr val="5D6B75"/>
+                </a:solidFill>
+                <a:latin typeface="Calibri"/>
+              </a:rPr>
+              <a:t>Toute la manipulation. Le modèle </a:t>
+            </a:r>
+            <a:r>
+              <a:rPr sz="1150" b="1">
+                <a:solidFill>
+                  <a:srgbClr val="16232B"/>
+                </a:solidFill>
+                <a:latin typeface="Calibri"/>
+              </a:rPr>
+              <a:t>DataFrame</a:t>
+            </a:r>
+            <a:r>
+              <a:rPr sz="1150" b="0">
+                <a:solidFill>
+                  <a:srgbClr val="5D6B75"/>
+                </a:solidFill>
+                <a:latin typeface="Calibri"/>
+              </a:rPr>
+              <a:t> épouse le format tabulaire des CSV, et jointures comme regroupements y sont natifs, exécutés en C plutôt qu'en boucles Python. Polars irait plus vite ; pandas reste le standard qu'un relecteur sait lire.</a:t>
+            </a:r>
+          </a:p>
+        </p:txBody>
+      </p:sp>
+      <p:sp>
+        <p:nvSpPr>
+          <p:cNvPr id="7" name="Shape 1"/>
+          <p:cNvSpPr/>
+          <p:nvPr/>
+        </p:nvSpPr>
+        <p:spPr>
+          <a:xfrm>
+            <a:off x="6236208" y="1325880"/>
+            <a:ext cx="5358384" cy="1938528"/>
+          </a:xfrm>
+          <a:prstGeom prst="roundRect">
+            <a:avLst>
+              <a:gd name="adj" fmla="val 2800"/>
+            </a:avLst>
+          </a:prstGeom>
+          <a:solidFill>
+            <a:srgbClr val="FFFFFF"/>
+          </a:solidFill>
+          <a:ln w="12700">
+            <a:solidFill>
+              <a:srgbClr val="DFE6EA"/>
+            </a:solidFill>
+          </a:ln>
+          <a:effectLst/>
+        </p:spPr>
+        <p:style>
+          <a:lnRef idx="1">
+            <a:schemeClr val="accent1"/>
+          </a:lnRef>
+          <a:fillRef idx="3">
+            <a:schemeClr val="accent1"/>
+          </a:fillRef>
+          <a:effectRef idx="2">
+            <a:schemeClr val="accent1"/>
+          </a:effectRef>
+          <a:fontRef idx="minor">
+            <a:schemeClr val="lt1"/>
+          </a:fontRef>
+        </p:style>
+        <p:txBody>
+          <a:bodyPr rtlCol="0" anchor="ctr"/>
+          <a:lstStyle/>
+          <a:p>
+            <a:pPr algn="ctr"/>
+          </a:p>
+        </p:txBody>
+      </p:sp>
+      <p:sp>
+        <p:nvSpPr>
+          <p:cNvPr id="8" name="Text 4"/>
+          <p:cNvSpPr txBox="1"/>
+          <p:nvPr/>
+        </p:nvSpPr>
+        <p:spPr>
+          <a:xfrm>
+            <a:off x="6510528" y="1508760"/>
+            <a:ext cx="4809744" cy="365760"/>
+          </a:xfrm>
+          <a:prstGeom prst="rect">
+            <a:avLst/>
+          </a:prstGeom>
+          <a:noFill/>
+        </p:spPr>
+        <p:txBody>
+          <a:bodyPr wrap="square" anchor="t" lIns="0" rIns="0" tIns="0" bIns="0">
+            <a:spAutoFit/>
+          </a:bodyPr>
+          <a:lstStyle/>
+          <a:p>
+            <a:r>
+              <a:rPr sz="1800" b="1">
+                <a:solidFill>
+                  <a:srgbClr val="0E7C86"/>
+                </a:solidFill>
+                <a:latin typeface="Cambria"/>
+              </a:rPr>
+              <a:t>NumPy</a:t>
+            </a:r>
+            <a:r>
+              <a:rPr sz="1050" b="0">
+                <a:solidFill>
+                  <a:srgbClr val="5D6B75"/>
+                </a:solidFill>
+                <a:latin typeface="Calibri"/>
+              </a:rPr>
+              <a:t>   2.5</a:t>
+            </a:r>
+          </a:p>
+        </p:txBody>
+      </p:sp>
+      <p:sp>
+        <p:nvSpPr>
+          <p:cNvPr id="9" name="Text 5"/>
+          <p:cNvSpPr txBox="1"/>
+          <p:nvPr/>
+        </p:nvSpPr>
+        <p:spPr>
+          <a:xfrm>
+            <a:off x="6510528" y="1965960"/>
+            <a:ext cx="4809744" cy="1069848"/>
+          </a:xfrm>
+          <a:prstGeom prst="rect">
+            <a:avLst/>
+          </a:prstGeom>
+          <a:noFill/>
+        </p:spPr>
+        <p:txBody>
+          <a:bodyPr wrap="square" anchor="t" lIns="0" rIns="0" tIns="0" bIns="0">
+            <a:spAutoFit/>
+          </a:bodyPr>
+          <a:lstStyle/>
+          <a:p>
+            <a:pPr>
+              <a:lnSpc>
+                <a:spcPct val="118000"/>
+              </a:lnSpc>
+            </a:pPr>
+            <a:r>
+              <a:rPr sz="1150" b="0">
+                <a:solidFill>
+                  <a:srgbClr val="5D6B75"/>
+                </a:solidFill>
+                <a:latin typeface="Calibri"/>
+              </a:rPr>
+              <a:t>Les tableaux typés sur lesquels pandas repose lui-même. Nous nous en servons directement pour le calcul vectorisé — une opération sur 32 millions de valeurs d'un seul coup — et pour le tirage aléatoire à graine fixe qui rend l'exécution reproductible.</a:t>
+            </a:r>
+          </a:p>
+        </p:txBody>
+      </p:sp>
+      <p:sp>
+        <p:nvSpPr>
+          <p:cNvPr id="10" name="Shape 2"/>
+          <p:cNvSpPr/>
+          <p:nvPr/>
+        </p:nvSpPr>
+        <p:spPr>
+          <a:xfrm>
+            <a:off x="594360" y="3401568"/>
+            <a:ext cx="5358384" cy="1938528"/>
+          </a:xfrm>
+          <a:prstGeom prst="roundRect">
+            <a:avLst>
+              <a:gd name="adj" fmla="val 2800"/>
+            </a:avLst>
+          </a:prstGeom>
+          <a:solidFill>
+            <a:srgbClr val="FFFFFF"/>
+          </a:solidFill>
+          <a:ln w="12700">
+            <a:solidFill>
+              <a:srgbClr val="DFE6EA"/>
+            </a:solidFill>
+          </a:ln>
+          <a:effectLst/>
+        </p:spPr>
+        <p:style>
+          <a:lnRef idx="1">
+            <a:schemeClr val="accent1"/>
+          </a:lnRef>
+          <a:fillRef idx="3">
+            <a:schemeClr val="accent1"/>
+          </a:fillRef>
+          <a:effectRef idx="2">
+            <a:schemeClr val="accent1"/>
+          </a:effectRef>
+          <a:fontRef idx="minor">
+            <a:schemeClr val="lt1"/>
+          </a:fontRef>
+        </p:style>
+        <p:txBody>
+          <a:bodyPr rtlCol="0" anchor="ctr"/>
+          <a:lstStyle/>
+          <a:p>
+            <a:pPr algn="ctr"/>
+          </a:p>
+        </p:txBody>
+      </p:sp>
+      <p:sp>
+        <p:nvSpPr>
+          <p:cNvPr id="11" name="Text 6"/>
+          <p:cNvSpPr txBox="1"/>
+          <p:nvPr/>
+        </p:nvSpPr>
+        <p:spPr>
+          <a:xfrm>
+            <a:off x="868680" y="3584448"/>
+            <a:ext cx="4809744" cy="365760"/>
+          </a:xfrm>
+          <a:prstGeom prst="rect">
+            <a:avLst/>
+          </a:prstGeom>
+          <a:noFill/>
+        </p:spPr>
+        <p:txBody>
+          <a:bodyPr wrap="square" anchor="t" lIns="0" rIns="0" tIns="0" bIns="0">
+            <a:spAutoFit/>
+          </a:bodyPr>
+          <a:lstStyle/>
+          <a:p>
+            <a:r>
+              <a:rPr sz="1800" b="1">
+                <a:solidFill>
+                  <a:srgbClr val="0E7C86"/>
+                </a:solidFill>
+                <a:latin typeface="Cambria"/>
+              </a:rPr>
+              <a:t>Matplotlib</a:t>
+            </a:r>
+            <a:r>
+              <a:rPr sz="1050" b="0">
+                <a:solidFill>
+                  <a:srgbClr val="5D6B75"/>
+                </a:solidFill>
+                <a:latin typeface="Calibri"/>
+              </a:rPr>
+              <a:t>   3.11</a:t>
+            </a:r>
+          </a:p>
+        </p:txBody>
+      </p:sp>
+      <p:sp>
+        <p:nvSpPr>
+          <p:cNvPr id="12" name="Text 7"/>
+          <p:cNvSpPr txBox="1"/>
+          <p:nvPr/>
+        </p:nvSpPr>
+        <p:spPr>
+          <a:xfrm>
+            <a:off x="868680" y="4041648"/>
+            <a:ext cx="4809744" cy="1069848"/>
+          </a:xfrm>
+          <a:prstGeom prst="rect">
+            <a:avLst/>
+          </a:prstGeom>
+          <a:noFill/>
+        </p:spPr>
+        <p:txBody>
+          <a:bodyPr wrap="square" anchor="t" lIns="0" rIns="0" tIns="0" bIns="0">
+            <a:spAutoFit/>
+          </a:bodyPr>
+          <a:lstStyle/>
+          <a:p>
+            <a:pPr>
+              <a:lnSpc>
+                <a:spcPct val="118000"/>
+              </a:lnSpc>
+            </a:pPr>
+            <a:r>
+              <a:rPr sz="1150" b="0">
+                <a:solidFill>
+                  <a:srgbClr val="5D6B75"/>
+                </a:solidFill>
+                <a:latin typeface="Calibri"/>
+              </a:rPr>
+              <a:t>Les dix graphiques. Seaborn serait plus flatteur en moins de lignes, Plotly ajouterait l'interactivité ; Matplotlib donne le contrôle sur </a:t>
+            </a:r>
+            <a:r>
+              <a:rPr sz="1150" b="1">
+                <a:solidFill>
+                  <a:srgbClr val="16232B"/>
+                </a:solidFill>
+                <a:latin typeface="Calibri"/>
+              </a:rPr>
+              <a:t>chaque</a:t>
+            </a:r>
+            <a:r>
+              <a:rPr sz="1150" b="0">
+                <a:solidFill>
+                  <a:srgbClr val="5D6B75"/>
+                </a:solidFill>
+                <a:latin typeface="Calibri"/>
+              </a:rPr>
+              <a:t> élément — indispensable quand il faut justifier chaque choix visuel et retirer tout ornement inutile.</a:t>
+            </a:r>
+          </a:p>
+        </p:txBody>
+      </p:sp>
+      <p:sp>
+        <p:nvSpPr>
+          <p:cNvPr id="13" name="Shape 3"/>
+          <p:cNvSpPr/>
+          <p:nvPr/>
+        </p:nvSpPr>
+        <p:spPr>
+          <a:xfrm>
+            <a:off x="6236208" y="3401568"/>
+            <a:ext cx="5358384" cy="1938528"/>
+          </a:xfrm>
+          <a:prstGeom prst="roundRect">
+            <a:avLst>
+              <a:gd name="adj" fmla="val 2800"/>
+            </a:avLst>
+          </a:prstGeom>
+          <a:solidFill>
+            <a:srgbClr val="FFFFFF"/>
+          </a:solidFill>
+          <a:ln w="12700">
+            <a:solidFill>
+              <a:srgbClr val="DFE6EA"/>
+            </a:solidFill>
+          </a:ln>
+          <a:effectLst/>
+        </p:spPr>
+        <p:style>
+          <a:lnRef idx="1">
+            <a:schemeClr val="accent1"/>
+          </a:lnRef>
+          <a:fillRef idx="3">
+            <a:schemeClr val="accent1"/>
+          </a:fillRef>
+          <a:effectRef idx="2">
+            <a:schemeClr val="accent1"/>
+          </a:effectRef>
+          <a:fontRef idx="minor">
+            <a:schemeClr val="lt1"/>
+          </a:fontRef>
+        </p:style>
+        <p:txBody>
+          <a:bodyPr rtlCol="0" anchor="ctr"/>
+          <a:lstStyle/>
+          <a:p>
+            <a:pPr algn="ctr"/>
+          </a:p>
+        </p:txBody>
+      </p:sp>
+      <p:sp>
+        <p:nvSpPr>
+          <p:cNvPr id="14" name="Text 8"/>
+          <p:cNvSpPr txBox="1"/>
+          <p:nvPr/>
+        </p:nvSpPr>
+        <p:spPr>
+          <a:xfrm>
+            <a:off x="6510528" y="3584448"/>
+            <a:ext cx="4809744" cy="365760"/>
+          </a:xfrm>
+          <a:prstGeom prst="rect">
+            <a:avLst/>
+          </a:prstGeom>
+          <a:noFill/>
+        </p:spPr>
+        <p:txBody>
+          <a:bodyPr wrap="square" anchor="t" lIns="0" rIns="0" tIns="0" bIns="0">
+            <a:spAutoFit/>
+          </a:bodyPr>
+          <a:lstStyle/>
+          <a:p>
+            <a:r>
+              <a:rPr sz="1800" b="1">
+                <a:solidFill>
+                  <a:srgbClr val="0E7C86"/>
+                </a:solidFill>
+                <a:latin typeface="Cambria"/>
+              </a:rPr>
+              <a:t>scikit-learn</a:t>
+            </a:r>
+            <a:r>
+              <a:rPr sz="1050" b="0">
+                <a:solidFill>
+                  <a:srgbClr val="5D6B75"/>
+                </a:solidFill>
+                <a:latin typeface="Calibri"/>
+              </a:rPr>
+              <a:t>   1.9</a:t>
+            </a:r>
+          </a:p>
+        </p:txBody>
+      </p:sp>
+      <p:sp>
+        <p:nvSpPr>
+          <p:cNvPr id="15" name="Text 9"/>
+          <p:cNvSpPr txBox="1"/>
+          <p:nvPr/>
+        </p:nvSpPr>
+        <p:spPr>
+          <a:xfrm>
+            <a:off x="6510528" y="4041648"/>
+            <a:ext cx="4809744" cy="1069848"/>
+          </a:xfrm>
+          <a:prstGeom prst="rect">
+            <a:avLst/>
+          </a:prstGeom>
+          <a:noFill/>
+        </p:spPr>
+        <p:txBody>
+          <a:bodyPr wrap="square" anchor="t" lIns="0" rIns="0" tIns="0" bIns="0">
+            <a:spAutoFit/>
+          </a:bodyPr>
+          <a:lstStyle/>
+          <a:p>
+            <a:pPr>
+              <a:lnSpc>
+                <a:spcPct val="118000"/>
+              </a:lnSpc>
+            </a:pPr>
+            <a:r>
+              <a:rPr sz="1150" b="0">
+                <a:solidFill>
+                  <a:srgbClr val="5D6B75"/>
+                </a:solidFill>
+                <a:latin typeface="Calibri"/>
+              </a:rPr>
+              <a:t>Le modèle prédictif. Découpe, algorithmes, métriques et importance des variables partagent la même interface </a:t>
+            </a:r>
+            <a:r>
+              <a:rPr sz="1150" b="1">
+                <a:solidFill>
+                  <a:srgbClr val="16232B"/>
+                </a:solidFill>
+                <a:latin typeface="Calibri"/>
+              </a:rPr>
+              <a:t>fit / predict</a:t>
+            </a:r>
+            <a:r>
+              <a:rPr sz="1150" b="0">
+                <a:solidFill>
+                  <a:srgbClr val="5D6B75"/>
+                </a:solidFill>
+                <a:latin typeface="Calibri"/>
+              </a:rPr>
+              <a:t> : comparer quatre modèles ne demande alors que d'en changer le nom.</a:t>
+            </a:r>
+          </a:p>
+        </p:txBody>
+      </p:sp>
+      <p:sp>
+        <p:nvSpPr>
+          <p:cNvPr id="16" name="Text 10"/>
+          <p:cNvSpPr txBox="1"/>
+          <p:nvPr/>
+        </p:nvSpPr>
+        <p:spPr>
+          <a:xfrm>
+            <a:off x="594360" y="5623560"/>
+            <a:ext cx="10972800" cy="777240"/>
+          </a:xfrm>
+          <a:prstGeom prst="rect">
+            <a:avLst/>
+          </a:prstGeom>
+          <a:noFill/>
+        </p:spPr>
+        <p:txBody>
+          <a:bodyPr wrap="square" anchor="ctr" lIns="0" rIns="0" tIns="0" bIns="0">
+            <a:spAutoFit/>
+          </a:bodyPr>
+          <a:lstStyle/>
+          <a:p>
+            <a:pPr>
+              <a:lnSpc>
+                <a:spcPct val="120000"/>
+              </a:lnSpc>
+            </a:pPr>
+            <a:r>
+              <a:rPr sz="1350" b="0">
+                <a:solidFill>
+                  <a:srgbClr val="5D6B75"/>
+                </a:solidFill>
+                <a:latin typeface="Calibri"/>
+              </a:rPr>
+              <a:t>Versions figées dans </a:t>
+            </a:r>
+            <a:r>
+              <a:rPr sz="1300" b="0">
+                <a:solidFill>
+                  <a:srgbClr val="16232B"/>
+                </a:solidFill>
+                <a:latin typeface="Consolas"/>
+              </a:rPr>
+              <a:t>requirements.txt</a:t>
+            </a:r>
+            <a:r>
+              <a:rPr sz="1350" b="0">
+                <a:solidFill>
+                  <a:srgbClr val="5D6B75"/>
+                </a:solidFill>
+                <a:latin typeface="Calibri"/>
+              </a:rPr>
+              <a:t>. Les types compacts imposés à pandas — </a:t>
+            </a:r>
+            <a:r>
+              <a:rPr sz="1350" b="1">
+                <a:solidFill>
+                  <a:srgbClr val="16232B"/>
+                </a:solidFill>
+                <a:latin typeface="Calibri"/>
+              </a:rPr>
+              <a:t>int8</a:t>
+            </a:r>
+            <a:r>
+              <a:rPr sz="1350" b="0">
+                <a:solidFill>
+                  <a:srgbClr val="5D6B75"/>
+                </a:solidFill>
+                <a:latin typeface="Calibri"/>
+              </a:rPr>
+              <a:t>, </a:t>
+            </a:r>
+            <a:r>
+              <a:rPr sz="1350" b="1">
+                <a:solidFill>
+                  <a:srgbClr val="16232B"/>
+                </a:solidFill>
+                <a:latin typeface="Calibri"/>
+              </a:rPr>
+              <a:t>int16</a:t>
+            </a:r>
+            <a:r>
+              <a:rPr sz="1350" b="0">
+                <a:solidFill>
+                  <a:srgbClr val="5D6B75"/>
+                </a:solidFill>
+                <a:latin typeface="Calibri"/>
+              </a:rPr>
+              <a:t>, catégories — ramènent l'empreinte mémoire de 3,2 Go à 1,0 Go : c'est ce qui rend le projet exécutable sur une machine ordinaire, et non sur un serveur.</a:t>
+            </a:r>
+          </a:p>
+        </p:txBody>
+      </p:sp>
+    </p:spTree>
+  </p:cSld>
+  <p:clrMapOvr>
+    <a:masterClrMapping/>
+  </p:clrMapOvr>
+</p:sld>
+</file>
+
+<file path=ppt/slides/slide4.xml><?xml version="1.0" encoding="utf-8"?>
 <p:sld xmlns:a="http://schemas.openxmlformats.org/drawingml/2006/main" xmlns:r="http://schemas.openxmlformats.org/officeDocument/2006/relationships" xmlns:p="http://schemas.openxmlformats.org/presentationml/2006/main">
   <p:cSld name="Slide 3">
     <p:bg>
@@ -5150,7 +6327,7 @@
 </p:sld>
 </file>
 
-<file path=ppt/slides/slide4.xml><?xml version="1.0" encoding="utf-8"?>
+<file path=ppt/slides/slide5.xml><?xml version="1.0" encoding="utf-8"?>
 <p:sld xmlns:a="http://schemas.openxmlformats.org/drawingml/2006/main" xmlns:r="http://schemas.openxmlformats.org/officeDocument/2006/relationships" xmlns:p="http://schemas.openxmlformats.org/presentationml/2006/main">
   <p:cSld name="Slide 4">
     <p:bg>
@@ -5478,7 +6655,7 @@
 </p:sld>
 </file>
 
-<file path=ppt/slides/slide5.xml><?xml version="1.0" encoding="utf-8"?>
+<file path=ppt/slides/slide6.xml><?xml version="1.0" encoding="utf-8"?>
 <p:sld xmlns:a="http://schemas.openxmlformats.org/drawingml/2006/main" xmlns:r="http://schemas.openxmlformats.org/officeDocument/2006/relationships" xmlns:p="http://schemas.openxmlformats.org/presentationml/2006/main">
   <p:cSld name="Slide 5">
     <p:bg>
@@ -5806,7 +6983,7 @@
 </p:sld>
 </file>
 
-<file path=ppt/slides/slide6.xml><?xml version="1.0" encoding="utf-8"?>
+<file path=ppt/slides/slide7.xml><?xml version="1.0" encoding="utf-8"?>
 <p:sld xmlns:a="http://schemas.openxmlformats.org/drawingml/2006/main" xmlns:r="http://schemas.openxmlformats.org/officeDocument/2006/relationships" xmlns:p="http://schemas.openxmlformats.org/presentationml/2006/main">
   <p:cSld name="Slide 6">
     <p:bg>
@@ -6134,7 +7311,7 @@
 </p:sld>
 </file>
 
-<file path=ppt/slides/slide7.xml><?xml version="1.0" encoding="utf-8"?>
+<file path=ppt/slides/slide8.xml><?xml version="1.0" encoding="utf-8"?>
 <p:sld xmlns:a="http://schemas.openxmlformats.org/drawingml/2006/main" xmlns:r="http://schemas.openxmlformats.org/officeDocument/2006/relationships" xmlns:p="http://schemas.openxmlformats.org/presentationml/2006/main">
   <p:cSld name="Slide 7">
     <p:bg>
@@ -6462,7 +7639,7 @@
 </p:sld>
 </file>
 
-<file path=ppt/slides/slide8.xml><?xml version="1.0" encoding="utf-8"?>
+<file path=ppt/slides/slide9.xml><?xml version="1.0" encoding="utf-8"?>
 <p:sld xmlns:a="http://schemas.openxmlformats.org/drawingml/2006/main" xmlns:r="http://schemas.openxmlformats.org/officeDocument/2006/relationships" xmlns:p="http://schemas.openxmlformats.org/presentationml/2006/main">
   <p:cSld name="Slide 8">
     <p:bg>
@@ -6777,334 +7954,6 @@
                 <a:cs typeface="Cambria" pitchFamily="34" charset="-120"/>
               </a:rPr>
               <a:t>5</a:t>
-            </a:r>
-            <a:endParaRPr lang="en-US" sz="3400" dirty="0"/>
-          </a:p>
-        </p:txBody>
-      </p:sp>
-    </p:spTree>
-  </p:cSld>
-  <p:clrMapOvr>
-    <a:masterClrMapping/>
-  </p:clrMapOvr>
-</p:sld>
-</file>
-
-<file path=ppt/slides/slide9.xml><?xml version="1.0" encoding="utf-8"?>
-<p:sld xmlns:a="http://schemas.openxmlformats.org/drawingml/2006/main" xmlns:r="http://schemas.openxmlformats.org/officeDocument/2006/relationships" xmlns:p="http://schemas.openxmlformats.org/presentationml/2006/main">
-  <p:cSld name="Slide 9">
-    <p:bg>
-      <p:bgPr>
-        <a:solidFill>
-          <a:srgbClr val="FFFFFF"/>
-        </a:solidFill>
-        <a:effectLst/>
-      </p:bgPr>
-    </p:bg>
-    <p:spTree>
-      <p:nvGrpSpPr>
-        <p:cNvPr id="1" name=""/>
-        <p:cNvGrpSpPr/>
-        <p:nvPr/>
-      </p:nvGrpSpPr>
-      <p:grpSpPr>
-        <a:xfrm>
-          <a:off x="0" y="0"/>
-          <a:ext cx="0" cy="0"/>
-          <a:chOff x="0" y="0"/>
-          <a:chExt cx="0" cy="0"/>
-        </a:xfrm>
-      </p:grpSpPr>
-      <p:sp>
-        <p:nvSpPr>
-          <p:cNvPr id="2" name="Text 0"/>
-          <p:cNvSpPr txBox="1"/>
-          <p:nvPr/>
-        </p:nvSpPr>
-        <p:spPr>
-          <a:xfrm>
-            <a:off x="594360" y="182880"/>
-            <a:ext cx="10972800" cy="219456"/>
-          </a:xfrm>
-          <a:prstGeom prst="rect">
-            <a:avLst/>
-          </a:prstGeom>
-          <a:noFill/>
-          <a:ln/>
-        </p:spPr>
-        <p:txBody>
-          <a:bodyPr wrap="square" lIns="0" tIns="0" rIns="0" bIns="0" rtlCol="0" anchor="ctr"/>
-          <a:lstStyle/>
-          <a:p>
-            <a:pPr marL="0" indent="0">
-              <a:buNone/>
-            </a:pPr>
-            <a:r>
-              <a:rPr lang="en-US" sz="1050" b="1" kern="0" spc="160" dirty="0">
-                <a:solidFill>
-                  <a:srgbClr val="0E7C86"/>
-                </a:solidFill>
-                <a:latin typeface="Calibri" pitchFamily="34" charset="0"/>
-                <a:ea typeface="Calibri" pitchFamily="34" charset="-122"/>
-                <a:cs typeface="Calibri" pitchFamily="34" charset="-120"/>
-              </a:rPr>
-              <a:t>DÉMONSTRATION 6</a:t>
-            </a:r>
-            <a:endParaRPr lang="en-US" sz="1050" dirty="0"/>
-          </a:p>
-        </p:txBody>
-      </p:sp>
-      <p:sp>
-        <p:nvSpPr>
-          <p:cNvPr id="3" name="Text 1"/>
-          <p:cNvSpPr txBox="1"/>
-          <p:nvPr/>
-        </p:nvSpPr>
-        <p:spPr>
-          <a:xfrm>
-            <a:off x="594360" y="384048"/>
-            <a:ext cx="10972800" cy="658368"/>
-          </a:xfrm>
-          <a:prstGeom prst="rect">
-            <a:avLst/>
-          </a:prstGeom>
-          <a:noFill/>
-          <a:ln/>
-        </p:spPr>
-        <p:txBody>
-          <a:bodyPr wrap="square" lIns="0" tIns="0" rIns="0" bIns="0" rtlCol="0" anchor="ctr"/>
-          <a:lstStyle/>
-          <a:p>
-            <a:pPr marL="0" indent="0">
-              <a:buNone/>
-            </a:pPr>
-            <a:r>
-              <a:rPr lang="en-US" sz="2700" b="1" dirty="0">
-                <a:solidFill>
-                  <a:srgbClr val="16232B"/>
-                </a:solidFill>
-                <a:latin typeface="Cambria" pitchFamily="34" charset="0"/>
-                <a:ea typeface="Cambria" pitchFamily="34" charset="-122"/>
-                <a:cs typeface="Cambria" pitchFamily="34" charset="-120"/>
-              </a:rPr>
-              <a:t>Le week-end ne gonfle pas les paniers, il les déplace</a:t>
-            </a:r>
-            <a:endParaRPr lang="en-US" sz="2700" dirty="0"/>
-          </a:p>
-        </p:txBody>
-      </p:sp>
-      <p:pic>
-        <p:nvPicPr>
-          <p:cNvPr id="4" name="Image 0" descr="02_projet\_ppt\fig06.png"/>
-          <p:cNvPicPr>
-            <a:picLocks noChangeAspect="1"/>
-          </p:cNvPicPr>
-          <p:nvPr/>
-        </p:nvPicPr>
-        <p:blipFill>
-          <a:blip r:embed="rId3"/>
-          <a:stretch>
-            <a:fillRect/>
-          </a:stretch>
-        </p:blipFill>
-        <p:spPr>
-          <a:xfrm>
-            <a:off x="594360" y="1481726"/>
-            <a:ext cx="6903720" cy="3565364"/>
-          </a:xfrm>
-          <a:prstGeom prst="rect">
-            <a:avLst/>
-          </a:prstGeom>
-        </p:spPr>
-      </p:pic>
-      <p:sp>
-        <p:nvSpPr>
-          <p:cNvPr id="5" name="Text 2"/>
-          <p:cNvSpPr txBox="1"/>
-          <p:nvPr/>
-        </p:nvSpPr>
-        <p:spPr>
-          <a:xfrm>
-            <a:off x="594360" y="5440680"/>
-            <a:ext cx="6903720" cy="457200"/>
-          </a:xfrm>
-          <a:prstGeom prst="rect">
-            <a:avLst/>
-          </a:prstGeom>
-          <a:noFill/>
-          <a:ln/>
-        </p:spPr>
-        <p:txBody>
-          <a:bodyPr wrap="square" lIns="0" tIns="0" rIns="0" bIns="0" rtlCol="0" anchor="t"/>
-          <a:lstStyle/>
-          <a:p>
-            <a:pPr marL="0" indent="0">
-              <a:buNone/>
-            </a:pPr>
-            <a:r>
-              <a:rPr lang="en-US" sz="1100" i="1" dirty="0">
-                <a:solidFill>
-                  <a:srgbClr val="5D6B75"/>
-                </a:solidFill>
-                <a:latin typeface="Calibri" pitchFamily="34" charset="0"/>
-                <a:ea typeface="Calibri" pitchFamily="34" charset="-122"/>
-                <a:cs typeface="Calibri" pitchFamily="34" charset="-120"/>
-              </a:rPr>
-              <a:t>Les petits paniers reculent de 7 points au profit des gros.</a:t>
-            </a:r>
-            <a:endParaRPr lang="en-US" sz="1100" dirty="0"/>
-          </a:p>
-        </p:txBody>
-      </p:sp>
-      <p:sp>
-        <p:nvSpPr>
-          <p:cNvPr id="6" name="Shape 3"/>
-          <p:cNvSpPr/>
-          <p:nvPr/>
-        </p:nvSpPr>
-        <p:spPr>
-          <a:xfrm>
-            <a:off x="7818120" y="1207008"/>
-            <a:ext cx="3749040" cy="3200400"/>
-          </a:xfrm>
-          <a:prstGeom prst="roundRect">
-            <a:avLst>
-              <a:gd name="adj" fmla="val 1714"/>
-            </a:avLst>
-          </a:prstGeom>
-          <a:solidFill>
-            <a:srgbClr val="EAF3F4"/>
-          </a:solidFill>
-          <a:ln w="12700">
-            <a:solidFill>
-              <a:srgbClr val="D3E5E7"/>
-            </a:solidFill>
-            <a:prstDash val="solid"/>
-          </a:ln>
-        </p:spPr>
-        <p:txBody>
-          <a:bodyPr/>
-          <a:lstStyle/>
-          <a:p>
-            <a:endParaRPr lang="fr-FR"/>
-          </a:p>
-        </p:txBody>
-      </p:sp>
-      <p:sp>
-        <p:nvSpPr>
-          <p:cNvPr id="7" name="Text 4"/>
-          <p:cNvSpPr txBox="1"/>
-          <p:nvPr/>
-        </p:nvSpPr>
-        <p:spPr>
-          <a:xfrm>
-            <a:off x="8074152" y="1389888"/>
-            <a:ext cx="3236976" cy="219456"/>
-          </a:xfrm>
-          <a:prstGeom prst="rect">
-            <a:avLst/>
-          </a:prstGeom>
-          <a:noFill/>
-          <a:ln/>
-        </p:spPr>
-        <p:txBody>
-          <a:bodyPr wrap="square" lIns="0" tIns="0" rIns="0" bIns="0" rtlCol="0" anchor="ctr"/>
-          <a:lstStyle/>
-          <a:p>
-            <a:pPr marL="0" indent="0">
-              <a:buNone/>
-            </a:pPr>
-            <a:r>
-              <a:rPr lang="en-US" sz="950" b="1" kern="0" spc="120" dirty="0">
-                <a:solidFill>
-                  <a:srgbClr val="0E7C86"/>
-                </a:solidFill>
-                <a:latin typeface="Calibri" pitchFamily="34" charset="0"/>
-                <a:ea typeface="Calibri" pitchFamily="34" charset="-122"/>
-                <a:cs typeface="Calibri" pitchFamily="34" charset="-120"/>
-              </a:rPr>
-              <a:t>CE QUE NOUS PROPOSONS</a:t>
-            </a:r>
-            <a:endParaRPr lang="en-US" sz="950" dirty="0"/>
-          </a:p>
-        </p:txBody>
-      </p:sp>
-      <p:sp>
-        <p:nvSpPr>
-          <p:cNvPr id="8" name="Text 5"/>
-          <p:cNvSpPr txBox="1"/>
-          <p:nvPr/>
-        </p:nvSpPr>
-        <p:spPr>
-          <a:xfrm>
-            <a:off x="8074152" y="1682496"/>
-            <a:ext cx="3236976" cy="2505456"/>
-          </a:xfrm>
-          <a:prstGeom prst="rect">
-            <a:avLst/>
-          </a:prstGeom>
-          <a:noFill/>
-          <a:ln/>
-        </p:spPr>
-        <p:txBody>
-          <a:bodyPr wrap="square" lIns="0" tIns="0" rIns="0" bIns="0" rtlCol="0" anchor="t"/>
-          <a:lstStyle/>
-          <a:p>
-            <a:pPr marL="0" indent="0">
-              <a:lnSpc>
-                <a:spcPct val="110000"/>
-              </a:lnSpc>
-              <a:buNone/>
-            </a:pPr>
-            <a:r>
-              <a:rPr lang="en-US" sz="1300" dirty="0">
-                <a:solidFill>
-                  <a:srgbClr val="16232B"/>
-                </a:solidFill>
-                <a:latin typeface="Calibri" pitchFamily="34" charset="0"/>
-                <a:ea typeface="Calibri" pitchFamily="34" charset="-122"/>
-                <a:cs typeface="Calibri" pitchFamily="34" charset="-120"/>
-              </a:rPr>
-              <a:t>Placer les offres à seuil — « livraison offerte dès X articles » — le week-end, où les gros paniers sont déjà la norme.</a:t>
-            </a:r>
-            <a:endParaRPr lang="en-US" sz="1300" dirty="0"/>
-          </a:p>
-        </p:txBody>
-      </p:sp>
-      <p:sp>
-        <p:nvSpPr>
-          <p:cNvPr id="9" name="Text 6"/>
-          <p:cNvSpPr txBox="1"/>
-          <p:nvPr/>
-        </p:nvSpPr>
-        <p:spPr>
-          <a:xfrm>
-            <a:off x="7818120" y="4663440"/>
-            <a:ext cx="548640" cy="548640"/>
-          </a:xfrm>
-          <a:prstGeom prst="rect">
-            <a:avLst/>
-          </a:prstGeom>
-          <a:noFill/>
-          <a:ln/>
-        </p:spPr>
-        <p:txBody>
-          <a:bodyPr wrap="square" lIns="0" tIns="0" rIns="0" bIns="0" rtlCol="0" anchor="ctr"/>
-          <a:lstStyle/>
-          <a:p>
-            <a:pPr marL="0" indent="0">
-              <a:buNone/>
-            </a:pPr>
-            <a:r>
-              <a:rPr lang="en-US" sz="3400" b="1" dirty="0">
-                <a:solidFill>
-                  <a:srgbClr val="D8E4E6"/>
-                </a:solidFill>
-                <a:latin typeface="Cambria" pitchFamily="34" charset="0"/>
-                <a:ea typeface="Cambria" pitchFamily="34" charset="-122"/>
-                <a:cs typeface="Cambria" pitchFamily="34" charset="-120"/>
-              </a:rPr>
-              <a:t>6</a:t>
             </a:r>
             <a:endParaRPr lang="en-US" sz="3400" dirty="0"/>
           </a:p>

</xml_diff>

<commit_message>
refactor(soutenance): allege la diapositive des bibliotheques
Le texte de chaque carte passe d un paragraphe a une phrase : le role,
puis l alternative ecartee. Corps grossi a 12,5 pt, cartes aplaties et
calees sur le rythme de la diapositive voisine, meme remplissage vert
d eau pour rester lisible au videoprojecteur.

Co-Authored-By: Claude Opus 5 <noreply@anthropic.com>
</commit_message>
<xml_diff>
--- a/02_projet/soutenance.pptx
+++ b/02_projet/soutenance.pptx
@@ -929,7 +929,7 @@
             <a:r>
               <a:rPr lang="fr-FR"/>
               <a:t>AVEC QUOI — 40 secondes.
-Cette diapositive répond à une question que le jury posera de toute façon. Ne lisez pas les quatre cases : donnez la logique. « Chaque bibliothèque a été choisie contre une alternative, pas prise par défaut. »
+Ne lisez pas les quatre cases : donnez la logique. « Chaque bibliothèque a été choisie contre une alternative, pas prise par défaut. »
 LE POINT À FAIRE ENTENDRE : Matplotlib plutôt que Seaborn est un choix coûteux — davantage de lignes de code — mais c'est lui qui nous a permis de retirer chaque ornement inutile. Sans ce contrôle, la promesse d'un graphique lisible ne tenait pas.
 LE CHIFFRE À CITER : 3,2 Go ramenés à 1,0 Go en imposant les types. Par défaut pandas met tout entier en int64, huit octets par valeur ; un jour de semaine en occupe un seul. Sur 32 millions de lignes, cet écart décide de la faisabilité.
 SI ON DEMANDE POURQUOI PAS POLARS : plus rapide, mais moins répandu. Ce code est fait pour être relu et repris — nous avons préféré le standard à la performance.
@@ -2178,334 +2178,6 @@
 
 <file path=ppt/slides/slide10.xml><?xml version="1.0" encoding="utf-8"?>
 <p:sld xmlns:a="http://schemas.openxmlformats.org/drawingml/2006/main" xmlns:r="http://schemas.openxmlformats.org/officeDocument/2006/relationships" xmlns:p="http://schemas.openxmlformats.org/presentationml/2006/main">
-  <p:cSld name="Slide 9">
-    <p:bg>
-      <p:bgPr>
-        <a:solidFill>
-          <a:srgbClr val="FFFFFF"/>
-        </a:solidFill>
-        <a:effectLst/>
-      </p:bgPr>
-    </p:bg>
-    <p:spTree>
-      <p:nvGrpSpPr>
-        <p:cNvPr id="1" name=""/>
-        <p:cNvGrpSpPr/>
-        <p:nvPr/>
-      </p:nvGrpSpPr>
-      <p:grpSpPr>
-        <a:xfrm>
-          <a:off x="0" y="0"/>
-          <a:ext cx="0" cy="0"/>
-          <a:chOff x="0" y="0"/>
-          <a:chExt cx="0" cy="0"/>
-        </a:xfrm>
-      </p:grpSpPr>
-      <p:sp>
-        <p:nvSpPr>
-          <p:cNvPr id="2" name="Text 0"/>
-          <p:cNvSpPr txBox="1"/>
-          <p:nvPr/>
-        </p:nvSpPr>
-        <p:spPr>
-          <a:xfrm>
-            <a:off x="594360" y="182880"/>
-            <a:ext cx="10972800" cy="219456"/>
-          </a:xfrm>
-          <a:prstGeom prst="rect">
-            <a:avLst/>
-          </a:prstGeom>
-          <a:noFill/>
-          <a:ln/>
-        </p:spPr>
-        <p:txBody>
-          <a:bodyPr wrap="square" lIns="0" tIns="0" rIns="0" bIns="0" rtlCol="0" anchor="ctr"/>
-          <a:lstStyle/>
-          <a:p>
-            <a:pPr marL="0" indent="0">
-              <a:buNone/>
-            </a:pPr>
-            <a:r>
-              <a:rPr lang="en-US" sz="1050" b="1" kern="0" spc="160" dirty="0">
-                <a:solidFill>
-                  <a:srgbClr val="0E7C86"/>
-                </a:solidFill>
-                <a:latin typeface="Calibri" pitchFamily="34" charset="0"/>
-                <a:ea typeface="Calibri" pitchFamily="34" charset="-122"/>
-                <a:cs typeface="Calibri" pitchFamily="34" charset="-120"/>
-              </a:rPr>
-              <a:t>DÉMONSTRATION 6</a:t>
-            </a:r>
-            <a:endParaRPr lang="en-US" sz="1050" dirty="0"/>
-          </a:p>
-        </p:txBody>
-      </p:sp>
-      <p:sp>
-        <p:nvSpPr>
-          <p:cNvPr id="3" name="Text 1"/>
-          <p:cNvSpPr txBox="1"/>
-          <p:nvPr/>
-        </p:nvSpPr>
-        <p:spPr>
-          <a:xfrm>
-            <a:off x="594360" y="384048"/>
-            <a:ext cx="10972800" cy="658368"/>
-          </a:xfrm>
-          <a:prstGeom prst="rect">
-            <a:avLst/>
-          </a:prstGeom>
-          <a:noFill/>
-          <a:ln/>
-        </p:spPr>
-        <p:txBody>
-          <a:bodyPr wrap="square" lIns="0" tIns="0" rIns="0" bIns="0" rtlCol="0" anchor="ctr"/>
-          <a:lstStyle/>
-          <a:p>
-            <a:pPr marL="0" indent="0">
-              <a:buNone/>
-            </a:pPr>
-            <a:r>
-              <a:rPr lang="en-US" sz="2700" b="1" dirty="0">
-                <a:solidFill>
-                  <a:srgbClr val="16232B"/>
-                </a:solidFill>
-                <a:latin typeface="Cambria" pitchFamily="34" charset="0"/>
-                <a:ea typeface="Cambria" pitchFamily="34" charset="-122"/>
-                <a:cs typeface="Cambria" pitchFamily="34" charset="-120"/>
-              </a:rPr>
-              <a:t>Le week-end ne gonfle pas les paniers, il les déplace</a:t>
-            </a:r>
-            <a:endParaRPr lang="en-US" sz="2700" dirty="0"/>
-          </a:p>
-        </p:txBody>
-      </p:sp>
-      <p:pic>
-        <p:nvPicPr>
-          <p:cNvPr id="4" name="Image 0" descr="02_projet\_ppt\fig06.png"/>
-          <p:cNvPicPr>
-            <a:picLocks noChangeAspect="1"/>
-          </p:cNvPicPr>
-          <p:nvPr/>
-        </p:nvPicPr>
-        <p:blipFill>
-          <a:blip r:embed="rId3"/>
-          <a:stretch>
-            <a:fillRect/>
-          </a:stretch>
-        </p:blipFill>
-        <p:spPr>
-          <a:xfrm>
-            <a:off x="594360" y="1481726"/>
-            <a:ext cx="6903720" cy="3565364"/>
-          </a:xfrm>
-          <a:prstGeom prst="rect">
-            <a:avLst/>
-          </a:prstGeom>
-        </p:spPr>
-      </p:pic>
-      <p:sp>
-        <p:nvSpPr>
-          <p:cNvPr id="5" name="Text 2"/>
-          <p:cNvSpPr txBox="1"/>
-          <p:nvPr/>
-        </p:nvSpPr>
-        <p:spPr>
-          <a:xfrm>
-            <a:off x="594360" y="5440680"/>
-            <a:ext cx="6903720" cy="457200"/>
-          </a:xfrm>
-          <a:prstGeom prst="rect">
-            <a:avLst/>
-          </a:prstGeom>
-          <a:noFill/>
-          <a:ln/>
-        </p:spPr>
-        <p:txBody>
-          <a:bodyPr wrap="square" lIns="0" tIns="0" rIns="0" bIns="0" rtlCol="0" anchor="t"/>
-          <a:lstStyle/>
-          <a:p>
-            <a:pPr marL="0" indent="0">
-              <a:buNone/>
-            </a:pPr>
-            <a:r>
-              <a:rPr lang="en-US" sz="1100" i="1" dirty="0">
-                <a:solidFill>
-                  <a:srgbClr val="5D6B75"/>
-                </a:solidFill>
-                <a:latin typeface="Calibri" pitchFamily="34" charset="0"/>
-                <a:ea typeface="Calibri" pitchFamily="34" charset="-122"/>
-                <a:cs typeface="Calibri" pitchFamily="34" charset="-120"/>
-              </a:rPr>
-              <a:t>Les petits paniers reculent de 7 points au profit des gros.</a:t>
-            </a:r>
-            <a:endParaRPr lang="en-US" sz="1100" dirty="0"/>
-          </a:p>
-        </p:txBody>
-      </p:sp>
-      <p:sp>
-        <p:nvSpPr>
-          <p:cNvPr id="6" name="Shape 3"/>
-          <p:cNvSpPr/>
-          <p:nvPr/>
-        </p:nvSpPr>
-        <p:spPr>
-          <a:xfrm>
-            <a:off x="7818120" y="1207008"/>
-            <a:ext cx="3749040" cy="3200400"/>
-          </a:xfrm>
-          <a:prstGeom prst="roundRect">
-            <a:avLst>
-              <a:gd name="adj" fmla="val 1714"/>
-            </a:avLst>
-          </a:prstGeom>
-          <a:solidFill>
-            <a:srgbClr val="EAF3F4"/>
-          </a:solidFill>
-          <a:ln w="12700">
-            <a:solidFill>
-              <a:srgbClr val="D3E5E7"/>
-            </a:solidFill>
-            <a:prstDash val="solid"/>
-          </a:ln>
-        </p:spPr>
-        <p:txBody>
-          <a:bodyPr/>
-          <a:lstStyle/>
-          <a:p>
-            <a:endParaRPr lang="fr-FR"/>
-          </a:p>
-        </p:txBody>
-      </p:sp>
-      <p:sp>
-        <p:nvSpPr>
-          <p:cNvPr id="7" name="Text 4"/>
-          <p:cNvSpPr txBox="1"/>
-          <p:nvPr/>
-        </p:nvSpPr>
-        <p:spPr>
-          <a:xfrm>
-            <a:off x="8074152" y="1389888"/>
-            <a:ext cx="3236976" cy="219456"/>
-          </a:xfrm>
-          <a:prstGeom prst="rect">
-            <a:avLst/>
-          </a:prstGeom>
-          <a:noFill/>
-          <a:ln/>
-        </p:spPr>
-        <p:txBody>
-          <a:bodyPr wrap="square" lIns="0" tIns="0" rIns="0" bIns="0" rtlCol="0" anchor="ctr"/>
-          <a:lstStyle/>
-          <a:p>
-            <a:pPr marL="0" indent="0">
-              <a:buNone/>
-            </a:pPr>
-            <a:r>
-              <a:rPr lang="en-US" sz="950" b="1" kern="0" spc="120" dirty="0">
-                <a:solidFill>
-                  <a:srgbClr val="0E7C86"/>
-                </a:solidFill>
-                <a:latin typeface="Calibri" pitchFamily="34" charset="0"/>
-                <a:ea typeface="Calibri" pitchFamily="34" charset="-122"/>
-                <a:cs typeface="Calibri" pitchFamily="34" charset="-120"/>
-              </a:rPr>
-              <a:t>CE QUE NOUS PROPOSONS</a:t>
-            </a:r>
-            <a:endParaRPr lang="en-US" sz="950" dirty="0"/>
-          </a:p>
-        </p:txBody>
-      </p:sp>
-      <p:sp>
-        <p:nvSpPr>
-          <p:cNvPr id="8" name="Text 5"/>
-          <p:cNvSpPr txBox="1"/>
-          <p:nvPr/>
-        </p:nvSpPr>
-        <p:spPr>
-          <a:xfrm>
-            <a:off x="8074152" y="1682496"/>
-            <a:ext cx="3236976" cy="2505456"/>
-          </a:xfrm>
-          <a:prstGeom prst="rect">
-            <a:avLst/>
-          </a:prstGeom>
-          <a:noFill/>
-          <a:ln/>
-        </p:spPr>
-        <p:txBody>
-          <a:bodyPr wrap="square" lIns="0" tIns="0" rIns="0" bIns="0" rtlCol="0" anchor="t"/>
-          <a:lstStyle/>
-          <a:p>
-            <a:pPr marL="0" indent="0">
-              <a:lnSpc>
-                <a:spcPct val="110000"/>
-              </a:lnSpc>
-              <a:buNone/>
-            </a:pPr>
-            <a:r>
-              <a:rPr lang="en-US" sz="1300" dirty="0">
-                <a:solidFill>
-                  <a:srgbClr val="16232B"/>
-                </a:solidFill>
-                <a:latin typeface="Calibri" pitchFamily="34" charset="0"/>
-                <a:ea typeface="Calibri" pitchFamily="34" charset="-122"/>
-                <a:cs typeface="Calibri" pitchFamily="34" charset="-120"/>
-              </a:rPr>
-              <a:t>Placer les offres à seuil — « livraison offerte dès X articles » — le week-end, où les gros paniers sont déjà la norme.</a:t>
-            </a:r>
-            <a:endParaRPr lang="en-US" sz="1300" dirty="0"/>
-          </a:p>
-        </p:txBody>
-      </p:sp>
-      <p:sp>
-        <p:nvSpPr>
-          <p:cNvPr id="9" name="Text 6"/>
-          <p:cNvSpPr txBox="1"/>
-          <p:nvPr/>
-        </p:nvSpPr>
-        <p:spPr>
-          <a:xfrm>
-            <a:off x="7818120" y="4663440"/>
-            <a:ext cx="548640" cy="548640"/>
-          </a:xfrm>
-          <a:prstGeom prst="rect">
-            <a:avLst/>
-          </a:prstGeom>
-          <a:noFill/>
-          <a:ln/>
-        </p:spPr>
-        <p:txBody>
-          <a:bodyPr wrap="square" lIns="0" tIns="0" rIns="0" bIns="0" rtlCol="0" anchor="ctr"/>
-          <a:lstStyle/>
-          <a:p>
-            <a:pPr marL="0" indent="0">
-              <a:buNone/>
-            </a:pPr>
-            <a:r>
-              <a:rPr lang="en-US" sz="3400" b="1" dirty="0">
-                <a:solidFill>
-                  <a:srgbClr val="D8E4E6"/>
-                </a:solidFill>
-                <a:latin typeface="Cambria" pitchFamily="34" charset="0"/>
-                <a:ea typeface="Cambria" pitchFamily="34" charset="-122"/>
-                <a:cs typeface="Cambria" pitchFamily="34" charset="-120"/>
-              </a:rPr>
-              <a:t>6</a:t>
-            </a:r>
-            <a:endParaRPr lang="en-US" sz="3400" dirty="0"/>
-          </a:p>
-        </p:txBody>
-      </p:sp>
-    </p:spTree>
-  </p:cSld>
-  <p:clrMapOvr>
-    <a:masterClrMapping/>
-  </p:clrMapOvr>
-</p:sld>
-</file>
-
-<file path=ppt/slides/slide11.xml><?xml version="1.0" encoding="utf-8"?>
-<p:sld xmlns:a="http://schemas.openxmlformats.org/drawingml/2006/main" xmlns:r="http://schemas.openxmlformats.org/officeDocument/2006/relationships" xmlns:p="http://schemas.openxmlformats.org/presentationml/2006/main">
   <p:cSld name="Slide 10">
     <p:bg>
       <p:bgPr>
@@ -2832,7 +2504,7 @@
 </p:sld>
 </file>
 
-<file path=ppt/slides/slide12.xml><?xml version="1.0" encoding="utf-8"?>
+<file path=ppt/slides/slide11.xml><?xml version="1.0" encoding="utf-8"?>
 <p:sld xmlns:a="http://schemas.openxmlformats.org/drawingml/2006/main" xmlns:r="http://schemas.openxmlformats.org/officeDocument/2006/relationships" xmlns:p="http://schemas.openxmlformats.org/presentationml/2006/main">
   <p:cSld name="Slide 11">
     <p:bg>
@@ -3160,7 +2832,7 @@
 </p:sld>
 </file>
 
-<file path=ppt/slides/slide13.xml><?xml version="1.0" encoding="utf-8"?>
+<file path=ppt/slides/slide12.xml><?xml version="1.0" encoding="utf-8"?>
 <p:sld xmlns:a="http://schemas.openxmlformats.org/drawingml/2006/main" xmlns:r="http://schemas.openxmlformats.org/officeDocument/2006/relationships" xmlns:p="http://schemas.openxmlformats.org/presentationml/2006/main">
   <p:cSld name="Slide 12">
     <p:bg>
@@ -3488,7 +3160,7 @@
 </p:sld>
 </file>
 
-<file path=ppt/slides/slide14.xml><?xml version="1.0" encoding="utf-8"?>
+<file path=ppt/slides/slide13.xml><?xml version="1.0" encoding="utf-8"?>
 <p:sld xmlns:a="http://schemas.openxmlformats.org/drawingml/2006/main" xmlns:r="http://schemas.openxmlformats.org/officeDocument/2006/relationships" xmlns:p="http://schemas.openxmlformats.org/presentationml/2006/main">
   <p:cSld name="Slide 13">
     <p:bg>
@@ -3816,7 +3488,7 @@
 </p:sld>
 </file>
 
-<file path=ppt/slides/slide15.xml><?xml version="1.0" encoding="utf-8"?>
+<file path=ppt/slides/slide14.xml><?xml version="1.0" encoding="utf-8"?>
 <p:sld xmlns:a="http://schemas.openxmlformats.org/drawingml/2006/main" xmlns:r="http://schemas.openxmlformats.org/officeDocument/2006/relationships" xmlns:p="http://schemas.openxmlformats.org/presentationml/2006/main">
   <p:cSld name="Slide 14">
     <p:bg>
@@ -4535,7 +4207,7 @@
 </p:sld>
 </file>
 
-<file path=ppt/slides/slide16.xml><?xml version="1.0" encoding="utf-8"?>
+<file path=ppt/slides/slide15.xml><?xml version="1.0" encoding="utf-8"?>
 <p:sld xmlns:a="http://schemas.openxmlformats.org/drawingml/2006/main" xmlns:r="http://schemas.openxmlformats.org/officeDocument/2006/relationships" xmlns:p="http://schemas.openxmlformats.org/presentationml/2006/main">
   <p:cSld name="Slide 18">
     <p:bg>
@@ -4711,6 +4383,695 @@
               <a:t>.</a:t>
             </a:r>
             <a:endParaRPr lang="en-US" sz="1600" dirty="0"/>
+          </a:p>
+        </p:txBody>
+      </p:sp>
+    </p:spTree>
+  </p:cSld>
+  <p:clrMapOvr>
+    <a:masterClrMapping/>
+  </p:clrMapOvr>
+</p:sld>
+</file>
+
+<file path=ppt/slides/slide16.xml><?xml version="1.0" encoding="utf-8"?>
+<p:sld xmlns:a="http://schemas.openxmlformats.org/drawingml/2006/main" xmlns:p="http://schemas.openxmlformats.org/presentationml/2006/main" xmlns:r="http://schemas.openxmlformats.org/officeDocument/2006/relationships">
+  <p:cSld>
+    <p:bg>
+      <p:bgPr>
+        <a:solidFill>
+          <a:srgbClr val="FFFFFF"/>
+        </a:solidFill>
+        <a:effectLst/>
+      </p:bgPr>
+    </p:bg>
+    <p:spTree>
+      <p:nvGrpSpPr>
+        <p:cNvPr id="1" name=""/>
+        <p:cNvGrpSpPr/>
+        <p:nvPr/>
+      </p:nvGrpSpPr>
+      <p:grpSpPr/>
+      <p:sp>
+        <p:nvSpPr>
+          <p:cNvPr id="2" name="Text 0"/>
+          <p:cNvSpPr txBox="1"/>
+          <p:nvPr/>
+        </p:nvSpPr>
+        <p:spPr>
+          <a:xfrm>
+            <a:off x="594360" y="182880"/>
+            <a:ext cx="10972800" cy="219456"/>
+          </a:xfrm>
+          <a:prstGeom prst="rect">
+            <a:avLst/>
+          </a:prstGeom>
+          <a:noFill/>
+        </p:spPr>
+        <p:txBody>
+          <a:bodyPr wrap="square" anchor="ctr" lIns="0" rIns="0" tIns="0" bIns="0">
+            <a:spAutoFit/>
+          </a:bodyPr>
+          <a:lstStyle/>
+          <a:p>
+            <a:r>
+              <a:rPr sz="1050" b="1" spc="160">
+                <a:solidFill>
+                  <a:srgbClr val="0E7C86"/>
+                </a:solidFill>
+                <a:latin typeface="Calibri"/>
+              </a:rPr>
+              <a:t>AVEC QUOI NOUS AVONS TRAVAILLÉ</a:t>
+            </a:r>
+          </a:p>
+        </p:txBody>
+      </p:sp>
+      <p:sp>
+        <p:nvSpPr>
+          <p:cNvPr id="3" name="Text 1"/>
+          <p:cNvSpPr txBox="1"/>
+          <p:nvPr/>
+        </p:nvSpPr>
+        <p:spPr>
+          <a:xfrm>
+            <a:off x="594360" y="384048"/>
+            <a:ext cx="10972800" cy="658368"/>
+          </a:xfrm>
+          <a:prstGeom prst="rect">
+            <a:avLst/>
+          </a:prstGeom>
+          <a:noFill/>
+        </p:spPr>
+        <p:txBody>
+          <a:bodyPr wrap="square" anchor="ctr" lIns="0" rIns="0" tIns="0" bIns="0">
+            <a:spAutoFit/>
+          </a:bodyPr>
+          <a:lstStyle/>
+          <a:p>
+            <a:r>
+              <a:rPr sz="2700" b="1">
+                <a:solidFill>
+                  <a:srgbClr val="16232B"/>
+                </a:solidFill>
+                <a:latin typeface="Cambria"/>
+              </a:rPr>
+              <a:t>Quatre bibliothèques, un choix assumé pour chacune</a:t>
+            </a:r>
+          </a:p>
+        </p:txBody>
+      </p:sp>
+      <p:sp>
+        <p:nvSpPr>
+          <p:cNvPr id="4" name="Shape 0"/>
+          <p:cNvSpPr/>
+          <p:nvPr/>
+        </p:nvSpPr>
+        <p:spPr>
+          <a:xfrm>
+            <a:off x="594360" y="1554480"/>
+            <a:ext cx="5358384" cy="1325880"/>
+          </a:xfrm>
+          <a:prstGeom prst="roundRect">
+            <a:avLst>
+              <a:gd name="adj" fmla="val 3077"/>
+            </a:avLst>
+          </a:prstGeom>
+          <a:solidFill>
+            <a:srgbClr val="EAF3F4"/>
+          </a:solidFill>
+          <a:ln w="12700">
+            <a:solidFill>
+              <a:srgbClr val="D3E5E7"/>
+            </a:solidFill>
+          </a:ln>
+          <a:effectLst/>
+        </p:spPr>
+        <p:style>
+          <a:lnRef idx="1">
+            <a:schemeClr val="accent1"/>
+          </a:lnRef>
+          <a:fillRef idx="3">
+            <a:schemeClr val="accent1"/>
+          </a:fillRef>
+          <a:effectRef idx="2">
+            <a:schemeClr val="accent1"/>
+          </a:effectRef>
+          <a:fontRef idx="minor">
+            <a:schemeClr val="lt1"/>
+          </a:fontRef>
+        </p:style>
+        <p:txBody>
+          <a:bodyPr rtlCol="0" anchor="ctr"/>
+          <a:lstStyle/>
+          <a:p>
+            <a:pPr algn="ctr"/>
+          </a:p>
+        </p:txBody>
+      </p:sp>
+      <p:sp>
+        <p:nvSpPr>
+          <p:cNvPr id="5" name="Text 2"/>
+          <p:cNvSpPr txBox="1"/>
+          <p:nvPr/>
+        </p:nvSpPr>
+        <p:spPr>
+          <a:xfrm>
+            <a:off x="868680" y="1737360"/>
+            <a:ext cx="4809744" cy="365760"/>
+          </a:xfrm>
+          <a:prstGeom prst="rect">
+            <a:avLst/>
+          </a:prstGeom>
+          <a:noFill/>
+        </p:spPr>
+        <p:txBody>
+          <a:bodyPr wrap="square" anchor="t" lIns="0" rIns="0" tIns="0" bIns="0">
+            <a:spAutoFit/>
+          </a:bodyPr>
+          <a:lstStyle/>
+          <a:p>
+            <a:r>
+              <a:rPr sz="1800" b="1">
+                <a:solidFill>
+                  <a:srgbClr val="0E7C86"/>
+                </a:solidFill>
+                <a:latin typeface="Cambria"/>
+              </a:rPr>
+              <a:t>pandas</a:t>
+            </a:r>
+            <a:r>
+              <a:rPr sz="1050" b="0">
+                <a:solidFill>
+                  <a:srgbClr val="5D6B75"/>
+                </a:solidFill>
+                <a:latin typeface="Calibri"/>
+              </a:rPr>
+              <a:t>   3.0</a:t>
+            </a:r>
+          </a:p>
+        </p:txBody>
+      </p:sp>
+      <p:sp>
+        <p:nvSpPr>
+          <p:cNvPr id="6" name="Text 3"/>
+          <p:cNvSpPr txBox="1"/>
+          <p:nvPr/>
+        </p:nvSpPr>
+        <p:spPr>
+          <a:xfrm>
+            <a:off x="868680" y="2231136"/>
+            <a:ext cx="4809744" cy="411479"/>
+          </a:xfrm>
+          <a:prstGeom prst="rect">
+            <a:avLst/>
+          </a:prstGeom>
+          <a:noFill/>
+        </p:spPr>
+        <p:txBody>
+          <a:bodyPr wrap="square" anchor="t" lIns="0" rIns="0" tIns="0" bIns="0">
+            <a:spAutoFit/>
+          </a:bodyPr>
+          <a:lstStyle/>
+          <a:p>
+            <a:pPr>
+              <a:lnSpc>
+                <a:spcPct val="118000"/>
+              </a:lnSpc>
+            </a:pPr>
+            <a:r>
+              <a:rPr sz="1250" b="0">
+                <a:solidFill>
+                  <a:srgbClr val="5D6B75"/>
+                </a:solidFill>
+                <a:latin typeface="Calibri"/>
+              </a:rPr>
+              <a:t>Manipuler 32 millions de lignes. Jointures et regroupements natifs, exécutés en C. Polars irait plus vite ; pandas est le standard.</a:t>
+            </a:r>
+          </a:p>
+        </p:txBody>
+      </p:sp>
+      <p:sp>
+        <p:nvSpPr>
+          <p:cNvPr id="7" name="Shape 1"/>
+          <p:cNvSpPr/>
+          <p:nvPr/>
+        </p:nvSpPr>
+        <p:spPr>
+          <a:xfrm>
+            <a:off x="6236208" y="1554480"/>
+            <a:ext cx="5358384" cy="1325880"/>
+          </a:xfrm>
+          <a:prstGeom prst="roundRect">
+            <a:avLst>
+              <a:gd name="adj" fmla="val 3077"/>
+            </a:avLst>
+          </a:prstGeom>
+          <a:solidFill>
+            <a:srgbClr val="EAF3F4"/>
+          </a:solidFill>
+          <a:ln w="12700">
+            <a:solidFill>
+              <a:srgbClr val="D3E5E7"/>
+            </a:solidFill>
+          </a:ln>
+          <a:effectLst/>
+        </p:spPr>
+        <p:style>
+          <a:lnRef idx="1">
+            <a:schemeClr val="accent1"/>
+          </a:lnRef>
+          <a:fillRef idx="3">
+            <a:schemeClr val="accent1"/>
+          </a:fillRef>
+          <a:effectRef idx="2">
+            <a:schemeClr val="accent1"/>
+          </a:effectRef>
+          <a:fontRef idx="minor">
+            <a:schemeClr val="lt1"/>
+          </a:fontRef>
+        </p:style>
+        <p:txBody>
+          <a:bodyPr rtlCol="0" anchor="ctr"/>
+          <a:lstStyle/>
+          <a:p>
+            <a:pPr algn="ctr"/>
+          </a:p>
+        </p:txBody>
+      </p:sp>
+      <p:sp>
+        <p:nvSpPr>
+          <p:cNvPr id="8" name="Text 4"/>
+          <p:cNvSpPr txBox="1"/>
+          <p:nvPr/>
+        </p:nvSpPr>
+        <p:spPr>
+          <a:xfrm>
+            <a:off x="6510528" y="1737360"/>
+            <a:ext cx="4809744" cy="365760"/>
+          </a:xfrm>
+          <a:prstGeom prst="rect">
+            <a:avLst/>
+          </a:prstGeom>
+          <a:noFill/>
+        </p:spPr>
+        <p:txBody>
+          <a:bodyPr wrap="square" anchor="t" lIns="0" rIns="0" tIns="0" bIns="0">
+            <a:spAutoFit/>
+          </a:bodyPr>
+          <a:lstStyle/>
+          <a:p>
+            <a:r>
+              <a:rPr sz="1800" b="1">
+                <a:solidFill>
+                  <a:srgbClr val="0E7C86"/>
+                </a:solidFill>
+                <a:latin typeface="Cambria"/>
+              </a:rPr>
+              <a:t>NumPy</a:t>
+            </a:r>
+            <a:r>
+              <a:rPr sz="1050" b="0">
+                <a:solidFill>
+                  <a:srgbClr val="5D6B75"/>
+                </a:solidFill>
+                <a:latin typeface="Calibri"/>
+              </a:rPr>
+              <a:t>   2.5</a:t>
+            </a:r>
+          </a:p>
+        </p:txBody>
+      </p:sp>
+      <p:sp>
+        <p:nvSpPr>
+          <p:cNvPr id="9" name="Text 5"/>
+          <p:cNvSpPr txBox="1"/>
+          <p:nvPr/>
+        </p:nvSpPr>
+        <p:spPr>
+          <a:xfrm>
+            <a:off x="6510528" y="2231136"/>
+            <a:ext cx="4809744" cy="411479"/>
+          </a:xfrm>
+          <a:prstGeom prst="rect">
+            <a:avLst/>
+          </a:prstGeom>
+          <a:noFill/>
+        </p:spPr>
+        <p:txBody>
+          <a:bodyPr wrap="square" anchor="t" lIns="0" rIns="0" tIns="0" bIns="0">
+            <a:spAutoFit/>
+          </a:bodyPr>
+          <a:lstStyle/>
+          <a:p>
+            <a:pPr>
+              <a:lnSpc>
+                <a:spcPct val="118000"/>
+              </a:lnSpc>
+            </a:pPr>
+            <a:r>
+              <a:rPr sz="1250" b="0">
+                <a:solidFill>
+                  <a:srgbClr val="5D6B75"/>
+                </a:solidFill>
+                <a:latin typeface="Calibri"/>
+              </a:rPr>
+              <a:t>Le calcul vectorisé sur lequel pandas repose. Et la graine aléatoire qui rend l'exécution reproductible.</a:t>
+            </a:r>
+          </a:p>
+        </p:txBody>
+      </p:sp>
+      <p:sp>
+        <p:nvSpPr>
+          <p:cNvPr id="10" name="Shape 2"/>
+          <p:cNvSpPr/>
+          <p:nvPr/>
+        </p:nvSpPr>
+        <p:spPr>
+          <a:xfrm>
+            <a:off x="594360" y="3035808"/>
+            <a:ext cx="5358384" cy="1325880"/>
+          </a:xfrm>
+          <a:prstGeom prst="roundRect">
+            <a:avLst>
+              <a:gd name="adj" fmla="val 3077"/>
+            </a:avLst>
+          </a:prstGeom>
+          <a:solidFill>
+            <a:srgbClr val="EAF3F4"/>
+          </a:solidFill>
+          <a:ln w="12700">
+            <a:solidFill>
+              <a:srgbClr val="D3E5E7"/>
+            </a:solidFill>
+          </a:ln>
+          <a:effectLst/>
+        </p:spPr>
+        <p:style>
+          <a:lnRef idx="1">
+            <a:schemeClr val="accent1"/>
+          </a:lnRef>
+          <a:fillRef idx="3">
+            <a:schemeClr val="accent1"/>
+          </a:fillRef>
+          <a:effectRef idx="2">
+            <a:schemeClr val="accent1"/>
+          </a:effectRef>
+          <a:fontRef idx="minor">
+            <a:schemeClr val="lt1"/>
+          </a:fontRef>
+        </p:style>
+        <p:txBody>
+          <a:bodyPr rtlCol="0" anchor="ctr"/>
+          <a:lstStyle/>
+          <a:p>
+            <a:pPr algn="ctr"/>
+          </a:p>
+        </p:txBody>
+      </p:sp>
+      <p:sp>
+        <p:nvSpPr>
+          <p:cNvPr id="11" name="Text 6"/>
+          <p:cNvSpPr txBox="1"/>
+          <p:nvPr/>
+        </p:nvSpPr>
+        <p:spPr>
+          <a:xfrm>
+            <a:off x="868680" y="3218688"/>
+            <a:ext cx="4809744" cy="365760"/>
+          </a:xfrm>
+          <a:prstGeom prst="rect">
+            <a:avLst/>
+          </a:prstGeom>
+          <a:noFill/>
+        </p:spPr>
+        <p:txBody>
+          <a:bodyPr wrap="square" anchor="t" lIns="0" rIns="0" tIns="0" bIns="0">
+            <a:spAutoFit/>
+          </a:bodyPr>
+          <a:lstStyle/>
+          <a:p>
+            <a:r>
+              <a:rPr sz="1800" b="1">
+                <a:solidFill>
+                  <a:srgbClr val="0E7C86"/>
+                </a:solidFill>
+                <a:latin typeface="Cambria"/>
+              </a:rPr>
+              <a:t>Matplotlib</a:t>
+            </a:r>
+            <a:r>
+              <a:rPr sz="1050" b="0">
+                <a:solidFill>
+                  <a:srgbClr val="5D6B75"/>
+                </a:solidFill>
+                <a:latin typeface="Calibri"/>
+              </a:rPr>
+              <a:t>   3.11</a:t>
+            </a:r>
+          </a:p>
+        </p:txBody>
+      </p:sp>
+      <p:sp>
+        <p:nvSpPr>
+          <p:cNvPr id="12" name="Text 7"/>
+          <p:cNvSpPr txBox="1"/>
+          <p:nvPr/>
+        </p:nvSpPr>
+        <p:spPr>
+          <a:xfrm>
+            <a:off x="868680" y="3712463"/>
+            <a:ext cx="4809744" cy="411479"/>
+          </a:xfrm>
+          <a:prstGeom prst="rect">
+            <a:avLst/>
+          </a:prstGeom>
+          <a:noFill/>
+        </p:spPr>
+        <p:txBody>
+          <a:bodyPr wrap="square" anchor="t" lIns="0" rIns="0" tIns="0" bIns="0">
+            <a:spAutoFit/>
+          </a:bodyPr>
+          <a:lstStyle/>
+          <a:p>
+            <a:pPr>
+              <a:lnSpc>
+                <a:spcPct val="118000"/>
+              </a:lnSpc>
+            </a:pPr>
+            <a:r>
+              <a:rPr sz="1250" b="0">
+                <a:solidFill>
+                  <a:srgbClr val="5D6B75"/>
+                </a:solidFill>
+                <a:latin typeface="Calibri"/>
+              </a:rPr>
+              <a:t>Les dix graphiques. Moins commode que Seaborn, mais le contrôle sur chaque élément — donc sur chaque ornement retiré.</a:t>
+            </a:r>
+          </a:p>
+        </p:txBody>
+      </p:sp>
+      <p:sp>
+        <p:nvSpPr>
+          <p:cNvPr id="13" name="Shape 3"/>
+          <p:cNvSpPr/>
+          <p:nvPr/>
+        </p:nvSpPr>
+        <p:spPr>
+          <a:xfrm>
+            <a:off x="6236208" y="3035808"/>
+            <a:ext cx="5358384" cy="1325880"/>
+          </a:xfrm>
+          <a:prstGeom prst="roundRect">
+            <a:avLst>
+              <a:gd name="adj" fmla="val 3077"/>
+            </a:avLst>
+          </a:prstGeom>
+          <a:solidFill>
+            <a:srgbClr val="EAF3F4"/>
+          </a:solidFill>
+          <a:ln w="12700">
+            <a:solidFill>
+              <a:srgbClr val="D3E5E7"/>
+            </a:solidFill>
+          </a:ln>
+          <a:effectLst/>
+        </p:spPr>
+        <p:style>
+          <a:lnRef idx="1">
+            <a:schemeClr val="accent1"/>
+          </a:lnRef>
+          <a:fillRef idx="3">
+            <a:schemeClr val="accent1"/>
+          </a:fillRef>
+          <a:effectRef idx="2">
+            <a:schemeClr val="accent1"/>
+          </a:effectRef>
+          <a:fontRef idx="minor">
+            <a:schemeClr val="lt1"/>
+          </a:fontRef>
+        </p:style>
+        <p:txBody>
+          <a:bodyPr rtlCol="0" anchor="ctr"/>
+          <a:lstStyle/>
+          <a:p>
+            <a:pPr algn="ctr"/>
+          </a:p>
+        </p:txBody>
+      </p:sp>
+      <p:sp>
+        <p:nvSpPr>
+          <p:cNvPr id="14" name="Text 8"/>
+          <p:cNvSpPr txBox="1"/>
+          <p:nvPr/>
+        </p:nvSpPr>
+        <p:spPr>
+          <a:xfrm>
+            <a:off x="6510528" y="3218688"/>
+            <a:ext cx="4809744" cy="365760"/>
+          </a:xfrm>
+          <a:prstGeom prst="rect">
+            <a:avLst/>
+          </a:prstGeom>
+          <a:noFill/>
+        </p:spPr>
+        <p:txBody>
+          <a:bodyPr wrap="square" anchor="t" lIns="0" rIns="0" tIns="0" bIns="0">
+            <a:spAutoFit/>
+          </a:bodyPr>
+          <a:lstStyle/>
+          <a:p>
+            <a:r>
+              <a:rPr sz="1800" b="1">
+                <a:solidFill>
+                  <a:srgbClr val="0E7C86"/>
+                </a:solidFill>
+                <a:latin typeface="Cambria"/>
+              </a:rPr>
+              <a:t>scikit-learn</a:t>
+            </a:r>
+            <a:r>
+              <a:rPr sz="1050" b="0">
+                <a:solidFill>
+                  <a:srgbClr val="5D6B75"/>
+                </a:solidFill>
+                <a:latin typeface="Calibri"/>
+              </a:rPr>
+              <a:t>   1.9</a:t>
+            </a:r>
+          </a:p>
+        </p:txBody>
+      </p:sp>
+      <p:sp>
+        <p:nvSpPr>
+          <p:cNvPr id="15" name="Text 9"/>
+          <p:cNvSpPr txBox="1"/>
+          <p:nvPr/>
+        </p:nvSpPr>
+        <p:spPr>
+          <a:xfrm>
+            <a:off x="6510528" y="3712463"/>
+            <a:ext cx="4809744" cy="411479"/>
+          </a:xfrm>
+          <a:prstGeom prst="rect">
+            <a:avLst/>
+          </a:prstGeom>
+          <a:noFill/>
+        </p:spPr>
+        <p:txBody>
+          <a:bodyPr wrap="square" anchor="t" lIns="0" rIns="0" tIns="0" bIns="0">
+            <a:spAutoFit/>
+          </a:bodyPr>
+          <a:lstStyle/>
+          <a:p>
+            <a:pPr>
+              <a:lnSpc>
+                <a:spcPct val="118000"/>
+              </a:lnSpc>
+            </a:pPr>
+            <a:r>
+              <a:rPr sz="1250" b="0">
+                <a:solidFill>
+                  <a:srgbClr val="5D6B75"/>
+                </a:solidFill>
+                <a:latin typeface="Calibri"/>
+              </a:rPr>
+              <a:t>Le modèle prédictif. Une seule interface </a:t>
+            </a:r>
+            <a:r>
+              <a:rPr sz="1250" b="1">
+                <a:solidFill>
+                  <a:srgbClr val="16232B"/>
+                </a:solidFill>
+                <a:latin typeface="Calibri"/>
+              </a:rPr>
+              <a:t>fit / predict</a:t>
+            </a:r>
+            <a:r>
+              <a:rPr sz="1250" b="0">
+                <a:solidFill>
+                  <a:srgbClr val="5D6B75"/>
+                </a:solidFill>
+                <a:latin typeface="Calibri"/>
+              </a:rPr>
+              <a:t> : comparer quatre algorithmes ne change qu'un nom.</a:t>
+            </a:r>
+          </a:p>
+        </p:txBody>
+      </p:sp>
+      <p:sp>
+        <p:nvSpPr>
+          <p:cNvPr id="16" name="Text 10"/>
+          <p:cNvSpPr txBox="1"/>
+          <p:nvPr/>
+        </p:nvSpPr>
+        <p:spPr>
+          <a:xfrm>
+            <a:off x="594360" y="4572000"/>
+            <a:ext cx="10972800" cy="640080"/>
+          </a:xfrm>
+          <a:prstGeom prst="rect">
+            <a:avLst/>
+          </a:prstGeom>
+          <a:noFill/>
+        </p:spPr>
+        <p:txBody>
+          <a:bodyPr wrap="square" anchor="ctr" lIns="0" rIns="0" tIns="0" bIns="0">
+            <a:spAutoFit/>
+          </a:bodyPr>
+          <a:lstStyle/>
+          <a:p>
+            <a:pPr>
+              <a:lnSpc>
+                <a:spcPct val="120000"/>
+              </a:lnSpc>
+            </a:pPr>
+            <a:r>
+              <a:rPr sz="1350" b="0">
+                <a:solidFill>
+                  <a:srgbClr val="5D6B75"/>
+                </a:solidFill>
+                <a:latin typeface="Calibri"/>
+              </a:rPr>
+              <a:t>Versions figées dans </a:t>
+            </a:r>
+            <a:r>
+              <a:rPr sz="1300" b="0">
+                <a:solidFill>
+                  <a:srgbClr val="16232B"/>
+                </a:solidFill>
+                <a:latin typeface="Consolas"/>
+              </a:rPr>
+              <a:t>requirements.txt</a:t>
+            </a:r>
+            <a:r>
+              <a:rPr sz="1350" b="0">
+                <a:solidFill>
+                  <a:srgbClr val="5D6B75"/>
+                </a:solidFill>
+                <a:latin typeface="Calibri"/>
+              </a:rPr>
+              <a:t>. Les types compacts imposés à pandas ramènent la mémoire de 3,2 Go à 1,0 Go.</a:t>
+            </a:r>
           </a:p>
         </p:txBody>
       </p:sp>
@@ -5324,767 +5685,6 @@
 </file>
 
 <file path=ppt/slides/slide3.xml><?xml version="1.0" encoding="utf-8"?>
-<p:sld xmlns:a="http://schemas.openxmlformats.org/drawingml/2006/main" xmlns:p="http://schemas.openxmlformats.org/presentationml/2006/main" xmlns:r="http://schemas.openxmlformats.org/officeDocument/2006/relationships">
-  <p:cSld>
-    <p:bg>
-      <p:bgPr>
-        <a:solidFill>
-          <a:srgbClr val="FFFFFF"/>
-        </a:solidFill>
-        <a:effectLst/>
-      </p:bgPr>
-    </p:bg>
-    <p:spTree>
-      <p:nvGrpSpPr>
-        <p:cNvPr id="1" name=""/>
-        <p:cNvGrpSpPr/>
-        <p:nvPr/>
-      </p:nvGrpSpPr>
-      <p:grpSpPr/>
-      <p:sp>
-        <p:nvSpPr>
-          <p:cNvPr id="2" name="Text 0"/>
-          <p:cNvSpPr txBox="1"/>
-          <p:nvPr/>
-        </p:nvSpPr>
-        <p:spPr>
-          <a:xfrm>
-            <a:off x="594360" y="182880"/>
-            <a:ext cx="10972800" cy="219456"/>
-          </a:xfrm>
-          <a:prstGeom prst="rect">
-            <a:avLst/>
-          </a:prstGeom>
-          <a:noFill/>
-        </p:spPr>
-        <p:txBody>
-          <a:bodyPr wrap="square" anchor="ctr" lIns="0" rIns="0" tIns="0" bIns="0">
-            <a:spAutoFit/>
-          </a:bodyPr>
-          <a:lstStyle/>
-          <a:p>
-            <a:r>
-              <a:rPr sz="1050" b="1" spc="160">
-                <a:solidFill>
-                  <a:srgbClr val="0E7C86"/>
-                </a:solidFill>
-                <a:latin typeface="Calibri"/>
-              </a:rPr>
-              <a:t>AVEC QUOI NOUS AVONS TRAVAILLÉ</a:t>
-            </a:r>
-          </a:p>
-        </p:txBody>
-      </p:sp>
-      <p:sp>
-        <p:nvSpPr>
-          <p:cNvPr id="3" name="Text 1"/>
-          <p:cNvSpPr txBox="1"/>
-          <p:nvPr/>
-        </p:nvSpPr>
-        <p:spPr>
-          <a:xfrm>
-            <a:off x="594360" y="384048"/>
-            <a:ext cx="10972800" cy="658368"/>
-          </a:xfrm>
-          <a:prstGeom prst="rect">
-            <a:avLst/>
-          </a:prstGeom>
-          <a:noFill/>
-        </p:spPr>
-        <p:txBody>
-          <a:bodyPr wrap="square" anchor="ctr" lIns="0" rIns="0" tIns="0" bIns="0">
-            <a:spAutoFit/>
-          </a:bodyPr>
-          <a:lstStyle/>
-          <a:p>
-            <a:r>
-              <a:rPr sz="2700" b="1">
-                <a:solidFill>
-                  <a:srgbClr val="16232B"/>
-                </a:solidFill>
-                <a:latin typeface="Cambria"/>
-              </a:rPr>
-              <a:t>Quatre bibliothèques, un choix assumé pour chacune</a:t>
-            </a:r>
-          </a:p>
-        </p:txBody>
-      </p:sp>
-      <p:sp>
-        <p:nvSpPr>
-          <p:cNvPr id="4" name="Shape 0"/>
-          <p:cNvSpPr/>
-          <p:nvPr/>
-        </p:nvSpPr>
-        <p:spPr>
-          <a:xfrm>
-            <a:off x="594360" y="1325880"/>
-            <a:ext cx="5358384" cy="1938528"/>
-          </a:xfrm>
-          <a:prstGeom prst="roundRect">
-            <a:avLst>
-              <a:gd name="adj" fmla="val 2800"/>
-            </a:avLst>
-          </a:prstGeom>
-          <a:solidFill>
-            <a:srgbClr val="FFFFFF"/>
-          </a:solidFill>
-          <a:ln w="12700">
-            <a:solidFill>
-              <a:srgbClr val="DFE6EA"/>
-            </a:solidFill>
-          </a:ln>
-          <a:effectLst/>
-        </p:spPr>
-        <p:style>
-          <a:lnRef idx="1">
-            <a:schemeClr val="accent1"/>
-          </a:lnRef>
-          <a:fillRef idx="3">
-            <a:schemeClr val="accent1"/>
-          </a:fillRef>
-          <a:effectRef idx="2">
-            <a:schemeClr val="accent1"/>
-          </a:effectRef>
-          <a:fontRef idx="minor">
-            <a:schemeClr val="lt1"/>
-          </a:fontRef>
-        </p:style>
-        <p:txBody>
-          <a:bodyPr rtlCol="0" anchor="ctr"/>
-          <a:lstStyle/>
-          <a:p>
-            <a:pPr algn="ctr"/>
-          </a:p>
-        </p:txBody>
-      </p:sp>
-      <p:sp>
-        <p:nvSpPr>
-          <p:cNvPr id="5" name="Text 2"/>
-          <p:cNvSpPr txBox="1"/>
-          <p:nvPr/>
-        </p:nvSpPr>
-        <p:spPr>
-          <a:xfrm>
-            <a:off x="868680" y="1508760"/>
-            <a:ext cx="4809744" cy="365760"/>
-          </a:xfrm>
-          <a:prstGeom prst="rect">
-            <a:avLst/>
-          </a:prstGeom>
-          <a:noFill/>
-        </p:spPr>
-        <p:txBody>
-          <a:bodyPr wrap="square" anchor="t" lIns="0" rIns="0" tIns="0" bIns="0">
-            <a:spAutoFit/>
-          </a:bodyPr>
-          <a:lstStyle/>
-          <a:p>
-            <a:r>
-              <a:rPr sz="1800" b="1">
-                <a:solidFill>
-                  <a:srgbClr val="0E7C86"/>
-                </a:solidFill>
-                <a:latin typeface="Cambria"/>
-              </a:rPr>
-              <a:t>pandas</a:t>
-            </a:r>
-            <a:r>
-              <a:rPr sz="1050" b="0">
-                <a:solidFill>
-                  <a:srgbClr val="5D6B75"/>
-                </a:solidFill>
-                <a:latin typeface="Calibri"/>
-              </a:rPr>
-              <a:t>   3.0</a:t>
-            </a:r>
-          </a:p>
-        </p:txBody>
-      </p:sp>
-      <p:sp>
-        <p:nvSpPr>
-          <p:cNvPr id="6" name="Text 3"/>
-          <p:cNvSpPr txBox="1"/>
-          <p:nvPr/>
-        </p:nvSpPr>
-        <p:spPr>
-          <a:xfrm>
-            <a:off x="868680" y="1965960"/>
-            <a:ext cx="4809744" cy="1069848"/>
-          </a:xfrm>
-          <a:prstGeom prst="rect">
-            <a:avLst/>
-          </a:prstGeom>
-          <a:noFill/>
-        </p:spPr>
-        <p:txBody>
-          <a:bodyPr wrap="square" anchor="t" lIns="0" rIns="0" tIns="0" bIns="0">
-            <a:spAutoFit/>
-          </a:bodyPr>
-          <a:lstStyle/>
-          <a:p>
-            <a:pPr>
-              <a:lnSpc>
-                <a:spcPct val="118000"/>
-              </a:lnSpc>
-            </a:pPr>
-            <a:r>
-              <a:rPr sz="1150" b="0">
-                <a:solidFill>
-                  <a:srgbClr val="5D6B75"/>
-                </a:solidFill>
-                <a:latin typeface="Calibri"/>
-              </a:rPr>
-              <a:t>Toute la manipulation. Le modèle </a:t>
-            </a:r>
-            <a:r>
-              <a:rPr sz="1150" b="1">
-                <a:solidFill>
-                  <a:srgbClr val="16232B"/>
-                </a:solidFill>
-                <a:latin typeface="Calibri"/>
-              </a:rPr>
-              <a:t>DataFrame</a:t>
-            </a:r>
-            <a:r>
-              <a:rPr sz="1150" b="0">
-                <a:solidFill>
-                  <a:srgbClr val="5D6B75"/>
-                </a:solidFill>
-                <a:latin typeface="Calibri"/>
-              </a:rPr>
-              <a:t> épouse le format tabulaire des CSV, et jointures comme regroupements y sont natifs, exécutés en C plutôt qu'en boucles Python. Polars irait plus vite ; pandas reste le standard qu'un relecteur sait lire.</a:t>
-            </a:r>
-          </a:p>
-        </p:txBody>
-      </p:sp>
-      <p:sp>
-        <p:nvSpPr>
-          <p:cNvPr id="7" name="Shape 1"/>
-          <p:cNvSpPr/>
-          <p:nvPr/>
-        </p:nvSpPr>
-        <p:spPr>
-          <a:xfrm>
-            <a:off x="6236208" y="1325880"/>
-            <a:ext cx="5358384" cy="1938528"/>
-          </a:xfrm>
-          <a:prstGeom prst="roundRect">
-            <a:avLst>
-              <a:gd name="adj" fmla="val 2800"/>
-            </a:avLst>
-          </a:prstGeom>
-          <a:solidFill>
-            <a:srgbClr val="FFFFFF"/>
-          </a:solidFill>
-          <a:ln w="12700">
-            <a:solidFill>
-              <a:srgbClr val="DFE6EA"/>
-            </a:solidFill>
-          </a:ln>
-          <a:effectLst/>
-        </p:spPr>
-        <p:style>
-          <a:lnRef idx="1">
-            <a:schemeClr val="accent1"/>
-          </a:lnRef>
-          <a:fillRef idx="3">
-            <a:schemeClr val="accent1"/>
-          </a:fillRef>
-          <a:effectRef idx="2">
-            <a:schemeClr val="accent1"/>
-          </a:effectRef>
-          <a:fontRef idx="minor">
-            <a:schemeClr val="lt1"/>
-          </a:fontRef>
-        </p:style>
-        <p:txBody>
-          <a:bodyPr rtlCol="0" anchor="ctr"/>
-          <a:lstStyle/>
-          <a:p>
-            <a:pPr algn="ctr"/>
-          </a:p>
-        </p:txBody>
-      </p:sp>
-      <p:sp>
-        <p:nvSpPr>
-          <p:cNvPr id="8" name="Text 4"/>
-          <p:cNvSpPr txBox="1"/>
-          <p:nvPr/>
-        </p:nvSpPr>
-        <p:spPr>
-          <a:xfrm>
-            <a:off x="6510528" y="1508760"/>
-            <a:ext cx="4809744" cy="365760"/>
-          </a:xfrm>
-          <a:prstGeom prst="rect">
-            <a:avLst/>
-          </a:prstGeom>
-          <a:noFill/>
-        </p:spPr>
-        <p:txBody>
-          <a:bodyPr wrap="square" anchor="t" lIns="0" rIns="0" tIns="0" bIns="0">
-            <a:spAutoFit/>
-          </a:bodyPr>
-          <a:lstStyle/>
-          <a:p>
-            <a:r>
-              <a:rPr sz="1800" b="1">
-                <a:solidFill>
-                  <a:srgbClr val="0E7C86"/>
-                </a:solidFill>
-                <a:latin typeface="Cambria"/>
-              </a:rPr>
-              <a:t>NumPy</a:t>
-            </a:r>
-            <a:r>
-              <a:rPr sz="1050" b="0">
-                <a:solidFill>
-                  <a:srgbClr val="5D6B75"/>
-                </a:solidFill>
-                <a:latin typeface="Calibri"/>
-              </a:rPr>
-              <a:t>   2.5</a:t>
-            </a:r>
-          </a:p>
-        </p:txBody>
-      </p:sp>
-      <p:sp>
-        <p:nvSpPr>
-          <p:cNvPr id="9" name="Text 5"/>
-          <p:cNvSpPr txBox="1"/>
-          <p:nvPr/>
-        </p:nvSpPr>
-        <p:spPr>
-          <a:xfrm>
-            <a:off x="6510528" y="1965960"/>
-            <a:ext cx="4809744" cy="1069848"/>
-          </a:xfrm>
-          <a:prstGeom prst="rect">
-            <a:avLst/>
-          </a:prstGeom>
-          <a:noFill/>
-        </p:spPr>
-        <p:txBody>
-          <a:bodyPr wrap="square" anchor="t" lIns="0" rIns="0" tIns="0" bIns="0">
-            <a:spAutoFit/>
-          </a:bodyPr>
-          <a:lstStyle/>
-          <a:p>
-            <a:pPr>
-              <a:lnSpc>
-                <a:spcPct val="118000"/>
-              </a:lnSpc>
-            </a:pPr>
-            <a:r>
-              <a:rPr sz="1150" b="0">
-                <a:solidFill>
-                  <a:srgbClr val="5D6B75"/>
-                </a:solidFill>
-                <a:latin typeface="Calibri"/>
-              </a:rPr>
-              <a:t>Les tableaux typés sur lesquels pandas repose lui-même. Nous nous en servons directement pour le calcul vectorisé — une opération sur 32 millions de valeurs d'un seul coup — et pour le tirage aléatoire à graine fixe qui rend l'exécution reproductible.</a:t>
-            </a:r>
-          </a:p>
-        </p:txBody>
-      </p:sp>
-      <p:sp>
-        <p:nvSpPr>
-          <p:cNvPr id="10" name="Shape 2"/>
-          <p:cNvSpPr/>
-          <p:nvPr/>
-        </p:nvSpPr>
-        <p:spPr>
-          <a:xfrm>
-            <a:off x="594360" y="3401568"/>
-            <a:ext cx="5358384" cy="1938528"/>
-          </a:xfrm>
-          <a:prstGeom prst="roundRect">
-            <a:avLst>
-              <a:gd name="adj" fmla="val 2800"/>
-            </a:avLst>
-          </a:prstGeom>
-          <a:solidFill>
-            <a:srgbClr val="FFFFFF"/>
-          </a:solidFill>
-          <a:ln w="12700">
-            <a:solidFill>
-              <a:srgbClr val="DFE6EA"/>
-            </a:solidFill>
-          </a:ln>
-          <a:effectLst/>
-        </p:spPr>
-        <p:style>
-          <a:lnRef idx="1">
-            <a:schemeClr val="accent1"/>
-          </a:lnRef>
-          <a:fillRef idx="3">
-            <a:schemeClr val="accent1"/>
-          </a:fillRef>
-          <a:effectRef idx="2">
-            <a:schemeClr val="accent1"/>
-          </a:effectRef>
-          <a:fontRef idx="minor">
-            <a:schemeClr val="lt1"/>
-          </a:fontRef>
-        </p:style>
-        <p:txBody>
-          <a:bodyPr rtlCol="0" anchor="ctr"/>
-          <a:lstStyle/>
-          <a:p>
-            <a:pPr algn="ctr"/>
-          </a:p>
-        </p:txBody>
-      </p:sp>
-      <p:sp>
-        <p:nvSpPr>
-          <p:cNvPr id="11" name="Text 6"/>
-          <p:cNvSpPr txBox="1"/>
-          <p:nvPr/>
-        </p:nvSpPr>
-        <p:spPr>
-          <a:xfrm>
-            <a:off x="868680" y="3584448"/>
-            <a:ext cx="4809744" cy="365760"/>
-          </a:xfrm>
-          <a:prstGeom prst="rect">
-            <a:avLst/>
-          </a:prstGeom>
-          <a:noFill/>
-        </p:spPr>
-        <p:txBody>
-          <a:bodyPr wrap="square" anchor="t" lIns="0" rIns="0" tIns="0" bIns="0">
-            <a:spAutoFit/>
-          </a:bodyPr>
-          <a:lstStyle/>
-          <a:p>
-            <a:r>
-              <a:rPr sz="1800" b="1">
-                <a:solidFill>
-                  <a:srgbClr val="0E7C86"/>
-                </a:solidFill>
-                <a:latin typeface="Cambria"/>
-              </a:rPr>
-              <a:t>Matplotlib</a:t>
-            </a:r>
-            <a:r>
-              <a:rPr sz="1050" b="0">
-                <a:solidFill>
-                  <a:srgbClr val="5D6B75"/>
-                </a:solidFill>
-                <a:latin typeface="Calibri"/>
-              </a:rPr>
-              <a:t>   3.11</a:t>
-            </a:r>
-          </a:p>
-        </p:txBody>
-      </p:sp>
-      <p:sp>
-        <p:nvSpPr>
-          <p:cNvPr id="12" name="Text 7"/>
-          <p:cNvSpPr txBox="1"/>
-          <p:nvPr/>
-        </p:nvSpPr>
-        <p:spPr>
-          <a:xfrm>
-            <a:off x="868680" y="4041648"/>
-            <a:ext cx="4809744" cy="1069848"/>
-          </a:xfrm>
-          <a:prstGeom prst="rect">
-            <a:avLst/>
-          </a:prstGeom>
-          <a:noFill/>
-        </p:spPr>
-        <p:txBody>
-          <a:bodyPr wrap="square" anchor="t" lIns="0" rIns="0" tIns="0" bIns="0">
-            <a:spAutoFit/>
-          </a:bodyPr>
-          <a:lstStyle/>
-          <a:p>
-            <a:pPr>
-              <a:lnSpc>
-                <a:spcPct val="118000"/>
-              </a:lnSpc>
-            </a:pPr>
-            <a:r>
-              <a:rPr sz="1150" b="0">
-                <a:solidFill>
-                  <a:srgbClr val="5D6B75"/>
-                </a:solidFill>
-                <a:latin typeface="Calibri"/>
-              </a:rPr>
-              <a:t>Les dix graphiques. Seaborn serait plus flatteur en moins de lignes, Plotly ajouterait l'interactivité ; Matplotlib donne le contrôle sur </a:t>
-            </a:r>
-            <a:r>
-              <a:rPr sz="1150" b="1">
-                <a:solidFill>
-                  <a:srgbClr val="16232B"/>
-                </a:solidFill>
-                <a:latin typeface="Calibri"/>
-              </a:rPr>
-              <a:t>chaque</a:t>
-            </a:r>
-            <a:r>
-              <a:rPr sz="1150" b="0">
-                <a:solidFill>
-                  <a:srgbClr val="5D6B75"/>
-                </a:solidFill>
-                <a:latin typeface="Calibri"/>
-              </a:rPr>
-              <a:t> élément — indispensable quand il faut justifier chaque choix visuel et retirer tout ornement inutile.</a:t>
-            </a:r>
-          </a:p>
-        </p:txBody>
-      </p:sp>
-      <p:sp>
-        <p:nvSpPr>
-          <p:cNvPr id="13" name="Shape 3"/>
-          <p:cNvSpPr/>
-          <p:nvPr/>
-        </p:nvSpPr>
-        <p:spPr>
-          <a:xfrm>
-            <a:off x="6236208" y="3401568"/>
-            <a:ext cx="5358384" cy="1938528"/>
-          </a:xfrm>
-          <a:prstGeom prst="roundRect">
-            <a:avLst>
-              <a:gd name="adj" fmla="val 2800"/>
-            </a:avLst>
-          </a:prstGeom>
-          <a:solidFill>
-            <a:srgbClr val="FFFFFF"/>
-          </a:solidFill>
-          <a:ln w="12700">
-            <a:solidFill>
-              <a:srgbClr val="DFE6EA"/>
-            </a:solidFill>
-          </a:ln>
-          <a:effectLst/>
-        </p:spPr>
-        <p:style>
-          <a:lnRef idx="1">
-            <a:schemeClr val="accent1"/>
-          </a:lnRef>
-          <a:fillRef idx="3">
-            <a:schemeClr val="accent1"/>
-          </a:fillRef>
-          <a:effectRef idx="2">
-            <a:schemeClr val="accent1"/>
-          </a:effectRef>
-          <a:fontRef idx="minor">
-            <a:schemeClr val="lt1"/>
-          </a:fontRef>
-        </p:style>
-        <p:txBody>
-          <a:bodyPr rtlCol="0" anchor="ctr"/>
-          <a:lstStyle/>
-          <a:p>
-            <a:pPr algn="ctr"/>
-          </a:p>
-        </p:txBody>
-      </p:sp>
-      <p:sp>
-        <p:nvSpPr>
-          <p:cNvPr id="14" name="Text 8"/>
-          <p:cNvSpPr txBox="1"/>
-          <p:nvPr/>
-        </p:nvSpPr>
-        <p:spPr>
-          <a:xfrm>
-            <a:off x="6510528" y="3584448"/>
-            <a:ext cx="4809744" cy="365760"/>
-          </a:xfrm>
-          <a:prstGeom prst="rect">
-            <a:avLst/>
-          </a:prstGeom>
-          <a:noFill/>
-        </p:spPr>
-        <p:txBody>
-          <a:bodyPr wrap="square" anchor="t" lIns="0" rIns="0" tIns="0" bIns="0">
-            <a:spAutoFit/>
-          </a:bodyPr>
-          <a:lstStyle/>
-          <a:p>
-            <a:r>
-              <a:rPr sz="1800" b="1">
-                <a:solidFill>
-                  <a:srgbClr val="0E7C86"/>
-                </a:solidFill>
-                <a:latin typeface="Cambria"/>
-              </a:rPr>
-              <a:t>scikit-learn</a:t>
-            </a:r>
-            <a:r>
-              <a:rPr sz="1050" b="0">
-                <a:solidFill>
-                  <a:srgbClr val="5D6B75"/>
-                </a:solidFill>
-                <a:latin typeface="Calibri"/>
-              </a:rPr>
-              <a:t>   1.9</a:t>
-            </a:r>
-          </a:p>
-        </p:txBody>
-      </p:sp>
-      <p:sp>
-        <p:nvSpPr>
-          <p:cNvPr id="15" name="Text 9"/>
-          <p:cNvSpPr txBox="1"/>
-          <p:nvPr/>
-        </p:nvSpPr>
-        <p:spPr>
-          <a:xfrm>
-            <a:off x="6510528" y="4041648"/>
-            <a:ext cx="4809744" cy="1069848"/>
-          </a:xfrm>
-          <a:prstGeom prst="rect">
-            <a:avLst/>
-          </a:prstGeom>
-          <a:noFill/>
-        </p:spPr>
-        <p:txBody>
-          <a:bodyPr wrap="square" anchor="t" lIns="0" rIns="0" tIns="0" bIns="0">
-            <a:spAutoFit/>
-          </a:bodyPr>
-          <a:lstStyle/>
-          <a:p>
-            <a:pPr>
-              <a:lnSpc>
-                <a:spcPct val="118000"/>
-              </a:lnSpc>
-            </a:pPr>
-            <a:r>
-              <a:rPr sz="1150" b="0">
-                <a:solidFill>
-                  <a:srgbClr val="5D6B75"/>
-                </a:solidFill>
-                <a:latin typeface="Calibri"/>
-              </a:rPr>
-              <a:t>Le modèle prédictif. Découpe, algorithmes, métriques et importance des variables partagent la même interface </a:t>
-            </a:r>
-            <a:r>
-              <a:rPr sz="1150" b="1">
-                <a:solidFill>
-                  <a:srgbClr val="16232B"/>
-                </a:solidFill>
-                <a:latin typeface="Calibri"/>
-              </a:rPr>
-              <a:t>fit / predict</a:t>
-            </a:r>
-            <a:r>
-              <a:rPr sz="1150" b="0">
-                <a:solidFill>
-                  <a:srgbClr val="5D6B75"/>
-                </a:solidFill>
-                <a:latin typeface="Calibri"/>
-              </a:rPr>
-              <a:t> : comparer quatre modèles ne demande alors que d'en changer le nom.</a:t>
-            </a:r>
-          </a:p>
-        </p:txBody>
-      </p:sp>
-      <p:sp>
-        <p:nvSpPr>
-          <p:cNvPr id="16" name="Text 10"/>
-          <p:cNvSpPr txBox="1"/>
-          <p:nvPr/>
-        </p:nvSpPr>
-        <p:spPr>
-          <a:xfrm>
-            <a:off x="594360" y="5623560"/>
-            <a:ext cx="10972800" cy="777240"/>
-          </a:xfrm>
-          <a:prstGeom prst="rect">
-            <a:avLst/>
-          </a:prstGeom>
-          <a:noFill/>
-        </p:spPr>
-        <p:txBody>
-          <a:bodyPr wrap="square" anchor="ctr" lIns="0" rIns="0" tIns="0" bIns="0">
-            <a:spAutoFit/>
-          </a:bodyPr>
-          <a:lstStyle/>
-          <a:p>
-            <a:pPr>
-              <a:lnSpc>
-                <a:spcPct val="120000"/>
-              </a:lnSpc>
-            </a:pPr>
-            <a:r>
-              <a:rPr sz="1350" b="0">
-                <a:solidFill>
-                  <a:srgbClr val="5D6B75"/>
-                </a:solidFill>
-                <a:latin typeface="Calibri"/>
-              </a:rPr>
-              <a:t>Versions figées dans </a:t>
-            </a:r>
-            <a:r>
-              <a:rPr sz="1300" b="0">
-                <a:solidFill>
-                  <a:srgbClr val="16232B"/>
-                </a:solidFill>
-                <a:latin typeface="Consolas"/>
-              </a:rPr>
-              <a:t>requirements.txt</a:t>
-            </a:r>
-            <a:r>
-              <a:rPr sz="1350" b="0">
-                <a:solidFill>
-                  <a:srgbClr val="5D6B75"/>
-                </a:solidFill>
-                <a:latin typeface="Calibri"/>
-              </a:rPr>
-              <a:t>. Les types compacts imposés à pandas — </a:t>
-            </a:r>
-            <a:r>
-              <a:rPr sz="1350" b="1">
-                <a:solidFill>
-                  <a:srgbClr val="16232B"/>
-                </a:solidFill>
-                <a:latin typeface="Calibri"/>
-              </a:rPr>
-              <a:t>int8</a:t>
-            </a:r>
-            <a:r>
-              <a:rPr sz="1350" b="0">
-                <a:solidFill>
-                  <a:srgbClr val="5D6B75"/>
-                </a:solidFill>
-                <a:latin typeface="Calibri"/>
-              </a:rPr>
-              <a:t>, </a:t>
-            </a:r>
-            <a:r>
-              <a:rPr sz="1350" b="1">
-                <a:solidFill>
-                  <a:srgbClr val="16232B"/>
-                </a:solidFill>
-                <a:latin typeface="Calibri"/>
-              </a:rPr>
-              <a:t>int16</a:t>
-            </a:r>
-            <a:r>
-              <a:rPr sz="1350" b="0">
-                <a:solidFill>
-                  <a:srgbClr val="5D6B75"/>
-                </a:solidFill>
-                <a:latin typeface="Calibri"/>
-              </a:rPr>
-              <a:t>, catégories — ramènent l'empreinte mémoire de 3,2 Go à 1,0 Go : c'est ce qui rend le projet exécutable sur une machine ordinaire, et non sur un serveur.</a:t>
-            </a:r>
-          </a:p>
-        </p:txBody>
-      </p:sp>
-    </p:spTree>
-  </p:cSld>
-  <p:clrMapOvr>
-    <a:masterClrMapping/>
-  </p:clrMapOvr>
-</p:sld>
-</file>
-
-<file path=ppt/slides/slide4.xml><?xml version="1.0" encoding="utf-8"?>
 <p:sld xmlns:a="http://schemas.openxmlformats.org/drawingml/2006/main" xmlns:r="http://schemas.openxmlformats.org/officeDocument/2006/relationships" xmlns:p="http://schemas.openxmlformats.org/presentationml/2006/main">
   <p:cSld name="Slide 3">
     <p:bg>
@@ -6327,7 +5927,7 @@
 </p:sld>
 </file>
 
-<file path=ppt/slides/slide5.xml><?xml version="1.0" encoding="utf-8"?>
+<file path=ppt/slides/slide4.xml><?xml version="1.0" encoding="utf-8"?>
 <p:sld xmlns:a="http://schemas.openxmlformats.org/drawingml/2006/main" xmlns:r="http://schemas.openxmlformats.org/officeDocument/2006/relationships" xmlns:p="http://schemas.openxmlformats.org/presentationml/2006/main">
   <p:cSld name="Slide 4">
     <p:bg>
@@ -6655,7 +6255,7 @@
 </p:sld>
 </file>
 
-<file path=ppt/slides/slide6.xml><?xml version="1.0" encoding="utf-8"?>
+<file path=ppt/slides/slide5.xml><?xml version="1.0" encoding="utf-8"?>
 <p:sld xmlns:a="http://schemas.openxmlformats.org/drawingml/2006/main" xmlns:r="http://schemas.openxmlformats.org/officeDocument/2006/relationships" xmlns:p="http://schemas.openxmlformats.org/presentationml/2006/main">
   <p:cSld name="Slide 5">
     <p:bg>
@@ -6983,7 +6583,7 @@
 </p:sld>
 </file>
 
-<file path=ppt/slides/slide7.xml><?xml version="1.0" encoding="utf-8"?>
+<file path=ppt/slides/slide6.xml><?xml version="1.0" encoding="utf-8"?>
 <p:sld xmlns:a="http://schemas.openxmlformats.org/drawingml/2006/main" xmlns:r="http://schemas.openxmlformats.org/officeDocument/2006/relationships" xmlns:p="http://schemas.openxmlformats.org/presentationml/2006/main">
   <p:cSld name="Slide 6">
     <p:bg>
@@ -7311,7 +6911,7 @@
 </p:sld>
 </file>
 
-<file path=ppt/slides/slide8.xml><?xml version="1.0" encoding="utf-8"?>
+<file path=ppt/slides/slide7.xml><?xml version="1.0" encoding="utf-8"?>
 <p:sld xmlns:a="http://schemas.openxmlformats.org/drawingml/2006/main" xmlns:r="http://schemas.openxmlformats.org/officeDocument/2006/relationships" xmlns:p="http://schemas.openxmlformats.org/presentationml/2006/main">
   <p:cSld name="Slide 7">
     <p:bg>
@@ -7639,7 +7239,7 @@
 </p:sld>
 </file>
 
-<file path=ppt/slides/slide9.xml><?xml version="1.0" encoding="utf-8"?>
+<file path=ppt/slides/slide8.xml><?xml version="1.0" encoding="utf-8"?>
 <p:sld xmlns:a="http://schemas.openxmlformats.org/drawingml/2006/main" xmlns:r="http://schemas.openxmlformats.org/officeDocument/2006/relationships" xmlns:p="http://schemas.openxmlformats.org/presentationml/2006/main">
   <p:cSld name="Slide 8">
     <p:bg>
@@ -7954,6 +7554,334 @@
                 <a:cs typeface="Cambria" pitchFamily="34" charset="-120"/>
               </a:rPr>
               <a:t>5</a:t>
+            </a:r>
+            <a:endParaRPr lang="en-US" sz="3400" dirty="0"/>
+          </a:p>
+        </p:txBody>
+      </p:sp>
+    </p:spTree>
+  </p:cSld>
+  <p:clrMapOvr>
+    <a:masterClrMapping/>
+  </p:clrMapOvr>
+</p:sld>
+</file>
+
+<file path=ppt/slides/slide9.xml><?xml version="1.0" encoding="utf-8"?>
+<p:sld xmlns:a="http://schemas.openxmlformats.org/drawingml/2006/main" xmlns:r="http://schemas.openxmlformats.org/officeDocument/2006/relationships" xmlns:p="http://schemas.openxmlformats.org/presentationml/2006/main">
+  <p:cSld name="Slide 9">
+    <p:bg>
+      <p:bgPr>
+        <a:solidFill>
+          <a:srgbClr val="FFFFFF"/>
+        </a:solidFill>
+        <a:effectLst/>
+      </p:bgPr>
+    </p:bg>
+    <p:spTree>
+      <p:nvGrpSpPr>
+        <p:cNvPr id="1" name=""/>
+        <p:cNvGrpSpPr/>
+        <p:nvPr/>
+      </p:nvGrpSpPr>
+      <p:grpSpPr>
+        <a:xfrm>
+          <a:off x="0" y="0"/>
+          <a:ext cx="0" cy="0"/>
+          <a:chOff x="0" y="0"/>
+          <a:chExt cx="0" cy="0"/>
+        </a:xfrm>
+      </p:grpSpPr>
+      <p:sp>
+        <p:nvSpPr>
+          <p:cNvPr id="2" name="Text 0"/>
+          <p:cNvSpPr txBox="1"/>
+          <p:nvPr/>
+        </p:nvSpPr>
+        <p:spPr>
+          <a:xfrm>
+            <a:off x="594360" y="182880"/>
+            <a:ext cx="10972800" cy="219456"/>
+          </a:xfrm>
+          <a:prstGeom prst="rect">
+            <a:avLst/>
+          </a:prstGeom>
+          <a:noFill/>
+          <a:ln/>
+        </p:spPr>
+        <p:txBody>
+          <a:bodyPr wrap="square" lIns="0" tIns="0" rIns="0" bIns="0" rtlCol="0" anchor="ctr"/>
+          <a:lstStyle/>
+          <a:p>
+            <a:pPr marL="0" indent="0">
+              <a:buNone/>
+            </a:pPr>
+            <a:r>
+              <a:rPr lang="en-US" sz="1050" b="1" kern="0" spc="160" dirty="0">
+                <a:solidFill>
+                  <a:srgbClr val="0E7C86"/>
+                </a:solidFill>
+                <a:latin typeface="Calibri" pitchFamily="34" charset="0"/>
+                <a:ea typeface="Calibri" pitchFamily="34" charset="-122"/>
+                <a:cs typeface="Calibri" pitchFamily="34" charset="-120"/>
+              </a:rPr>
+              <a:t>DÉMONSTRATION 6</a:t>
+            </a:r>
+            <a:endParaRPr lang="en-US" sz="1050" dirty="0"/>
+          </a:p>
+        </p:txBody>
+      </p:sp>
+      <p:sp>
+        <p:nvSpPr>
+          <p:cNvPr id="3" name="Text 1"/>
+          <p:cNvSpPr txBox="1"/>
+          <p:nvPr/>
+        </p:nvSpPr>
+        <p:spPr>
+          <a:xfrm>
+            <a:off x="594360" y="384048"/>
+            <a:ext cx="10972800" cy="658368"/>
+          </a:xfrm>
+          <a:prstGeom prst="rect">
+            <a:avLst/>
+          </a:prstGeom>
+          <a:noFill/>
+          <a:ln/>
+        </p:spPr>
+        <p:txBody>
+          <a:bodyPr wrap="square" lIns="0" tIns="0" rIns="0" bIns="0" rtlCol="0" anchor="ctr"/>
+          <a:lstStyle/>
+          <a:p>
+            <a:pPr marL="0" indent="0">
+              <a:buNone/>
+            </a:pPr>
+            <a:r>
+              <a:rPr lang="en-US" sz="2700" b="1" dirty="0">
+                <a:solidFill>
+                  <a:srgbClr val="16232B"/>
+                </a:solidFill>
+                <a:latin typeface="Cambria" pitchFamily="34" charset="0"/>
+                <a:ea typeface="Cambria" pitchFamily="34" charset="-122"/>
+                <a:cs typeface="Cambria" pitchFamily="34" charset="-120"/>
+              </a:rPr>
+              <a:t>Le week-end ne gonfle pas les paniers, il les déplace</a:t>
+            </a:r>
+            <a:endParaRPr lang="en-US" sz="2700" dirty="0"/>
+          </a:p>
+        </p:txBody>
+      </p:sp>
+      <p:pic>
+        <p:nvPicPr>
+          <p:cNvPr id="4" name="Image 0" descr="02_projet\_ppt\fig06.png"/>
+          <p:cNvPicPr>
+            <a:picLocks noChangeAspect="1"/>
+          </p:cNvPicPr>
+          <p:nvPr/>
+        </p:nvPicPr>
+        <p:blipFill>
+          <a:blip r:embed="rId3"/>
+          <a:stretch>
+            <a:fillRect/>
+          </a:stretch>
+        </p:blipFill>
+        <p:spPr>
+          <a:xfrm>
+            <a:off x="594360" y="1481726"/>
+            <a:ext cx="6903720" cy="3565364"/>
+          </a:xfrm>
+          <a:prstGeom prst="rect">
+            <a:avLst/>
+          </a:prstGeom>
+        </p:spPr>
+      </p:pic>
+      <p:sp>
+        <p:nvSpPr>
+          <p:cNvPr id="5" name="Text 2"/>
+          <p:cNvSpPr txBox="1"/>
+          <p:nvPr/>
+        </p:nvSpPr>
+        <p:spPr>
+          <a:xfrm>
+            <a:off x="594360" y="5440680"/>
+            <a:ext cx="6903720" cy="457200"/>
+          </a:xfrm>
+          <a:prstGeom prst="rect">
+            <a:avLst/>
+          </a:prstGeom>
+          <a:noFill/>
+          <a:ln/>
+        </p:spPr>
+        <p:txBody>
+          <a:bodyPr wrap="square" lIns="0" tIns="0" rIns="0" bIns="0" rtlCol="0" anchor="t"/>
+          <a:lstStyle/>
+          <a:p>
+            <a:pPr marL="0" indent="0">
+              <a:buNone/>
+            </a:pPr>
+            <a:r>
+              <a:rPr lang="en-US" sz="1100" i="1" dirty="0">
+                <a:solidFill>
+                  <a:srgbClr val="5D6B75"/>
+                </a:solidFill>
+                <a:latin typeface="Calibri" pitchFamily="34" charset="0"/>
+                <a:ea typeface="Calibri" pitchFamily="34" charset="-122"/>
+                <a:cs typeface="Calibri" pitchFamily="34" charset="-120"/>
+              </a:rPr>
+              <a:t>Les petits paniers reculent de 7 points au profit des gros.</a:t>
+            </a:r>
+            <a:endParaRPr lang="en-US" sz="1100" dirty="0"/>
+          </a:p>
+        </p:txBody>
+      </p:sp>
+      <p:sp>
+        <p:nvSpPr>
+          <p:cNvPr id="6" name="Shape 3"/>
+          <p:cNvSpPr/>
+          <p:nvPr/>
+        </p:nvSpPr>
+        <p:spPr>
+          <a:xfrm>
+            <a:off x="7818120" y="1207008"/>
+            <a:ext cx="3749040" cy="3200400"/>
+          </a:xfrm>
+          <a:prstGeom prst="roundRect">
+            <a:avLst>
+              <a:gd name="adj" fmla="val 1714"/>
+            </a:avLst>
+          </a:prstGeom>
+          <a:solidFill>
+            <a:srgbClr val="EAF3F4"/>
+          </a:solidFill>
+          <a:ln w="12700">
+            <a:solidFill>
+              <a:srgbClr val="D3E5E7"/>
+            </a:solidFill>
+            <a:prstDash val="solid"/>
+          </a:ln>
+        </p:spPr>
+        <p:txBody>
+          <a:bodyPr/>
+          <a:lstStyle/>
+          <a:p>
+            <a:endParaRPr lang="fr-FR"/>
+          </a:p>
+        </p:txBody>
+      </p:sp>
+      <p:sp>
+        <p:nvSpPr>
+          <p:cNvPr id="7" name="Text 4"/>
+          <p:cNvSpPr txBox="1"/>
+          <p:nvPr/>
+        </p:nvSpPr>
+        <p:spPr>
+          <a:xfrm>
+            <a:off x="8074152" y="1389888"/>
+            <a:ext cx="3236976" cy="219456"/>
+          </a:xfrm>
+          <a:prstGeom prst="rect">
+            <a:avLst/>
+          </a:prstGeom>
+          <a:noFill/>
+          <a:ln/>
+        </p:spPr>
+        <p:txBody>
+          <a:bodyPr wrap="square" lIns="0" tIns="0" rIns="0" bIns="0" rtlCol="0" anchor="ctr"/>
+          <a:lstStyle/>
+          <a:p>
+            <a:pPr marL="0" indent="0">
+              <a:buNone/>
+            </a:pPr>
+            <a:r>
+              <a:rPr lang="en-US" sz="950" b="1" kern="0" spc="120" dirty="0">
+                <a:solidFill>
+                  <a:srgbClr val="0E7C86"/>
+                </a:solidFill>
+                <a:latin typeface="Calibri" pitchFamily="34" charset="0"/>
+                <a:ea typeface="Calibri" pitchFamily="34" charset="-122"/>
+                <a:cs typeface="Calibri" pitchFamily="34" charset="-120"/>
+              </a:rPr>
+              <a:t>CE QUE NOUS PROPOSONS</a:t>
+            </a:r>
+            <a:endParaRPr lang="en-US" sz="950" dirty="0"/>
+          </a:p>
+        </p:txBody>
+      </p:sp>
+      <p:sp>
+        <p:nvSpPr>
+          <p:cNvPr id="8" name="Text 5"/>
+          <p:cNvSpPr txBox="1"/>
+          <p:nvPr/>
+        </p:nvSpPr>
+        <p:spPr>
+          <a:xfrm>
+            <a:off x="8074152" y="1682496"/>
+            <a:ext cx="3236976" cy="2505456"/>
+          </a:xfrm>
+          <a:prstGeom prst="rect">
+            <a:avLst/>
+          </a:prstGeom>
+          <a:noFill/>
+          <a:ln/>
+        </p:spPr>
+        <p:txBody>
+          <a:bodyPr wrap="square" lIns="0" tIns="0" rIns="0" bIns="0" rtlCol="0" anchor="t"/>
+          <a:lstStyle/>
+          <a:p>
+            <a:pPr marL="0" indent="0">
+              <a:lnSpc>
+                <a:spcPct val="110000"/>
+              </a:lnSpc>
+              <a:buNone/>
+            </a:pPr>
+            <a:r>
+              <a:rPr lang="en-US" sz="1300" dirty="0">
+                <a:solidFill>
+                  <a:srgbClr val="16232B"/>
+                </a:solidFill>
+                <a:latin typeface="Calibri" pitchFamily="34" charset="0"/>
+                <a:ea typeface="Calibri" pitchFamily="34" charset="-122"/>
+                <a:cs typeface="Calibri" pitchFamily="34" charset="-120"/>
+              </a:rPr>
+              <a:t>Placer les offres à seuil — « livraison offerte dès X articles » — le week-end, où les gros paniers sont déjà la norme.</a:t>
+            </a:r>
+            <a:endParaRPr lang="en-US" sz="1300" dirty="0"/>
+          </a:p>
+        </p:txBody>
+      </p:sp>
+      <p:sp>
+        <p:nvSpPr>
+          <p:cNvPr id="9" name="Text 6"/>
+          <p:cNvSpPr txBox="1"/>
+          <p:nvPr/>
+        </p:nvSpPr>
+        <p:spPr>
+          <a:xfrm>
+            <a:off x="7818120" y="4663440"/>
+            <a:ext cx="548640" cy="548640"/>
+          </a:xfrm>
+          <a:prstGeom prst="rect">
+            <a:avLst/>
+          </a:prstGeom>
+          <a:noFill/>
+          <a:ln/>
+        </p:spPr>
+        <p:txBody>
+          <a:bodyPr wrap="square" lIns="0" tIns="0" rIns="0" bIns="0" rtlCol="0" anchor="ctr"/>
+          <a:lstStyle/>
+          <a:p>
+            <a:pPr marL="0" indent="0">
+              <a:buNone/>
+            </a:pPr>
+            <a:r>
+              <a:rPr lang="en-US" sz="3400" b="1" dirty="0">
+                <a:solidFill>
+                  <a:srgbClr val="D8E4E6"/>
+                </a:solidFill>
+                <a:latin typeface="Cambria" pitchFamily="34" charset="0"/>
+                <a:ea typeface="Cambria" pitchFamily="34" charset="-122"/>
+                <a:cs typeface="Cambria" pitchFamily="34" charset="-120"/>
+              </a:rPr>
+              <a:t>6</a:t>
             </a:r>
             <a:endParaRPr lang="en-US" sz="3400" dirty="0"/>
           </a:p>

</xml_diff>

<commit_message>
Met a jour le support de soutenance
Co-Authored-By: Claude Fable 5.1 <noreply@anthropic.com>
</commit_message>
<xml_diff>
--- a/02_projet/soutenance.pptx
+++ b/02_projet/soutenance.pptx
@@ -5,25 +5,25 @@
     <p:sldMasterId id="2147483648" r:id="rId1"/>
   </p:sldMasterIdLst>
   <p:notesMasterIdLst>
-    <p:notesMasterId r:id="rId17"/>
+    <p:notesMasterId r:id="rId18"/>
   </p:notesMasterIdLst>
   <p:sldIdLst>
     <p:sldId id="256" r:id="rId2"/>
     <p:sldId id="257" r:id="rId3"/>
-    <p:sldId id="274" r:id="rId22"/>
-    <p:sldId id="258" r:id="rId4"/>
-    <p:sldId id="259" r:id="rId5"/>
-    <p:sldId id="260" r:id="rId6"/>
-    <p:sldId id="261" r:id="rId7"/>
-    <p:sldId id="262" r:id="rId8"/>
-    <p:sldId id="263" r:id="rId9"/>
-    <p:sldId id="264" r:id="rId10"/>
-    <p:sldId id="265" r:id="rId11"/>
-    <p:sldId id="266" r:id="rId12"/>
-    <p:sldId id="267" r:id="rId13"/>
-    <p:sldId id="268" r:id="rId14"/>
-    <p:sldId id="269" r:id="rId15"/>
-    <p:sldId id="273" r:id="rId16"/>
+    <p:sldId id="274" r:id="rId4"/>
+    <p:sldId id="258" r:id="rId5"/>
+    <p:sldId id="259" r:id="rId6"/>
+    <p:sldId id="260" r:id="rId7"/>
+    <p:sldId id="261" r:id="rId8"/>
+    <p:sldId id="262" r:id="rId9"/>
+    <p:sldId id="263" r:id="rId10"/>
+    <p:sldId id="264" r:id="rId11"/>
+    <p:sldId id="265" r:id="rId12"/>
+    <p:sldId id="266" r:id="rId13"/>
+    <p:sldId id="267" r:id="rId14"/>
+    <p:sldId id="268" r:id="rId15"/>
+    <p:sldId id="269" r:id="rId16"/>
+    <p:sldId id="273" r:id="rId17"/>
   </p:sldIdLst>
   <p:sldSz cx="12192000" cy="6858000"/>
   <p:notesSz cx="6858000" cy="12192000"/>
@@ -387,10 +387,10 @@
           <a:p>
             <a:r>
               <a:rPr lang="en-US" dirty="0"/>
-              <a:t>50 secondes.
-« On s'attendrait à ce que le lait revienne plus vite que les pâtes. Ce n'est pas le cas : entre l'allée la plus rapide et la plus lente, il n'y a que 2,7 jours d'écart. »
-LA CONCLUSION : le client ne commande pas quand il manque de lait. Il rachète du lait quand il fait ses courses.
-À DIRE AVANT QU'ON LE DEMANDE : notre première analyse utilisait la médiane et concluait à une platitude parfaite. Or cette variable ne prend que des valeurs entières : la médiane tombait toujours sur 7 ou 8. C'était un artefact. La moyenne révèle l'écart réel. RACONTEZ CETTE ERREUR, ELLE VOUS SERT — elle prouve que vous vérifiez.</a:t>
+              <a:t>45 secondes.
+« Le dimanche, les paniers de un à cinq articles tombent de 35 % à 25 %, et ceux de onze à vingt montent de 25 % à 33 %. »
+LA NUANCE QUI COMPTE : ce n'est pas une hausse générale, c'est un transfert. Les mêmes clients font moins de courses d'appoint et davantage de vraies courses. Le dire ainsi vaut mieux que « le panier moyen augmente ».
+SI ON DEMANDE POURQUOI PAS UNE MOYENNE : parce qu'elle masque la nature de l'effet. Elle passe de 9,3 à 11,1, ce qui suggère une hausse uniforme — les tranches montrent un déplacement.</a:t>
             </a:r>
           </a:p>
         </p:txBody>
@@ -477,10 +477,10 @@
           <a:p>
             <a:r>
               <a:rPr lang="en-US" dirty="0"/>
-              <a:t>40 secondes.
-« La composition du panier se déforme avec l'ancienneté. Certains rayons gagnent du terrain chez les clients installés, d'autres reculent après la première commande. »
-HONNÊTETÉ À ASSUMER : les écarts sont modestes — un à deux points. C'est une dérive lente, pas une substitution. Dites-le vous-même, cela vous crédibilise.
-LA CONSÉQUENCE OPÉRATIONNELLE RESTE VALABLE : les deux missions n'appellent ni les mêmes rayons ni les mêmes outils.</a:t>
+              <a:t>50 secondes.
+« On s'attendrait à ce que le lait revienne plus vite que les pâtes. Ce n'est pas le cas : entre l'allée la plus rapide et la plus lente, il n'y a que 2,7 jours d'écart. »
+LA CONCLUSION : le client ne commande pas quand il manque de lait. Il rachète du lait quand il fait ses courses.
+À DIRE AVANT QU'ON LE DEMANDE : notre première analyse utilisait la médiane et concluait à une platitude parfaite. Or cette variable ne prend que des valeurs entières : la médiane tombait toujours sur 7 ou 8. C'était un artefact. La moyenne révèle l'écart réel. RACONTEZ CETTE ERREUR, ELLE VOUS SERT — elle prouve que vous vérifiez.</a:t>
             </a:r>
           </a:p>
         </p:txBody>
@@ -567,10 +567,10 @@
           <a:p>
             <a:r>
               <a:rPr lang="en-US" dirty="0"/>
-              <a:t>60 secondes — C'EST VOTRE MEILLEURE DIAPOSITIVE.
-« Nous avons cherché quels produits s'achètent ensemble. Le comptage brut ne dit rien : il classe par popularité et met en tête bananes et fraises, ce qui est une tautologie. »
-« Nous avons donc calculé le lift : combien de fois plus souvent que le hasard. Et là, les couples changent complètement. Jalapeños et coriandre. Coriandre et oignon rouge. Citrons verts et coriandre. Ce sont des RECETTES. »
-LA RÉVÉLATION : à côté de la routine hebdomadaire, il existe un achat d'intention — « ce soir je cuisine tel plat ». Et puisque le panier ne grossit jamais, c'est le seul canal mesuré par lequel une nouveauté peut y entrer.</a:t>
+              <a:t>40 secondes.
+« La composition du panier se déforme avec l'ancienneté. Certains rayons gagnent du terrain chez les clients installés, d'autres reculent après la première commande. »
+HONNÊTETÉ À ASSUMER : les écarts sont modestes — un à deux points. C'est une dérive lente, pas une substitution. Dites-le vous-même, cela vous crédibilise.
+LA CONSÉQUENCE OPÉRATIONNELLE RESTE VALABLE : les deux missions n'appellent ni les mêmes rayons ni les mêmes outils.</a:t>
             </a:r>
           </a:p>
         </p:txBody>
@@ -657,10 +657,10 @@
           <a:p>
             <a:r>
               <a:rPr lang="en-US" dirty="0"/>
-              <a:t>40 secondes.
-« Si ce mode existe, il doit laisser une trace inverse : des produits très vendus mais rarement rachetés. La voici. »
-« Thym, concentré de tomate, courge butternut, huile d'olive, gingembre, échalote. Ce sont des ingrédients, pas des produits de base. Tout le monde en achète un jour, personne n'en rachète chaque semaine. »
-LE RENVERSEMENT À FAIRE ENTENDRE : ce ne sont pas des échecs. Chercher à augmenter leur réachat serait une erreur — ils ne fonctionnent pas ainsi. Il faut les traiter comme des portes d'entrée vers une recette.</a:t>
+              <a:t>60 secondes — C'EST VOTRE MEILLEURE DIAPOSITIVE.
+« Nous avons cherché quels produits s'achètent ensemble. Le comptage brut ne dit rien : il classe par popularité et met en tête bananes et fraises, ce qui est une tautologie. »
+« Nous avons donc calculé le lift : combien de fois plus souvent que le hasard. Et là, les couples changent complètement. Jalapeños et coriandre. Coriandre et oignon rouge. Citrons verts et coriandre. Ce sont des RECETTES. »
+LA RÉVÉLATION : à côté de la routine hebdomadaire, il existe un achat d'intention — « ce soir je cuisine tel plat ». Et puisque le panier ne grossit jamais, c'est le seul canal mesuré par lequel une nouveauté peut y entrer.</a:t>
             </a:r>
           </a:p>
         </p:txBody>
@@ -747,11 +747,10 @@
           <a:p>
             <a:r>
               <a:rPr lang="en-US" dirty="0"/>
-              <a:t>LE MOMENT DE LA VENTE — 90 secondes.
-Ralentissez. C'est ce que le jury doit retenir.
-Énoncez les quatre décisions dans l'ordre, en rattachant chacune à sa démonstration : « la première découle du graphique 1 », etc. Cela montre que rien n'est affirmé sans preuve.
-INSISTEZ SUR L'ORDRE : elles sont classées par rendement attendu, pas par facilité. La première est la plus rentable parce qu'elle agit sur la seule fenêtre où le comportement est encore malléable.
-SI ON DEMANDE LE COÛT : les trois premières sont des réallocations de budget existant, pas des dépenses nouvelles. Seule la quatrième demande un développement.</a:t>
+              <a:t>40 secondes.
+« Si ce mode existe, il doit laisser une trace inverse : des produits très vendus mais rarement rachetés. La voici. »
+« Thym, concentré de tomate, courge butternut, huile d'olive, gingembre, échalote. Ce sont des ingrédients, pas des produits de base. Tout le monde en achète un jour, personne n'en rachète chaque semaine. »
+LE RENVERSEMENT À FAIRE ENTENDRE : ce ne sont pas des échecs. Chercher à augmenter leur réachat serait une erreur — ils ne fonctionnent pas ainsi. Il faut les traiter comme des portes d'entrée vers une recette.</a:t>
             </a:r>
           </a:p>
         </p:txBody>
@@ -838,10 +837,11 @@
           <a:p>
             <a:r>
               <a:rPr lang="en-US" dirty="0"/>
-              <a:t>CLÔTURE — 20 secondes.
-Revenez à la phrase d'ouverture. La boucle se referme, et c'est elle que le jury emportera.
-« Nous avons commencé en disant que vous vendiez une habitude. Nous espérons vous avoir montré que c'est mesurable, et surtout que c'est actionnable. »
-Puis marquez un silence et proposez les questions. Ne meublez pas.</a:t>
+              <a:t>LE MOMENT DE LA VENTE — 90 secondes.
+Ralentissez. C'est ce que le jury doit retenir.
+Énoncez les quatre décisions dans l'ordre, en rattachant chacune à sa démonstration : « la première découle du graphique 1 », etc. Cela montre que rien n'est affirmé sans preuve.
+INSISTEZ SUR L'ORDRE : elles sont classées par rendement attendu, pas par facilité. La première est la plus rentable parce qu'elle agit sur la seule fenêtre où le comportement est encore malléable.
+SI ON DEMANDE LE COÛT : les trois premières sont des réallocations de budget existant, pas des dépenses nouvelles. Seule la quatrième demande un développement.</a:t>
             </a:r>
           </a:p>
         </p:txBody>
@@ -883,7 +883,7 @@
 </file>
 
 <file path=ppt/notesSlides/notesSlide16.xml><?xml version="1.0" encoding="utf-8"?>
-<p:notes xmlns:a="http://schemas.openxmlformats.org/drawingml/2006/main" xmlns:p="http://schemas.openxmlformats.org/presentationml/2006/main" xmlns:r="http://schemas.openxmlformats.org/officeDocument/2006/relationships">
+<p:notes xmlns:a="http://schemas.openxmlformats.org/drawingml/2006/main" xmlns:r="http://schemas.openxmlformats.org/officeDocument/2006/relationships" xmlns:p="http://schemas.openxmlformats.org/presentationml/2006/main">
   <p:cSld>
     <p:spTree>
       <p:nvGrpSpPr>
@@ -927,13 +927,11 @@
           <a:lstStyle/>
           <a:p>
             <a:r>
-              <a:rPr lang="fr-FR"/>
-              <a:t>AVEC QUOI — 40 secondes.
-Ne lisez pas les quatre cases : donnez la logique. « Chaque bibliothèque a été choisie contre une alternative, pas prise par défaut. »
-LE POINT À FAIRE ENTENDRE : Matplotlib plutôt que Seaborn est un choix coûteux — davantage de lignes de code — mais c'est lui qui nous a permis de retirer chaque ornement inutile. Sans ce contrôle, la promesse d'un graphique lisible ne tenait pas.
-LE CHIFFRE À CITER : 3,2 Go ramenés à 1,0 Go en imposant les types. Par défaut pandas met tout entier en int64, huit octets par valeur ; un jour de semaine en occupe un seul. Sur 32 millions de lignes, cet écart décide de la faisabilité.
-SI ON DEMANDE POURQUOI PAS POLARS : plus rapide, mais moins répandu. Ce code est fait pour être relu et repris — nous avons préféré le standard à la performance.
-SI ON DEMANDE POURQUOI PAS UNE BASE DE DONNÉES : une fois typées, les cinq tables tiennent en mémoire. Un SGBD n'aurait rien apporté et aurait ajouté une dépendance à installer.</a:t>
+              <a:rPr lang="en-US" dirty="0"/>
+              <a:t>CLÔTURE — 20 secondes.
+Revenez à la phrase d'ouverture. La boucle se referme, et c'est elle que le jury emportera.
+« Nous avons commencé en disant que vous vendiez une habitude. Nous espérons vous avoir montré que c'est mesurable, et surtout que c'est actionnable. »
+Puis marquez un silence et proposez les questions. Ne meublez pas.</a:t>
             </a:r>
           </a:p>
         </p:txBody>
@@ -955,13 +953,18 @@
           <a:p>
             <a:fld id="{F7021451-1387-4CA6-816F-3879F97B5CBC}" type="slidenum">
               <a:rPr lang="en-US"/>
-              <a:t>2</a:t>
+              <a:t>16</a:t>
             </a:fld>
             <a:endParaRPr lang="en-US"/>
           </a:p>
         </p:txBody>
       </p:sp>
     </p:spTree>
+    <p:extLst>
+      <p:ext uri="{BB962C8B-B14F-4D97-AF65-F5344CB8AC3E}">
+        <p14:creationId xmlns:p14="http://schemas.microsoft.com/office/powerpoint/2010/main" val="1024086991"/>
+      </p:ext>
+    </p:extLst>
   </p:cSld>
   <p:clrMapOvr>
     <a:masterClrMapping/>
@@ -1103,11 +1106,13 @@
           <a:lstStyle/>
           <a:p>
             <a:r>
-              <a:rPr lang="en-US" dirty="0"/>
-              <a:t>LE PIVOT — 30 secondes.
-C'est le moment le plus important de la présentation. Laissez le chiffre s'installer avant de parler.
-« Six articles sur dix que vous vendez, le client les avait déjà achetés. Votre chiffre d'affaires ne vient pas de la découverte, il vient de la répétition. »
-Tout ce qui suit découle de cette phrase — les dix démonstrations qui viennent ne font que l'établir et en tirer les conséquences.</a:t>
+              <a:rPr lang="fr-FR"/>
+              <a:t>AVEC QUOI — 40 secondes.
+Ne lisez pas les quatre cases : donnez la logique. « Chaque bibliothèque a été choisie contre une alternative, pas prise par défaut. »
+LE POINT À FAIRE ENTENDRE : Matplotlib plutôt que Seaborn est un choix coûteux — davantage de lignes de code — mais c'est lui qui nous a permis de retirer chaque ornement inutile. Sans ce contrôle, la promesse d'un graphique lisible ne tenait pas.
+LE CHIFFRE À CITER : 3,2 Go ramenés à 1,0 Go en imposant les types. Par défaut pandas met tout entier en int64, huit octets par valeur ; un jour de semaine en occupe un seul. Sur 32 millions de lignes, cet écart décide de la faisabilité.
+SI ON DEMANDE POURQUOI PAS POLARS : plus rapide, mais moins répandu. Ce code est fait pour être relu et repris — nous avons préféré le standard à la performance.
+SI ON DEMANDE POURQUOI PAS UNE BASE DE DONNÉES : une fois typées, les cinq tables tiennent en mémoire. Un SGBD n'aurait rien apporté et aurait ajouté une dépendance à installer.</a:t>
             </a:r>
           </a:p>
         </p:txBody>
@@ -1136,11 +1141,6 @@
         </p:txBody>
       </p:sp>
     </p:spTree>
-    <p:extLst>
-      <p:ext uri="{BB962C8B-B14F-4D97-AF65-F5344CB8AC3E}">
-        <p14:creationId xmlns:p14="http://schemas.microsoft.com/office/powerpoint/2010/main" val="1024086991"/>
-      </p:ext>
-    </p:extLst>
   </p:cSld>
   <p:clrMapOvr>
     <a:masterClrMapping/>
@@ -1194,10 +1194,10 @@
           <a:p>
             <a:r>
               <a:rPr lang="en-US" dirty="0"/>
-              <a:t>60 secondes.
-« Regardez la ligne du bas : elle est plate. De la deuxième à la quatre-vingtième commande, le panier reste à dix articles. Quinze ans de données ne la font pas bouger. » Puis la seconde : « en revanche, ce qu'il y a dedans se répète de plus en plus — 29 % de rachats au début, plus de 80 % ensuite. »
-LA CONCLUSION À ÉNONCER : le panier ne grossit pas, il se fige. Espérer un panier moyen plus gros est donc vain — c'est un objectif que les données déclarent inatteignable.
-OBJECTION PROBABLE : « la courbe descend à la fin ». Réponse : oui, de 10,4 à 9,0 après la quarantième commande, sur des effectifs plus faibles. Cela renforce l'argument.</a:t>
+              <a:t>LE PIVOT — 30 secondes.
+C'est le moment le plus important de la présentation. Laissez le chiffre s'installer avant de parler.
+« Six articles sur dix que vous vendez, le client les avait déjà achetés. Votre chiffre d'affaires ne vient pas de la découverte, il vient de la répétition. »
+Tout ce qui suit découle de cette phrase — les dix démonstrations qui viennent ne font que l'établir et en tirer les conséquences.</a:t>
             </a:r>
           </a:p>
         </p:txBody>
@@ -1284,10 +1284,10 @@
           <a:p>
             <a:r>
               <a:rPr lang="en-US" dirty="0"/>
-              <a:t>45 secondes.
-« Le premier article déposé dans le panier est racheté deux fois sur trois. Le vingtième, une fois sur deux. La décroissance est parfaitement régulière. »
-L'INTERPRÉTATION : le début du panier, ce sont les courses automatiques — le client ne réfléchit pas. La fin, c'est l'improvisation. C'est là qu'il est encore disponible pour une suggestion.
-OBJECTION : « les positions élevées sont-elles fiables ? » Seules celles comptant au moins 20 000 lignes de commande sont tracées.</a:t>
+              <a:t>60 secondes.
+« Regardez la ligne du bas : elle est plate. De la deuxième à la quatre-vingtième commande, le panier reste à dix articles. Quinze ans de données ne la font pas bouger. » Puis la seconde : « en revanche, ce qu'il y a dedans se répète de plus en plus — 29 % de rachats au début, plus de 80 % ensuite. »
+LA CONCLUSION À ÉNONCER : le panier ne grossit pas, il se fige. Espérer un panier moyen plus gros est donc vain — c'est un objectif que les données déclarent inatteignable.
+OBJECTION PROBABLE : « la courbe descend à la fin ». Réponse : oui, de 10,4 à 9,0 après la quarantième commande, sur des effectifs plus faibles. Cela renforce l'argument.</a:t>
             </a:r>
           </a:p>
         </p:txBody>
@@ -1375,9 +1375,9 @@
             <a:r>
               <a:rPr lang="en-US" dirty="0"/>
               <a:t>45 secondes.
-« Les produits laitiers se rachètent dans deux tiers des cas, l'hygiène dans un tiers. C'est un rapport de un à deux, et il est structurel : on consomme du lait tous les jours, pas du shampoing. »
-LA CONSÉQUENCE : leur appliquer le même objectif de fidélisation n'a pas de sens. C'est une erreur de pilotage courante, et elle se corrige sans rien investir.
-SI ON DEMANDE OÙ EST LE RAYON « NON RENSEIGNÉ » : écarté volontairement. Ce sont 1 258 produits non classés — liquide vaisselle, pommes, stylos — dont le taux moyen ne décrit aucun comportement. Ils restent dans les totaux, où ils pèsent 0,21 %.</a:t>
+« Le premier article déposé dans le panier est racheté deux fois sur trois. Le vingtième, une fois sur deux. La décroissance est parfaitement régulière. »
+L'INTERPRÉTATION : le début du panier, ce sont les courses automatiques — le client ne réfléchit pas. La fin, c'est l'improvisation. C'est là qu'il est encore disponible pour une suggestion.
+OBJECTION : « les positions élevées sont-elles fiables ? » Seules celles comptant au moins 20 000 lignes de commande sont tracées.</a:t>
             </a:r>
           </a:p>
         </p:txBody>
@@ -1464,10 +1464,10 @@
           <a:p>
             <a:r>
               <a:rPr lang="en-US" dirty="0"/>
-              <a:t>40 secondes.
-« Une référence sur dix est bio. Mais trois articles vendus sur dix le sont. Et ces produits se rachètent 6,6 points au-dessus du reste. »
-LA FORMULE À RETENIR : une référence bio travaille trois fois plus qu'une référence ordinaire. Ce n'est pas une niche, c'est un moteur de fidélité sous-exploité.
-RÉSERVE À ANNONCER VOUS-MÊME : nous repérons le bio par le mot « organic » dans le libellé. C'est une approximation, mais l'écart est trop marqué pour tenir à ce biais. Et attention : nous constatons une association, pas une causalité.</a:t>
+              <a:t>45 secondes.
+« Les produits laitiers se rachètent dans deux tiers des cas, l'hygiène dans un tiers. C'est un rapport de un à deux, et il est structurel : on consomme du lait tous les jours, pas du shampoing. »
+LA CONSÉQUENCE : leur appliquer le même objectif de fidélisation n'a pas de sens. C'est une erreur de pilotage courante, et elle se corrige sans rien investir.
+SI ON DEMANDE OÙ EST LE RAYON « NON RENSEIGNÉ » : écarté volontairement. Ce sont 1 258 produits non classés — liquide vaisselle, pommes, stylos — dont le taux moyen ne décrit aucun comportement. Ils restent dans les totaux, où ils pèsent 0,21 %.</a:t>
             </a:r>
           </a:p>
         </p:txBody>
@@ -1555,9 +1555,9 @@
             <a:r>
               <a:rPr lang="en-US" dirty="0"/>
               <a:t>40 secondes.
-« Cette carte croise le jour et l'heure. Deux foyers apparaissent, nettement séparés : le lundi vers dix heures, et le dimanche début d'après-midi. »
-L'INTERPRÉTATION : ce ne sont pas les mêmes courses. L'une ressemble au réapprovisionnement de semaine, l'autre à la course familiale. Une communication du dimanche ne parle pas au client du lundi.
-LE PIÈGE À ÉVITER : dimensionner la logistique sur la moyenne. Aucun client ne commande à l'heure moyenne.</a:t>
+« Une référence sur dix est bio. Mais trois articles vendus sur dix le sont. Et ces produits se rachètent 6,6 points au-dessus du reste. »
+LA FORMULE À RETENIR : une référence bio travaille trois fois plus qu'une référence ordinaire. Ce n'est pas une niche, c'est un moteur de fidélité sous-exploité.
+RÉSERVE À ANNONCER VOUS-MÊME : nous repérons le bio par le mot « organic » dans le libellé. C'est une approximation, mais l'écart est trop marqué pour tenir à ce biais. Et attention : nous constatons une association, pas une causalité.</a:t>
             </a:r>
           </a:p>
         </p:txBody>
@@ -1644,10 +1644,10 @@
           <a:p>
             <a:r>
               <a:rPr lang="en-US" dirty="0"/>
-              <a:t>45 secondes.
-« Le dimanche, les paniers de un à cinq articles tombent de 35 % à 25 %, et ceux de onze à vingt montent de 25 % à 33 %. »
-LA NUANCE QUI COMPTE : ce n'est pas une hausse générale, c'est un transfert. Les mêmes clients font moins de courses d'appoint et davantage de vraies courses. Le dire ainsi vaut mieux que « le panier moyen augmente ».
-SI ON DEMANDE POURQUOI PAS UNE MOYENNE : parce qu'elle masque la nature de l'effet. Elle passe de 9,3 à 11,1, ce qui suggère une hausse uniforme — les tranches montrent un déplacement.</a:t>
+              <a:t>40 secondes.
+« Cette carte croise le jour et l'heure. Deux foyers apparaissent, nettement séparés : le lundi vers dix heures, et le dimanche début d'après-midi. »
+L'INTERPRÉTATION : ce ne sont pas les mêmes courses. L'une ressemble au réapprovisionnement de semaine, l'autre à la course familiale. Une communication du dimanche ne parle pas au client du lundi.
+LE PIÈGE À ÉVITER : dimensionner la logistique sur la moyenne. Aucun client ne commande à l'heure moyenne.</a:t>
             </a:r>
           </a:p>
         </p:txBody>
@@ -2178,6 +2178,334 @@
 
 <file path=ppt/slides/slide10.xml><?xml version="1.0" encoding="utf-8"?>
 <p:sld xmlns:a="http://schemas.openxmlformats.org/drawingml/2006/main" xmlns:r="http://schemas.openxmlformats.org/officeDocument/2006/relationships" xmlns:p="http://schemas.openxmlformats.org/presentationml/2006/main">
+  <p:cSld name="Slide 9">
+    <p:bg>
+      <p:bgPr>
+        <a:solidFill>
+          <a:srgbClr val="FFFFFF"/>
+        </a:solidFill>
+        <a:effectLst/>
+      </p:bgPr>
+    </p:bg>
+    <p:spTree>
+      <p:nvGrpSpPr>
+        <p:cNvPr id="1" name=""/>
+        <p:cNvGrpSpPr/>
+        <p:nvPr/>
+      </p:nvGrpSpPr>
+      <p:grpSpPr>
+        <a:xfrm>
+          <a:off x="0" y="0"/>
+          <a:ext cx="0" cy="0"/>
+          <a:chOff x="0" y="0"/>
+          <a:chExt cx="0" cy="0"/>
+        </a:xfrm>
+      </p:grpSpPr>
+      <p:sp>
+        <p:nvSpPr>
+          <p:cNvPr id="2" name="Text 0"/>
+          <p:cNvSpPr txBox="1"/>
+          <p:nvPr/>
+        </p:nvSpPr>
+        <p:spPr>
+          <a:xfrm>
+            <a:off x="594360" y="182880"/>
+            <a:ext cx="10972800" cy="219456"/>
+          </a:xfrm>
+          <a:prstGeom prst="rect">
+            <a:avLst/>
+          </a:prstGeom>
+          <a:noFill/>
+          <a:ln/>
+        </p:spPr>
+        <p:txBody>
+          <a:bodyPr wrap="square" lIns="0" tIns="0" rIns="0" bIns="0" rtlCol="0" anchor="ctr"/>
+          <a:lstStyle/>
+          <a:p>
+            <a:pPr marL="0" indent="0">
+              <a:buNone/>
+            </a:pPr>
+            <a:r>
+              <a:rPr lang="en-US" sz="1050" b="1" kern="0" spc="160" dirty="0">
+                <a:solidFill>
+                  <a:srgbClr val="0E7C86"/>
+                </a:solidFill>
+                <a:latin typeface="Calibri" pitchFamily="34" charset="0"/>
+                <a:ea typeface="Calibri" pitchFamily="34" charset="-122"/>
+                <a:cs typeface="Calibri" pitchFamily="34" charset="-120"/>
+              </a:rPr>
+              <a:t>DÉMONSTRATION 6</a:t>
+            </a:r>
+            <a:endParaRPr lang="en-US" sz="1050" dirty="0"/>
+          </a:p>
+        </p:txBody>
+      </p:sp>
+      <p:sp>
+        <p:nvSpPr>
+          <p:cNvPr id="3" name="Text 1"/>
+          <p:cNvSpPr txBox="1"/>
+          <p:nvPr/>
+        </p:nvSpPr>
+        <p:spPr>
+          <a:xfrm>
+            <a:off x="594360" y="384048"/>
+            <a:ext cx="10972800" cy="658368"/>
+          </a:xfrm>
+          <a:prstGeom prst="rect">
+            <a:avLst/>
+          </a:prstGeom>
+          <a:noFill/>
+          <a:ln/>
+        </p:spPr>
+        <p:txBody>
+          <a:bodyPr wrap="square" lIns="0" tIns="0" rIns="0" bIns="0" rtlCol="0" anchor="ctr"/>
+          <a:lstStyle/>
+          <a:p>
+            <a:pPr marL="0" indent="0">
+              <a:buNone/>
+            </a:pPr>
+            <a:r>
+              <a:rPr lang="en-US" sz="2700" b="1" dirty="0">
+                <a:solidFill>
+                  <a:srgbClr val="16232B"/>
+                </a:solidFill>
+                <a:latin typeface="Cambria" pitchFamily="34" charset="0"/>
+                <a:ea typeface="Cambria" pitchFamily="34" charset="-122"/>
+                <a:cs typeface="Cambria" pitchFamily="34" charset="-120"/>
+              </a:rPr>
+              <a:t>Le week-end ne gonfle pas les paniers, il les déplace</a:t>
+            </a:r>
+            <a:endParaRPr lang="en-US" sz="2700" dirty="0"/>
+          </a:p>
+        </p:txBody>
+      </p:sp>
+      <p:pic>
+        <p:nvPicPr>
+          <p:cNvPr id="4" name="Image 0" descr="02_projet\_ppt\fig06.png"/>
+          <p:cNvPicPr>
+            <a:picLocks noChangeAspect="1"/>
+          </p:cNvPicPr>
+          <p:nvPr/>
+        </p:nvPicPr>
+        <p:blipFill>
+          <a:blip r:embed="rId3"/>
+          <a:stretch>
+            <a:fillRect/>
+          </a:stretch>
+        </p:blipFill>
+        <p:spPr>
+          <a:xfrm>
+            <a:off x="594360" y="1481726"/>
+            <a:ext cx="6903720" cy="3565364"/>
+          </a:xfrm>
+          <a:prstGeom prst="rect">
+            <a:avLst/>
+          </a:prstGeom>
+        </p:spPr>
+      </p:pic>
+      <p:sp>
+        <p:nvSpPr>
+          <p:cNvPr id="5" name="Text 2"/>
+          <p:cNvSpPr txBox="1"/>
+          <p:nvPr/>
+        </p:nvSpPr>
+        <p:spPr>
+          <a:xfrm>
+            <a:off x="594360" y="5440680"/>
+            <a:ext cx="6903720" cy="457200"/>
+          </a:xfrm>
+          <a:prstGeom prst="rect">
+            <a:avLst/>
+          </a:prstGeom>
+          <a:noFill/>
+          <a:ln/>
+        </p:spPr>
+        <p:txBody>
+          <a:bodyPr wrap="square" lIns="0" tIns="0" rIns="0" bIns="0" rtlCol="0" anchor="t"/>
+          <a:lstStyle/>
+          <a:p>
+            <a:pPr marL="0" indent="0">
+              <a:buNone/>
+            </a:pPr>
+            <a:r>
+              <a:rPr lang="en-US" sz="1100" i="1" dirty="0">
+                <a:solidFill>
+                  <a:srgbClr val="5D6B75"/>
+                </a:solidFill>
+                <a:latin typeface="Calibri" pitchFamily="34" charset="0"/>
+                <a:ea typeface="Calibri" pitchFamily="34" charset="-122"/>
+                <a:cs typeface="Calibri" pitchFamily="34" charset="-120"/>
+              </a:rPr>
+              <a:t>Les petits paniers reculent de 7 points au profit des gros.</a:t>
+            </a:r>
+            <a:endParaRPr lang="en-US" sz="1100" dirty="0"/>
+          </a:p>
+        </p:txBody>
+      </p:sp>
+      <p:sp>
+        <p:nvSpPr>
+          <p:cNvPr id="6" name="Shape 3"/>
+          <p:cNvSpPr/>
+          <p:nvPr/>
+        </p:nvSpPr>
+        <p:spPr>
+          <a:xfrm>
+            <a:off x="7818120" y="1207008"/>
+            <a:ext cx="3749040" cy="3200400"/>
+          </a:xfrm>
+          <a:prstGeom prst="roundRect">
+            <a:avLst>
+              <a:gd name="adj" fmla="val 1714"/>
+            </a:avLst>
+          </a:prstGeom>
+          <a:solidFill>
+            <a:srgbClr val="EAF3F4"/>
+          </a:solidFill>
+          <a:ln w="12700">
+            <a:solidFill>
+              <a:srgbClr val="D3E5E7"/>
+            </a:solidFill>
+            <a:prstDash val="solid"/>
+          </a:ln>
+        </p:spPr>
+        <p:txBody>
+          <a:bodyPr/>
+          <a:lstStyle/>
+          <a:p>
+            <a:endParaRPr lang="fr-FR"/>
+          </a:p>
+        </p:txBody>
+      </p:sp>
+      <p:sp>
+        <p:nvSpPr>
+          <p:cNvPr id="7" name="Text 4"/>
+          <p:cNvSpPr txBox="1"/>
+          <p:nvPr/>
+        </p:nvSpPr>
+        <p:spPr>
+          <a:xfrm>
+            <a:off x="8074152" y="1389888"/>
+            <a:ext cx="3236976" cy="219456"/>
+          </a:xfrm>
+          <a:prstGeom prst="rect">
+            <a:avLst/>
+          </a:prstGeom>
+          <a:noFill/>
+          <a:ln/>
+        </p:spPr>
+        <p:txBody>
+          <a:bodyPr wrap="square" lIns="0" tIns="0" rIns="0" bIns="0" rtlCol="0" anchor="ctr"/>
+          <a:lstStyle/>
+          <a:p>
+            <a:pPr marL="0" indent="0">
+              <a:buNone/>
+            </a:pPr>
+            <a:r>
+              <a:rPr lang="en-US" sz="950" b="1" kern="0" spc="120" dirty="0">
+                <a:solidFill>
+                  <a:srgbClr val="0E7C86"/>
+                </a:solidFill>
+                <a:latin typeface="Calibri" pitchFamily="34" charset="0"/>
+                <a:ea typeface="Calibri" pitchFamily="34" charset="-122"/>
+                <a:cs typeface="Calibri" pitchFamily="34" charset="-120"/>
+              </a:rPr>
+              <a:t>CE QUE NOUS PROPOSONS</a:t>
+            </a:r>
+            <a:endParaRPr lang="en-US" sz="950" dirty="0"/>
+          </a:p>
+        </p:txBody>
+      </p:sp>
+      <p:sp>
+        <p:nvSpPr>
+          <p:cNvPr id="8" name="Text 5"/>
+          <p:cNvSpPr txBox="1"/>
+          <p:nvPr/>
+        </p:nvSpPr>
+        <p:spPr>
+          <a:xfrm>
+            <a:off x="8074152" y="1682496"/>
+            <a:ext cx="3236976" cy="2505456"/>
+          </a:xfrm>
+          <a:prstGeom prst="rect">
+            <a:avLst/>
+          </a:prstGeom>
+          <a:noFill/>
+          <a:ln/>
+        </p:spPr>
+        <p:txBody>
+          <a:bodyPr wrap="square" lIns="0" tIns="0" rIns="0" bIns="0" rtlCol="0" anchor="t"/>
+          <a:lstStyle/>
+          <a:p>
+            <a:pPr marL="0" indent="0">
+              <a:lnSpc>
+                <a:spcPct val="110000"/>
+              </a:lnSpc>
+              <a:buNone/>
+            </a:pPr>
+            <a:r>
+              <a:rPr lang="en-US" sz="1300" dirty="0">
+                <a:solidFill>
+                  <a:srgbClr val="16232B"/>
+                </a:solidFill>
+                <a:latin typeface="Calibri" pitchFamily="34" charset="0"/>
+                <a:ea typeface="Calibri" pitchFamily="34" charset="-122"/>
+                <a:cs typeface="Calibri" pitchFamily="34" charset="-120"/>
+              </a:rPr>
+              <a:t>Placer les offres à seuil — « livraison offerte dès X articles » — le week-end, où les gros paniers sont déjà la norme.</a:t>
+            </a:r>
+            <a:endParaRPr lang="en-US" sz="1300" dirty="0"/>
+          </a:p>
+        </p:txBody>
+      </p:sp>
+      <p:sp>
+        <p:nvSpPr>
+          <p:cNvPr id="9" name="Text 6"/>
+          <p:cNvSpPr txBox="1"/>
+          <p:nvPr/>
+        </p:nvSpPr>
+        <p:spPr>
+          <a:xfrm>
+            <a:off x="7818120" y="4663440"/>
+            <a:ext cx="548640" cy="548640"/>
+          </a:xfrm>
+          <a:prstGeom prst="rect">
+            <a:avLst/>
+          </a:prstGeom>
+          <a:noFill/>
+          <a:ln/>
+        </p:spPr>
+        <p:txBody>
+          <a:bodyPr wrap="square" lIns="0" tIns="0" rIns="0" bIns="0" rtlCol="0" anchor="ctr"/>
+          <a:lstStyle/>
+          <a:p>
+            <a:pPr marL="0" indent="0">
+              <a:buNone/>
+            </a:pPr>
+            <a:r>
+              <a:rPr lang="en-US" sz="3400" b="1" dirty="0">
+                <a:solidFill>
+                  <a:srgbClr val="D8E4E6"/>
+                </a:solidFill>
+                <a:latin typeface="Cambria" pitchFamily="34" charset="0"/>
+                <a:ea typeface="Cambria" pitchFamily="34" charset="-122"/>
+                <a:cs typeface="Cambria" pitchFamily="34" charset="-120"/>
+              </a:rPr>
+              <a:t>6</a:t>
+            </a:r>
+            <a:endParaRPr lang="en-US" sz="3400" dirty="0"/>
+          </a:p>
+        </p:txBody>
+      </p:sp>
+    </p:spTree>
+  </p:cSld>
+  <p:clrMapOvr>
+    <a:masterClrMapping/>
+  </p:clrMapOvr>
+</p:sld>
+</file>
+
+<file path=ppt/slides/slide11.xml><?xml version="1.0" encoding="utf-8"?>
+<p:sld xmlns:a="http://schemas.openxmlformats.org/drawingml/2006/main" xmlns:r="http://schemas.openxmlformats.org/officeDocument/2006/relationships" xmlns:p="http://schemas.openxmlformats.org/presentationml/2006/main">
   <p:cSld name="Slide 10">
     <p:bg>
       <p:bgPr>
@@ -2504,7 +2832,7 @@
 </p:sld>
 </file>
 
-<file path=ppt/slides/slide11.xml><?xml version="1.0" encoding="utf-8"?>
+<file path=ppt/slides/slide12.xml><?xml version="1.0" encoding="utf-8"?>
 <p:sld xmlns:a="http://schemas.openxmlformats.org/drawingml/2006/main" xmlns:r="http://schemas.openxmlformats.org/officeDocument/2006/relationships" xmlns:p="http://schemas.openxmlformats.org/presentationml/2006/main">
   <p:cSld name="Slide 11">
     <p:bg>
@@ -2832,7 +3160,7 @@
 </p:sld>
 </file>
 
-<file path=ppt/slides/slide12.xml><?xml version="1.0" encoding="utf-8"?>
+<file path=ppt/slides/slide13.xml><?xml version="1.0" encoding="utf-8"?>
 <p:sld xmlns:a="http://schemas.openxmlformats.org/drawingml/2006/main" xmlns:r="http://schemas.openxmlformats.org/officeDocument/2006/relationships" xmlns:p="http://schemas.openxmlformats.org/presentationml/2006/main">
   <p:cSld name="Slide 12">
     <p:bg>
@@ -3160,7 +3488,7 @@
 </p:sld>
 </file>
 
-<file path=ppt/slides/slide13.xml><?xml version="1.0" encoding="utf-8"?>
+<file path=ppt/slides/slide14.xml><?xml version="1.0" encoding="utf-8"?>
 <p:sld xmlns:a="http://schemas.openxmlformats.org/drawingml/2006/main" xmlns:r="http://schemas.openxmlformats.org/officeDocument/2006/relationships" xmlns:p="http://schemas.openxmlformats.org/presentationml/2006/main">
   <p:cSld name="Slide 13">
     <p:bg>
@@ -3488,7 +3816,7 @@
 </p:sld>
 </file>
 
-<file path=ppt/slides/slide14.xml><?xml version="1.0" encoding="utf-8"?>
+<file path=ppt/slides/slide15.xml><?xml version="1.0" encoding="utf-8"?>
 <p:sld xmlns:a="http://schemas.openxmlformats.org/drawingml/2006/main" xmlns:r="http://schemas.openxmlformats.org/officeDocument/2006/relationships" xmlns:p="http://schemas.openxmlformats.org/presentationml/2006/main">
   <p:cSld name="Slide 14">
     <p:bg>
@@ -4207,7 +4535,7 @@
 </p:sld>
 </file>
 
-<file path=ppt/slides/slide15.xml><?xml version="1.0" encoding="utf-8"?>
+<file path=ppt/slides/slide16.xml><?xml version="1.0" encoding="utf-8"?>
 <p:sld xmlns:a="http://schemas.openxmlformats.org/drawingml/2006/main" xmlns:r="http://schemas.openxmlformats.org/officeDocument/2006/relationships" xmlns:p="http://schemas.openxmlformats.org/presentationml/2006/main">
   <p:cSld name="Slide 18">
     <p:bg>
@@ -4383,695 +4711,6 @@
               <a:t>.</a:t>
             </a:r>
             <a:endParaRPr lang="en-US" sz="1600" dirty="0"/>
-          </a:p>
-        </p:txBody>
-      </p:sp>
-    </p:spTree>
-  </p:cSld>
-  <p:clrMapOvr>
-    <a:masterClrMapping/>
-  </p:clrMapOvr>
-</p:sld>
-</file>
-
-<file path=ppt/slides/slide16.xml><?xml version="1.0" encoding="utf-8"?>
-<p:sld xmlns:a="http://schemas.openxmlformats.org/drawingml/2006/main" xmlns:p="http://schemas.openxmlformats.org/presentationml/2006/main" xmlns:r="http://schemas.openxmlformats.org/officeDocument/2006/relationships">
-  <p:cSld>
-    <p:bg>
-      <p:bgPr>
-        <a:solidFill>
-          <a:srgbClr val="FFFFFF"/>
-        </a:solidFill>
-        <a:effectLst/>
-      </p:bgPr>
-    </p:bg>
-    <p:spTree>
-      <p:nvGrpSpPr>
-        <p:cNvPr id="1" name=""/>
-        <p:cNvGrpSpPr/>
-        <p:nvPr/>
-      </p:nvGrpSpPr>
-      <p:grpSpPr/>
-      <p:sp>
-        <p:nvSpPr>
-          <p:cNvPr id="2" name="Text 0"/>
-          <p:cNvSpPr txBox="1"/>
-          <p:nvPr/>
-        </p:nvSpPr>
-        <p:spPr>
-          <a:xfrm>
-            <a:off x="594360" y="182880"/>
-            <a:ext cx="10972800" cy="219456"/>
-          </a:xfrm>
-          <a:prstGeom prst="rect">
-            <a:avLst/>
-          </a:prstGeom>
-          <a:noFill/>
-        </p:spPr>
-        <p:txBody>
-          <a:bodyPr wrap="square" anchor="ctr" lIns="0" rIns="0" tIns="0" bIns="0">
-            <a:spAutoFit/>
-          </a:bodyPr>
-          <a:lstStyle/>
-          <a:p>
-            <a:r>
-              <a:rPr sz="1050" b="1" spc="160">
-                <a:solidFill>
-                  <a:srgbClr val="0E7C86"/>
-                </a:solidFill>
-                <a:latin typeface="Calibri"/>
-              </a:rPr>
-              <a:t>AVEC QUOI NOUS AVONS TRAVAILLÉ</a:t>
-            </a:r>
-          </a:p>
-        </p:txBody>
-      </p:sp>
-      <p:sp>
-        <p:nvSpPr>
-          <p:cNvPr id="3" name="Text 1"/>
-          <p:cNvSpPr txBox="1"/>
-          <p:nvPr/>
-        </p:nvSpPr>
-        <p:spPr>
-          <a:xfrm>
-            <a:off x="594360" y="384048"/>
-            <a:ext cx="10972800" cy="658368"/>
-          </a:xfrm>
-          <a:prstGeom prst="rect">
-            <a:avLst/>
-          </a:prstGeom>
-          <a:noFill/>
-        </p:spPr>
-        <p:txBody>
-          <a:bodyPr wrap="square" anchor="ctr" lIns="0" rIns="0" tIns="0" bIns="0">
-            <a:spAutoFit/>
-          </a:bodyPr>
-          <a:lstStyle/>
-          <a:p>
-            <a:r>
-              <a:rPr sz="2700" b="1">
-                <a:solidFill>
-                  <a:srgbClr val="16232B"/>
-                </a:solidFill>
-                <a:latin typeface="Cambria"/>
-              </a:rPr>
-              <a:t>Quatre bibliothèques, un choix assumé pour chacune</a:t>
-            </a:r>
-          </a:p>
-        </p:txBody>
-      </p:sp>
-      <p:sp>
-        <p:nvSpPr>
-          <p:cNvPr id="4" name="Shape 0"/>
-          <p:cNvSpPr/>
-          <p:nvPr/>
-        </p:nvSpPr>
-        <p:spPr>
-          <a:xfrm>
-            <a:off x="594360" y="1554480"/>
-            <a:ext cx="5358384" cy="1325880"/>
-          </a:xfrm>
-          <a:prstGeom prst="roundRect">
-            <a:avLst>
-              <a:gd name="adj" fmla="val 3077"/>
-            </a:avLst>
-          </a:prstGeom>
-          <a:solidFill>
-            <a:srgbClr val="EAF3F4"/>
-          </a:solidFill>
-          <a:ln w="12700">
-            <a:solidFill>
-              <a:srgbClr val="D3E5E7"/>
-            </a:solidFill>
-          </a:ln>
-          <a:effectLst/>
-        </p:spPr>
-        <p:style>
-          <a:lnRef idx="1">
-            <a:schemeClr val="accent1"/>
-          </a:lnRef>
-          <a:fillRef idx="3">
-            <a:schemeClr val="accent1"/>
-          </a:fillRef>
-          <a:effectRef idx="2">
-            <a:schemeClr val="accent1"/>
-          </a:effectRef>
-          <a:fontRef idx="minor">
-            <a:schemeClr val="lt1"/>
-          </a:fontRef>
-        </p:style>
-        <p:txBody>
-          <a:bodyPr rtlCol="0" anchor="ctr"/>
-          <a:lstStyle/>
-          <a:p>
-            <a:pPr algn="ctr"/>
-          </a:p>
-        </p:txBody>
-      </p:sp>
-      <p:sp>
-        <p:nvSpPr>
-          <p:cNvPr id="5" name="Text 2"/>
-          <p:cNvSpPr txBox="1"/>
-          <p:nvPr/>
-        </p:nvSpPr>
-        <p:spPr>
-          <a:xfrm>
-            <a:off x="868680" y="1737360"/>
-            <a:ext cx="4809744" cy="365760"/>
-          </a:xfrm>
-          <a:prstGeom prst="rect">
-            <a:avLst/>
-          </a:prstGeom>
-          <a:noFill/>
-        </p:spPr>
-        <p:txBody>
-          <a:bodyPr wrap="square" anchor="t" lIns="0" rIns="0" tIns="0" bIns="0">
-            <a:spAutoFit/>
-          </a:bodyPr>
-          <a:lstStyle/>
-          <a:p>
-            <a:r>
-              <a:rPr sz="1800" b="1">
-                <a:solidFill>
-                  <a:srgbClr val="0E7C86"/>
-                </a:solidFill>
-                <a:latin typeface="Cambria"/>
-              </a:rPr>
-              <a:t>pandas</a:t>
-            </a:r>
-            <a:r>
-              <a:rPr sz="1050" b="0">
-                <a:solidFill>
-                  <a:srgbClr val="5D6B75"/>
-                </a:solidFill>
-                <a:latin typeface="Calibri"/>
-              </a:rPr>
-              <a:t>   3.0</a:t>
-            </a:r>
-          </a:p>
-        </p:txBody>
-      </p:sp>
-      <p:sp>
-        <p:nvSpPr>
-          <p:cNvPr id="6" name="Text 3"/>
-          <p:cNvSpPr txBox="1"/>
-          <p:nvPr/>
-        </p:nvSpPr>
-        <p:spPr>
-          <a:xfrm>
-            <a:off x="868680" y="2231136"/>
-            <a:ext cx="4809744" cy="411479"/>
-          </a:xfrm>
-          <a:prstGeom prst="rect">
-            <a:avLst/>
-          </a:prstGeom>
-          <a:noFill/>
-        </p:spPr>
-        <p:txBody>
-          <a:bodyPr wrap="square" anchor="t" lIns="0" rIns="0" tIns="0" bIns="0">
-            <a:spAutoFit/>
-          </a:bodyPr>
-          <a:lstStyle/>
-          <a:p>
-            <a:pPr>
-              <a:lnSpc>
-                <a:spcPct val="118000"/>
-              </a:lnSpc>
-            </a:pPr>
-            <a:r>
-              <a:rPr sz="1250" b="0">
-                <a:solidFill>
-                  <a:srgbClr val="5D6B75"/>
-                </a:solidFill>
-                <a:latin typeface="Calibri"/>
-              </a:rPr>
-              <a:t>Manipuler 32 millions de lignes. Jointures et regroupements natifs, exécutés en C. Polars irait plus vite ; pandas est le standard.</a:t>
-            </a:r>
-          </a:p>
-        </p:txBody>
-      </p:sp>
-      <p:sp>
-        <p:nvSpPr>
-          <p:cNvPr id="7" name="Shape 1"/>
-          <p:cNvSpPr/>
-          <p:nvPr/>
-        </p:nvSpPr>
-        <p:spPr>
-          <a:xfrm>
-            <a:off x="6236208" y="1554480"/>
-            <a:ext cx="5358384" cy="1325880"/>
-          </a:xfrm>
-          <a:prstGeom prst="roundRect">
-            <a:avLst>
-              <a:gd name="adj" fmla="val 3077"/>
-            </a:avLst>
-          </a:prstGeom>
-          <a:solidFill>
-            <a:srgbClr val="EAF3F4"/>
-          </a:solidFill>
-          <a:ln w="12700">
-            <a:solidFill>
-              <a:srgbClr val="D3E5E7"/>
-            </a:solidFill>
-          </a:ln>
-          <a:effectLst/>
-        </p:spPr>
-        <p:style>
-          <a:lnRef idx="1">
-            <a:schemeClr val="accent1"/>
-          </a:lnRef>
-          <a:fillRef idx="3">
-            <a:schemeClr val="accent1"/>
-          </a:fillRef>
-          <a:effectRef idx="2">
-            <a:schemeClr val="accent1"/>
-          </a:effectRef>
-          <a:fontRef idx="minor">
-            <a:schemeClr val="lt1"/>
-          </a:fontRef>
-        </p:style>
-        <p:txBody>
-          <a:bodyPr rtlCol="0" anchor="ctr"/>
-          <a:lstStyle/>
-          <a:p>
-            <a:pPr algn="ctr"/>
-          </a:p>
-        </p:txBody>
-      </p:sp>
-      <p:sp>
-        <p:nvSpPr>
-          <p:cNvPr id="8" name="Text 4"/>
-          <p:cNvSpPr txBox="1"/>
-          <p:nvPr/>
-        </p:nvSpPr>
-        <p:spPr>
-          <a:xfrm>
-            <a:off x="6510528" y="1737360"/>
-            <a:ext cx="4809744" cy="365760"/>
-          </a:xfrm>
-          <a:prstGeom prst="rect">
-            <a:avLst/>
-          </a:prstGeom>
-          <a:noFill/>
-        </p:spPr>
-        <p:txBody>
-          <a:bodyPr wrap="square" anchor="t" lIns="0" rIns="0" tIns="0" bIns="0">
-            <a:spAutoFit/>
-          </a:bodyPr>
-          <a:lstStyle/>
-          <a:p>
-            <a:r>
-              <a:rPr sz="1800" b="1">
-                <a:solidFill>
-                  <a:srgbClr val="0E7C86"/>
-                </a:solidFill>
-                <a:latin typeface="Cambria"/>
-              </a:rPr>
-              <a:t>NumPy</a:t>
-            </a:r>
-            <a:r>
-              <a:rPr sz="1050" b="0">
-                <a:solidFill>
-                  <a:srgbClr val="5D6B75"/>
-                </a:solidFill>
-                <a:latin typeface="Calibri"/>
-              </a:rPr>
-              <a:t>   2.5</a:t>
-            </a:r>
-          </a:p>
-        </p:txBody>
-      </p:sp>
-      <p:sp>
-        <p:nvSpPr>
-          <p:cNvPr id="9" name="Text 5"/>
-          <p:cNvSpPr txBox="1"/>
-          <p:nvPr/>
-        </p:nvSpPr>
-        <p:spPr>
-          <a:xfrm>
-            <a:off x="6510528" y="2231136"/>
-            <a:ext cx="4809744" cy="411479"/>
-          </a:xfrm>
-          <a:prstGeom prst="rect">
-            <a:avLst/>
-          </a:prstGeom>
-          <a:noFill/>
-        </p:spPr>
-        <p:txBody>
-          <a:bodyPr wrap="square" anchor="t" lIns="0" rIns="0" tIns="0" bIns="0">
-            <a:spAutoFit/>
-          </a:bodyPr>
-          <a:lstStyle/>
-          <a:p>
-            <a:pPr>
-              <a:lnSpc>
-                <a:spcPct val="118000"/>
-              </a:lnSpc>
-            </a:pPr>
-            <a:r>
-              <a:rPr sz="1250" b="0">
-                <a:solidFill>
-                  <a:srgbClr val="5D6B75"/>
-                </a:solidFill>
-                <a:latin typeface="Calibri"/>
-              </a:rPr>
-              <a:t>Le calcul vectorisé sur lequel pandas repose. Et la graine aléatoire qui rend l'exécution reproductible.</a:t>
-            </a:r>
-          </a:p>
-        </p:txBody>
-      </p:sp>
-      <p:sp>
-        <p:nvSpPr>
-          <p:cNvPr id="10" name="Shape 2"/>
-          <p:cNvSpPr/>
-          <p:nvPr/>
-        </p:nvSpPr>
-        <p:spPr>
-          <a:xfrm>
-            <a:off x="594360" y="3035808"/>
-            <a:ext cx="5358384" cy="1325880"/>
-          </a:xfrm>
-          <a:prstGeom prst="roundRect">
-            <a:avLst>
-              <a:gd name="adj" fmla="val 3077"/>
-            </a:avLst>
-          </a:prstGeom>
-          <a:solidFill>
-            <a:srgbClr val="EAF3F4"/>
-          </a:solidFill>
-          <a:ln w="12700">
-            <a:solidFill>
-              <a:srgbClr val="D3E5E7"/>
-            </a:solidFill>
-          </a:ln>
-          <a:effectLst/>
-        </p:spPr>
-        <p:style>
-          <a:lnRef idx="1">
-            <a:schemeClr val="accent1"/>
-          </a:lnRef>
-          <a:fillRef idx="3">
-            <a:schemeClr val="accent1"/>
-          </a:fillRef>
-          <a:effectRef idx="2">
-            <a:schemeClr val="accent1"/>
-          </a:effectRef>
-          <a:fontRef idx="minor">
-            <a:schemeClr val="lt1"/>
-          </a:fontRef>
-        </p:style>
-        <p:txBody>
-          <a:bodyPr rtlCol="0" anchor="ctr"/>
-          <a:lstStyle/>
-          <a:p>
-            <a:pPr algn="ctr"/>
-          </a:p>
-        </p:txBody>
-      </p:sp>
-      <p:sp>
-        <p:nvSpPr>
-          <p:cNvPr id="11" name="Text 6"/>
-          <p:cNvSpPr txBox="1"/>
-          <p:nvPr/>
-        </p:nvSpPr>
-        <p:spPr>
-          <a:xfrm>
-            <a:off x="868680" y="3218688"/>
-            <a:ext cx="4809744" cy="365760"/>
-          </a:xfrm>
-          <a:prstGeom prst="rect">
-            <a:avLst/>
-          </a:prstGeom>
-          <a:noFill/>
-        </p:spPr>
-        <p:txBody>
-          <a:bodyPr wrap="square" anchor="t" lIns="0" rIns="0" tIns="0" bIns="0">
-            <a:spAutoFit/>
-          </a:bodyPr>
-          <a:lstStyle/>
-          <a:p>
-            <a:r>
-              <a:rPr sz="1800" b="1">
-                <a:solidFill>
-                  <a:srgbClr val="0E7C86"/>
-                </a:solidFill>
-                <a:latin typeface="Cambria"/>
-              </a:rPr>
-              <a:t>Matplotlib</a:t>
-            </a:r>
-            <a:r>
-              <a:rPr sz="1050" b="0">
-                <a:solidFill>
-                  <a:srgbClr val="5D6B75"/>
-                </a:solidFill>
-                <a:latin typeface="Calibri"/>
-              </a:rPr>
-              <a:t>   3.11</a:t>
-            </a:r>
-          </a:p>
-        </p:txBody>
-      </p:sp>
-      <p:sp>
-        <p:nvSpPr>
-          <p:cNvPr id="12" name="Text 7"/>
-          <p:cNvSpPr txBox="1"/>
-          <p:nvPr/>
-        </p:nvSpPr>
-        <p:spPr>
-          <a:xfrm>
-            <a:off x="868680" y="3712463"/>
-            <a:ext cx="4809744" cy="411479"/>
-          </a:xfrm>
-          <a:prstGeom prst="rect">
-            <a:avLst/>
-          </a:prstGeom>
-          <a:noFill/>
-        </p:spPr>
-        <p:txBody>
-          <a:bodyPr wrap="square" anchor="t" lIns="0" rIns="0" tIns="0" bIns="0">
-            <a:spAutoFit/>
-          </a:bodyPr>
-          <a:lstStyle/>
-          <a:p>
-            <a:pPr>
-              <a:lnSpc>
-                <a:spcPct val="118000"/>
-              </a:lnSpc>
-            </a:pPr>
-            <a:r>
-              <a:rPr sz="1250" b="0">
-                <a:solidFill>
-                  <a:srgbClr val="5D6B75"/>
-                </a:solidFill>
-                <a:latin typeface="Calibri"/>
-              </a:rPr>
-              <a:t>Les dix graphiques. Moins commode que Seaborn, mais le contrôle sur chaque élément — donc sur chaque ornement retiré.</a:t>
-            </a:r>
-          </a:p>
-        </p:txBody>
-      </p:sp>
-      <p:sp>
-        <p:nvSpPr>
-          <p:cNvPr id="13" name="Shape 3"/>
-          <p:cNvSpPr/>
-          <p:nvPr/>
-        </p:nvSpPr>
-        <p:spPr>
-          <a:xfrm>
-            <a:off x="6236208" y="3035808"/>
-            <a:ext cx="5358384" cy="1325880"/>
-          </a:xfrm>
-          <a:prstGeom prst="roundRect">
-            <a:avLst>
-              <a:gd name="adj" fmla="val 3077"/>
-            </a:avLst>
-          </a:prstGeom>
-          <a:solidFill>
-            <a:srgbClr val="EAF3F4"/>
-          </a:solidFill>
-          <a:ln w="12700">
-            <a:solidFill>
-              <a:srgbClr val="D3E5E7"/>
-            </a:solidFill>
-          </a:ln>
-          <a:effectLst/>
-        </p:spPr>
-        <p:style>
-          <a:lnRef idx="1">
-            <a:schemeClr val="accent1"/>
-          </a:lnRef>
-          <a:fillRef idx="3">
-            <a:schemeClr val="accent1"/>
-          </a:fillRef>
-          <a:effectRef idx="2">
-            <a:schemeClr val="accent1"/>
-          </a:effectRef>
-          <a:fontRef idx="minor">
-            <a:schemeClr val="lt1"/>
-          </a:fontRef>
-        </p:style>
-        <p:txBody>
-          <a:bodyPr rtlCol="0" anchor="ctr"/>
-          <a:lstStyle/>
-          <a:p>
-            <a:pPr algn="ctr"/>
-          </a:p>
-        </p:txBody>
-      </p:sp>
-      <p:sp>
-        <p:nvSpPr>
-          <p:cNvPr id="14" name="Text 8"/>
-          <p:cNvSpPr txBox="1"/>
-          <p:nvPr/>
-        </p:nvSpPr>
-        <p:spPr>
-          <a:xfrm>
-            <a:off x="6510528" y="3218688"/>
-            <a:ext cx="4809744" cy="365760"/>
-          </a:xfrm>
-          <a:prstGeom prst="rect">
-            <a:avLst/>
-          </a:prstGeom>
-          <a:noFill/>
-        </p:spPr>
-        <p:txBody>
-          <a:bodyPr wrap="square" anchor="t" lIns="0" rIns="0" tIns="0" bIns="0">
-            <a:spAutoFit/>
-          </a:bodyPr>
-          <a:lstStyle/>
-          <a:p>
-            <a:r>
-              <a:rPr sz="1800" b="1">
-                <a:solidFill>
-                  <a:srgbClr val="0E7C86"/>
-                </a:solidFill>
-                <a:latin typeface="Cambria"/>
-              </a:rPr>
-              <a:t>scikit-learn</a:t>
-            </a:r>
-            <a:r>
-              <a:rPr sz="1050" b="0">
-                <a:solidFill>
-                  <a:srgbClr val="5D6B75"/>
-                </a:solidFill>
-                <a:latin typeface="Calibri"/>
-              </a:rPr>
-              <a:t>   1.9</a:t>
-            </a:r>
-          </a:p>
-        </p:txBody>
-      </p:sp>
-      <p:sp>
-        <p:nvSpPr>
-          <p:cNvPr id="15" name="Text 9"/>
-          <p:cNvSpPr txBox="1"/>
-          <p:nvPr/>
-        </p:nvSpPr>
-        <p:spPr>
-          <a:xfrm>
-            <a:off x="6510528" y="3712463"/>
-            <a:ext cx="4809744" cy="411479"/>
-          </a:xfrm>
-          <a:prstGeom prst="rect">
-            <a:avLst/>
-          </a:prstGeom>
-          <a:noFill/>
-        </p:spPr>
-        <p:txBody>
-          <a:bodyPr wrap="square" anchor="t" lIns="0" rIns="0" tIns="0" bIns="0">
-            <a:spAutoFit/>
-          </a:bodyPr>
-          <a:lstStyle/>
-          <a:p>
-            <a:pPr>
-              <a:lnSpc>
-                <a:spcPct val="118000"/>
-              </a:lnSpc>
-            </a:pPr>
-            <a:r>
-              <a:rPr sz="1250" b="0">
-                <a:solidFill>
-                  <a:srgbClr val="5D6B75"/>
-                </a:solidFill>
-                <a:latin typeface="Calibri"/>
-              </a:rPr>
-              <a:t>Le modèle prédictif. Une seule interface </a:t>
-            </a:r>
-            <a:r>
-              <a:rPr sz="1250" b="1">
-                <a:solidFill>
-                  <a:srgbClr val="16232B"/>
-                </a:solidFill>
-                <a:latin typeface="Calibri"/>
-              </a:rPr>
-              <a:t>fit / predict</a:t>
-            </a:r>
-            <a:r>
-              <a:rPr sz="1250" b="0">
-                <a:solidFill>
-                  <a:srgbClr val="5D6B75"/>
-                </a:solidFill>
-                <a:latin typeface="Calibri"/>
-              </a:rPr>
-              <a:t> : comparer quatre algorithmes ne change qu'un nom.</a:t>
-            </a:r>
-          </a:p>
-        </p:txBody>
-      </p:sp>
-      <p:sp>
-        <p:nvSpPr>
-          <p:cNvPr id="16" name="Text 10"/>
-          <p:cNvSpPr txBox="1"/>
-          <p:nvPr/>
-        </p:nvSpPr>
-        <p:spPr>
-          <a:xfrm>
-            <a:off x="594360" y="4572000"/>
-            <a:ext cx="10972800" cy="640080"/>
-          </a:xfrm>
-          <a:prstGeom prst="rect">
-            <a:avLst/>
-          </a:prstGeom>
-          <a:noFill/>
-        </p:spPr>
-        <p:txBody>
-          <a:bodyPr wrap="square" anchor="ctr" lIns="0" rIns="0" tIns="0" bIns="0">
-            <a:spAutoFit/>
-          </a:bodyPr>
-          <a:lstStyle/>
-          <a:p>
-            <a:pPr>
-              <a:lnSpc>
-                <a:spcPct val="120000"/>
-              </a:lnSpc>
-            </a:pPr>
-            <a:r>
-              <a:rPr sz="1350" b="0">
-                <a:solidFill>
-                  <a:srgbClr val="5D6B75"/>
-                </a:solidFill>
-                <a:latin typeface="Calibri"/>
-              </a:rPr>
-              <a:t>Versions figées dans </a:t>
-            </a:r>
-            <a:r>
-              <a:rPr sz="1300" b="0">
-                <a:solidFill>
-                  <a:srgbClr val="16232B"/>
-                </a:solidFill>
-                <a:latin typeface="Consolas"/>
-              </a:rPr>
-              <a:t>requirements.txt</a:t>
-            </a:r>
-            <a:r>
-              <a:rPr sz="1350" b="0">
-                <a:solidFill>
-                  <a:srgbClr val="5D6B75"/>
-                </a:solidFill>
-                <a:latin typeface="Calibri"/>
-              </a:rPr>
-              <a:t>. Les types compacts imposés à pandas ramènent la mémoire de 3,2 Go à 1,0 Go.</a:t>
-            </a:r>
           </a:p>
         </p:txBody>
       </p:sp>
@@ -5686,6 +5325,796 @@
 
 <file path=ppt/slides/slide3.xml><?xml version="1.0" encoding="utf-8"?>
 <p:sld xmlns:a="http://schemas.openxmlformats.org/drawingml/2006/main" xmlns:r="http://schemas.openxmlformats.org/officeDocument/2006/relationships" xmlns:p="http://schemas.openxmlformats.org/presentationml/2006/main">
+  <p:cSld>
+    <p:bg>
+      <p:bgPr>
+        <a:solidFill>
+          <a:srgbClr val="FFFFFF"/>
+        </a:solidFill>
+        <a:effectLst/>
+      </p:bgPr>
+    </p:bg>
+    <p:spTree>
+      <p:nvGrpSpPr>
+        <p:cNvPr id="1" name=""/>
+        <p:cNvGrpSpPr/>
+        <p:nvPr/>
+      </p:nvGrpSpPr>
+      <p:grpSpPr>
+        <a:xfrm>
+          <a:off x="0" y="0"/>
+          <a:ext cx="0" cy="0"/>
+          <a:chOff x="0" y="0"/>
+          <a:chExt cx="0" cy="0"/>
+        </a:xfrm>
+      </p:grpSpPr>
+      <p:sp>
+        <p:nvSpPr>
+          <p:cNvPr id="2" name="Text 0"/>
+          <p:cNvSpPr txBox="1"/>
+          <p:nvPr/>
+        </p:nvSpPr>
+        <p:spPr>
+          <a:xfrm>
+            <a:off x="594360" y="182880"/>
+            <a:ext cx="10972800" cy="219456"/>
+          </a:xfrm>
+          <a:prstGeom prst="rect">
+            <a:avLst/>
+          </a:prstGeom>
+          <a:noFill/>
+        </p:spPr>
+        <p:txBody>
+          <a:bodyPr wrap="square" lIns="0" tIns="0" rIns="0" bIns="0" anchor="ctr">
+            <a:spAutoFit/>
+          </a:bodyPr>
+          <a:lstStyle/>
+          <a:p>
+            <a:r>
+              <a:rPr sz="1050" b="1" spc="160">
+                <a:solidFill>
+                  <a:srgbClr val="0E7C86"/>
+                </a:solidFill>
+                <a:latin typeface="Calibri"/>
+              </a:rPr>
+              <a:t>AVEC QUOI NOUS AVONS TRAVAILLÉ</a:t>
+            </a:r>
+          </a:p>
+        </p:txBody>
+      </p:sp>
+      <p:sp>
+        <p:nvSpPr>
+          <p:cNvPr id="3" name="Text 1"/>
+          <p:cNvSpPr txBox="1"/>
+          <p:nvPr/>
+        </p:nvSpPr>
+        <p:spPr>
+          <a:xfrm>
+            <a:off x="594360" y="384048"/>
+            <a:ext cx="10972800" cy="658368"/>
+          </a:xfrm>
+          <a:prstGeom prst="rect">
+            <a:avLst/>
+          </a:prstGeom>
+          <a:noFill/>
+        </p:spPr>
+        <p:txBody>
+          <a:bodyPr wrap="square" lIns="0" tIns="0" rIns="0" bIns="0" anchor="ctr">
+            <a:spAutoFit/>
+          </a:bodyPr>
+          <a:lstStyle/>
+          <a:p>
+            <a:r>
+              <a:rPr sz="2700" b="1">
+                <a:solidFill>
+                  <a:srgbClr val="16232B"/>
+                </a:solidFill>
+                <a:latin typeface="Cambria"/>
+              </a:rPr>
+              <a:t>Quatre bibliothèques, un choix assumé pour chacune</a:t>
+            </a:r>
+          </a:p>
+        </p:txBody>
+      </p:sp>
+      <p:sp>
+        <p:nvSpPr>
+          <p:cNvPr id="4" name="Shape 0"/>
+          <p:cNvSpPr/>
+          <p:nvPr/>
+        </p:nvSpPr>
+        <p:spPr>
+          <a:xfrm>
+            <a:off x="594360" y="1554480"/>
+            <a:ext cx="5358384" cy="1325880"/>
+          </a:xfrm>
+          <a:prstGeom prst="roundRect">
+            <a:avLst>
+              <a:gd name="adj" fmla="val 3077"/>
+            </a:avLst>
+          </a:prstGeom>
+          <a:solidFill>
+            <a:srgbClr val="EAF3F4"/>
+          </a:solidFill>
+          <a:ln w="12700">
+            <a:solidFill>
+              <a:srgbClr val="D3E5E7"/>
+            </a:solidFill>
+          </a:ln>
+          <a:effectLst/>
+        </p:spPr>
+        <p:style>
+          <a:lnRef idx="1">
+            <a:schemeClr val="accent1"/>
+          </a:lnRef>
+          <a:fillRef idx="3">
+            <a:schemeClr val="accent1"/>
+          </a:fillRef>
+          <a:effectRef idx="2">
+            <a:schemeClr val="accent1"/>
+          </a:effectRef>
+          <a:fontRef idx="minor">
+            <a:schemeClr val="lt1"/>
+          </a:fontRef>
+        </p:style>
+        <p:txBody>
+          <a:bodyPr rtlCol="0" anchor="ctr"/>
+          <a:lstStyle/>
+          <a:p>
+            <a:pPr algn="ctr"/>
+            <a:endParaRPr/>
+          </a:p>
+        </p:txBody>
+      </p:sp>
+      <p:sp>
+        <p:nvSpPr>
+          <p:cNvPr id="5" name="Text 2"/>
+          <p:cNvSpPr txBox="1"/>
+          <p:nvPr/>
+        </p:nvSpPr>
+        <p:spPr>
+          <a:xfrm>
+            <a:off x="868680" y="1737360"/>
+            <a:ext cx="4809744" cy="365760"/>
+          </a:xfrm>
+          <a:prstGeom prst="rect">
+            <a:avLst/>
+          </a:prstGeom>
+          <a:noFill/>
+        </p:spPr>
+        <p:txBody>
+          <a:bodyPr wrap="square" lIns="0" tIns="0" rIns="0" bIns="0" anchor="t">
+            <a:spAutoFit/>
+          </a:bodyPr>
+          <a:lstStyle/>
+          <a:p>
+            <a:r>
+              <a:rPr sz="1800" b="1">
+                <a:solidFill>
+                  <a:srgbClr val="0E7C86"/>
+                </a:solidFill>
+                <a:latin typeface="Cambria"/>
+              </a:rPr>
+              <a:t>pandas</a:t>
+            </a:r>
+            <a:r>
+              <a:rPr sz="1050" b="0">
+                <a:solidFill>
+                  <a:srgbClr val="5D6B75"/>
+                </a:solidFill>
+                <a:latin typeface="Calibri"/>
+              </a:rPr>
+              <a:t>   3.0</a:t>
+            </a:r>
+          </a:p>
+        </p:txBody>
+      </p:sp>
+      <p:sp>
+        <p:nvSpPr>
+          <p:cNvPr id="6" name="Text 3"/>
+          <p:cNvSpPr txBox="1"/>
+          <p:nvPr/>
+        </p:nvSpPr>
+        <p:spPr>
+          <a:xfrm>
+            <a:off x="868680" y="2231136"/>
+            <a:ext cx="4809744" cy="411479"/>
+          </a:xfrm>
+          <a:prstGeom prst="rect">
+            <a:avLst/>
+          </a:prstGeom>
+          <a:noFill/>
+        </p:spPr>
+        <p:txBody>
+          <a:bodyPr wrap="square" lIns="0" tIns="0" rIns="0" bIns="0" anchor="t">
+            <a:spAutoFit/>
+          </a:bodyPr>
+          <a:lstStyle/>
+          <a:p>
+            <a:pPr>
+              <a:lnSpc>
+                <a:spcPct val="118000"/>
+              </a:lnSpc>
+            </a:pPr>
+            <a:r>
+              <a:rPr sz="1250" b="0">
+                <a:solidFill>
+                  <a:srgbClr val="5D6B75"/>
+                </a:solidFill>
+                <a:latin typeface="Calibri"/>
+              </a:rPr>
+              <a:t>Manipuler 32 millions de lignes. Jointures et regroupements natifs, exécutés en C. Polars irait plus vite ; pandas est le standard.</a:t>
+            </a:r>
+          </a:p>
+        </p:txBody>
+      </p:sp>
+      <p:sp>
+        <p:nvSpPr>
+          <p:cNvPr id="7" name="Shape 1"/>
+          <p:cNvSpPr/>
+          <p:nvPr/>
+        </p:nvSpPr>
+        <p:spPr>
+          <a:xfrm>
+            <a:off x="6236208" y="1554480"/>
+            <a:ext cx="5358384" cy="1325880"/>
+          </a:xfrm>
+          <a:prstGeom prst="roundRect">
+            <a:avLst>
+              <a:gd name="adj" fmla="val 3077"/>
+            </a:avLst>
+          </a:prstGeom>
+          <a:solidFill>
+            <a:srgbClr val="EAF3F4"/>
+          </a:solidFill>
+          <a:ln w="12700">
+            <a:solidFill>
+              <a:srgbClr val="D3E5E7"/>
+            </a:solidFill>
+          </a:ln>
+          <a:effectLst/>
+        </p:spPr>
+        <p:style>
+          <a:lnRef idx="1">
+            <a:schemeClr val="accent1"/>
+          </a:lnRef>
+          <a:fillRef idx="3">
+            <a:schemeClr val="accent1"/>
+          </a:fillRef>
+          <a:effectRef idx="2">
+            <a:schemeClr val="accent1"/>
+          </a:effectRef>
+          <a:fontRef idx="minor">
+            <a:schemeClr val="lt1"/>
+          </a:fontRef>
+        </p:style>
+        <p:txBody>
+          <a:bodyPr rtlCol="0" anchor="ctr"/>
+          <a:lstStyle/>
+          <a:p>
+            <a:pPr algn="ctr"/>
+            <a:endParaRPr/>
+          </a:p>
+        </p:txBody>
+      </p:sp>
+      <p:sp>
+        <p:nvSpPr>
+          <p:cNvPr id="8" name="Text 4"/>
+          <p:cNvSpPr txBox="1"/>
+          <p:nvPr/>
+        </p:nvSpPr>
+        <p:spPr>
+          <a:xfrm>
+            <a:off x="6510528" y="1737360"/>
+            <a:ext cx="4809744" cy="365760"/>
+          </a:xfrm>
+          <a:prstGeom prst="rect">
+            <a:avLst/>
+          </a:prstGeom>
+          <a:noFill/>
+        </p:spPr>
+        <p:txBody>
+          <a:bodyPr wrap="square" lIns="0" tIns="0" rIns="0" bIns="0" anchor="t">
+            <a:spAutoFit/>
+          </a:bodyPr>
+          <a:lstStyle/>
+          <a:p>
+            <a:r>
+              <a:rPr sz="1800" b="1" dirty="0">
+                <a:solidFill>
+                  <a:srgbClr val="0E7C86"/>
+                </a:solidFill>
+                <a:latin typeface="Cambria"/>
+              </a:rPr>
+              <a:t>NumPy</a:t>
+            </a:r>
+            <a:r>
+              <a:rPr sz="1050" b="0" dirty="0">
+                <a:solidFill>
+                  <a:srgbClr val="5D6B75"/>
+                </a:solidFill>
+                <a:latin typeface="Calibri"/>
+              </a:rPr>
+              <a:t>   2.5</a:t>
+            </a:r>
+          </a:p>
+        </p:txBody>
+      </p:sp>
+      <p:sp>
+        <p:nvSpPr>
+          <p:cNvPr id="9" name="Text 5"/>
+          <p:cNvSpPr txBox="1"/>
+          <p:nvPr/>
+        </p:nvSpPr>
+        <p:spPr>
+          <a:xfrm>
+            <a:off x="6510528" y="2231136"/>
+            <a:ext cx="4809744" cy="411479"/>
+          </a:xfrm>
+          <a:prstGeom prst="rect">
+            <a:avLst/>
+          </a:prstGeom>
+          <a:noFill/>
+        </p:spPr>
+        <p:txBody>
+          <a:bodyPr wrap="square" lIns="0" tIns="0" rIns="0" bIns="0" anchor="t">
+            <a:spAutoFit/>
+          </a:bodyPr>
+          <a:lstStyle/>
+          <a:p>
+            <a:pPr>
+              <a:lnSpc>
+                <a:spcPct val="118000"/>
+              </a:lnSpc>
+            </a:pPr>
+            <a:r>
+              <a:rPr sz="1250" b="0" dirty="0">
+                <a:solidFill>
+                  <a:srgbClr val="5D6B75"/>
+                </a:solidFill>
+                <a:latin typeface="Calibri"/>
+              </a:rPr>
+              <a:t>Le </a:t>
+            </a:r>
+            <a:r>
+              <a:rPr sz="1250" b="0" dirty="0" err="1">
+                <a:solidFill>
+                  <a:srgbClr val="5D6B75"/>
+                </a:solidFill>
+                <a:latin typeface="Calibri"/>
+              </a:rPr>
+              <a:t>calcul</a:t>
+            </a:r>
+            <a:r>
+              <a:rPr sz="1250" b="0" dirty="0">
+                <a:solidFill>
+                  <a:srgbClr val="5D6B75"/>
+                </a:solidFill>
+                <a:latin typeface="Calibri"/>
+              </a:rPr>
+              <a:t> </a:t>
+            </a:r>
+            <a:r>
+              <a:rPr sz="1250" b="0" dirty="0" err="1">
+                <a:solidFill>
+                  <a:srgbClr val="5D6B75"/>
+                </a:solidFill>
+                <a:latin typeface="Calibri"/>
+              </a:rPr>
+              <a:t>vectorisé</a:t>
+            </a:r>
+            <a:r>
+              <a:rPr sz="1250" b="0" dirty="0">
+                <a:solidFill>
+                  <a:srgbClr val="5D6B75"/>
+                </a:solidFill>
+                <a:latin typeface="Calibri"/>
+              </a:rPr>
+              <a:t> sur </a:t>
+            </a:r>
+            <a:r>
+              <a:rPr sz="1250" b="0" dirty="0" err="1">
+                <a:solidFill>
+                  <a:srgbClr val="5D6B75"/>
+                </a:solidFill>
+                <a:latin typeface="Calibri"/>
+              </a:rPr>
+              <a:t>lequel</a:t>
+            </a:r>
+            <a:r>
+              <a:rPr sz="1250" b="0" dirty="0">
+                <a:solidFill>
+                  <a:srgbClr val="5D6B75"/>
+                </a:solidFill>
+                <a:latin typeface="Calibri"/>
+              </a:rPr>
+              <a:t> pandas repose. Et la graine </a:t>
+            </a:r>
+            <a:r>
+              <a:rPr sz="1250" b="0" dirty="0" err="1">
+                <a:solidFill>
+                  <a:srgbClr val="5D6B75"/>
+                </a:solidFill>
+                <a:latin typeface="Calibri"/>
+              </a:rPr>
+              <a:t>aléatoire</a:t>
+            </a:r>
+            <a:r>
+              <a:rPr sz="1250" b="0" dirty="0">
+                <a:solidFill>
+                  <a:srgbClr val="5D6B75"/>
+                </a:solidFill>
+                <a:latin typeface="Calibri"/>
+              </a:rPr>
+              <a:t> qui rend </a:t>
+            </a:r>
+            <a:r>
+              <a:rPr sz="1250" b="0" dirty="0" err="1">
+                <a:solidFill>
+                  <a:srgbClr val="5D6B75"/>
+                </a:solidFill>
+                <a:latin typeface="Calibri"/>
+              </a:rPr>
+              <a:t>l'exécution</a:t>
+            </a:r>
+            <a:r>
+              <a:rPr sz="1250" b="0" dirty="0">
+                <a:solidFill>
+                  <a:srgbClr val="5D6B75"/>
+                </a:solidFill>
+                <a:latin typeface="Calibri"/>
+              </a:rPr>
+              <a:t> reproductible.</a:t>
+            </a:r>
+          </a:p>
+        </p:txBody>
+      </p:sp>
+      <p:sp>
+        <p:nvSpPr>
+          <p:cNvPr id="10" name="Shape 2"/>
+          <p:cNvSpPr/>
+          <p:nvPr/>
+        </p:nvSpPr>
+        <p:spPr>
+          <a:xfrm>
+            <a:off x="594360" y="3035808"/>
+            <a:ext cx="5358384" cy="1325880"/>
+          </a:xfrm>
+          <a:prstGeom prst="roundRect">
+            <a:avLst>
+              <a:gd name="adj" fmla="val 3077"/>
+            </a:avLst>
+          </a:prstGeom>
+          <a:solidFill>
+            <a:srgbClr val="EAF3F4"/>
+          </a:solidFill>
+          <a:ln w="12700">
+            <a:solidFill>
+              <a:srgbClr val="D3E5E7"/>
+            </a:solidFill>
+          </a:ln>
+          <a:effectLst/>
+        </p:spPr>
+        <p:style>
+          <a:lnRef idx="1">
+            <a:schemeClr val="accent1"/>
+          </a:lnRef>
+          <a:fillRef idx="3">
+            <a:schemeClr val="accent1"/>
+          </a:fillRef>
+          <a:effectRef idx="2">
+            <a:schemeClr val="accent1"/>
+          </a:effectRef>
+          <a:fontRef idx="minor">
+            <a:schemeClr val="lt1"/>
+          </a:fontRef>
+        </p:style>
+        <p:txBody>
+          <a:bodyPr rtlCol="0" anchor="ctr"/>
+          <a:lstStyle/>
+          <a:p>
+            <a:pPr algn="ctr"/>
+            <a:endParaRPr/>
+          </a:p>
+        </p:txBody>
+      </p:sp>
+      <p:sp>
+        <p:nvSpPr>
+          <p:cNvPr id="11" name="Text 6"/>
+          <p:cNvSpPr txBox="1"/>
+          <p:nvPr/>
+        </p:nvSpPr>
+        <p:spPr>
+          <a:xfrm>
+            <a:off x="868680" y="3218688"/>
+            <a:ext cx="4809744" cy="365760"/>
+          </a:xfrm>
+          <a:prstGeom prst="rect">
+            <a:avLst/>
+          </a:prstGeom>
+          <a:noFill/>
+        </p:spPr>
+        <p:txBody>
+          <a:bodyPr wrap="square" lIns="0" tIns="0" rIns="0" bIns="0" anchor="t">
+            <a:spAutoFit/>
+          </a:bodyPr>
+          <a:lstStyle/>
+          <a:p>
+            <a:r>
+              <a:rPr sz="1800" b="1">
+                <a:solidFill>
+                  <a:srgbClr val="0E7C86"/>
+                </a:solidFill>
+                <a:latin typeface="Cambria"/>
+              </a:rPr>
+              <a:t>Matplotlib</a:t>
+            </a:r>
+            <a:r>
+              <a:rPr sz="1050" b="0">
+                <a:solidFill>
+                  <a:srgbClr val="5D6B75"/>
+                </a:solidFill>
+                <a:latin typeface="Calibri"/>
+              </a:rPr>
+              <a:t>   3.11</a:t>
+            </a:r>
+          </a:p>
+        </p:txBody>
+      </p:sp>
+      <p:sp>
+        <p:nvSpPr>
+          <p:cNvPr id="12" name="Text 7"/>
+          <p:cNvSpPr txBox="1"/>
+          <p:nvPr/>
+        </p:nvSpPr>
+        <p:spPr>
+          <a:xfrm>
+            <a:off x="868680" y="3712463"/>
+            <a:ext cx="4809744" cy="411479"/>
+          </a:xfrm>
+          <a:prstGeom prst="rect">
+            <a:avLst/>
+          </a:prstGeom>
+          <a:noFill/>
+        </p:spPr>
+        <p:txBody>
+          <a:bodyPr wrap="square" lIns="0" tIns="0" rIns="0" bIns="0" anchor="t">
+            <a:spAutoFit/>
+          </a:bodyPr>
+          <a:lstStyle/>
+          <a:p>
+            <a:pPr>
+              <a:lnSpc>
+                <a:spcPct val="118000"/>
+              </a:lnSpc>
+            </a:pPr>
+            <a:r>
+              <a:rPr sz="1250" b="0">
+                <a:solidFill>
+                  <a:srgbClr val="5D6B75"/>
+                </a:solidFill>
+                <a:latin typeface="Calibri"/>
+              </a:rPr>
+              <a:t>Les dix graphiques. Moins commode que Seaborn, mais le contrôle sur chaque élément — donc sur chaque ornement retiré.</a:t>
+            </a:r>
+          </a:p>
+        </p:txBody>
+      </p:sp>
+      <p:sp>
+        <p:nvSpPr>
+          <p:cNvPr id="13" name="Shape 3"/>
+          <p:cNvSpPr/>
+          <p:nvPr/>
+        </p:nvSpPr>
+        <p:spPr>
+          <a:xfrm>
+            <a:off x="6236208" y="3035808"/>
+            <a:ext cx="5358384" cy="1325880"/>
+          </a:xfrm>
+          <a:prstGeom prst="roundRect">
+            <a:avLst>
+              <a:gd name="adj" fmla="val 3077"/>
+            </a:avLst>
+          </a:prstGeom>
+          <a:solidFill>
+            <a:srgbClr val="EAF3F4"/>
+          </a:solidFill>
+          <a:ln w="12700">
+            <a:solidFill>
+              <a:srgbClr val="D3E5E7"/>
+            </a:solidFill>
+          </a:ln>
+          <a:effectLst/>
+        </p:spPr>
+        <p:style>
+          <a:lnRef idx="1">
+            <a:schemeClr val="accent1"/>
+          </a:lnRef>
+          <a:fillRef idx="3">
+            <a:schemeClr val="accent1"/>
+          </a:fillRef>
+          <a:effectRef idx="2">
+            <a:schemeClr val="accent1"/>
+          </a:effectRef>
+          <a:fontRef idx="minor">
+            <a:schemeClr val="lt1"/>
+          </a:fontRef>
+        </p:style>
+        <p:txBody>
+          <a:bodyPr rtlCol="0" anchor="ctr"/>
+          <a:lstStyle/>
+          <a:p>
+            <a:pPr algn="ctr"/>
+            <a:endParaRPr/>
+          </a:p>
+        </p:txBody>
+      </p:sp>
+      <p:sp>
+        <p:nvSpPr>
+          <p:cNvPr id="14" name="Text 8"/>
+          <p:cNvSpPr txBox="1"/>
+          <p:nvPr/>
+        </p:nvSpPr>
+        <p:spPr>
+          <a:xfrm>
+            <a:off x="6510528" y="3218688"/>
+            <a:ext cx="4809744" cy="365760"/>
+          </a:xfrm>
+          <a:prstGeom prst="rect">
+            <a:avLst/>
+          </a:prstGeom>
+          <a:noFill/>
+        </p:spPr>
+        <p:txBody>
+          <a:bodyPr wrap="square" lIns="0" tIns="0" rIns="0" bIns="0" anchor="t">
+            <a:spAutoFit/>
+          </a:bodyPr>
+          <a:lstStyle/>
+          <a:p>
+            <a:r>
+              <a:rPr sz="1800" b="1">
+                <a:solidFill>
+                  <a:srgbClr val="0E7C86"/>
+                </a:solidFill>
+                <a:latin typeface="Cambria"/>
+              </a:rPr>
+              <a:t>scikit-learn</a:t>
+            </a:r>
+            <a:r>
+              <a:rPr sz="1050" b="0">
+                <a:solidFill>
+                  <a:srgbClr val="5D6B75"/>
+                </a:solidFill>
+                <a:latin typeface="Calibri"/>
+              </a:rPr>
+              <a:t>   1.9</a:t>
+            </a:r>
+          </a:p>
+        </p:txBody>
+      </p:sp>
+      <p:sp>
+        <p:nvSpPr>
+          <p:cNvPr id="15" name="Text 9"/>
+          <p:cNvSpPr txBox="1"/>
+          <p:nvPr/>
+        </p:nvSpPr>
+        <p:spPr>
+          <a:xfrm>
+            <a:off x="6510528" y="3712463"/>
+            <a:ext cx="4809744" cy="411479"/>
+          </a:xfrm>
+          <a:prstGeom prst="rect">
+            <a:avLst/>
+          </a:prstGeom>
+          <a:noFill/>
+        </p:spPr>
+        <p:txBody>
+          <a:bodyPr wrap="square" lIns="0" tIns="0" rIns="0" bIns="0" anchor="t">
+            <a:spAutoFit/>
+          </a:bodyPr>
+          <a:lstStyle/>
+          <a:p>
+            <a:pPr>
+              <a:lnSpc>
+                <a:spcPct val="118000"/>
+              </a:lnSpc>
+            </a:pPr>
+            <a:r>
+              <a:rPr sz="1250" b="0">
+                <a:solidFill>
+                  <a:srgbClr val="5D6B75"/>
+                </a:solidFill>
+                <a:latin typeface="Calibri"/>
+              </a:rPr>
+              <a:t>Le modèle prédictif. Une seule interface </a:t>
+            </a:r>
+            <a:r>
+              <a:rPr sz="1250" b="1">
+                <a:solidFill>
+                  <a:srgbClr val="16232B"/>
+                </a:solidFill>
+                <a:latin typeface="Calibri"/>
+              </a:rPr>
+              <a:t>fit / predict</a:t>
+            </a:r>
+            <a:r>
+              <a:rPr sz="1250" b="0">
+                <a:solidFill>
+                  <a:srgbClr val="5D6B75"/>
+                </a:solidFill>
+                <a:latin typeface="Calibri"/>
+              </a:rPr>
+              <a:t> : comparer quatre algorithmes ne change qu'un nom.</a:t>
+            </a:r>
+          </a:p>
+        </p:txBody>
+      </p:sp>
+      <p:sp>
+        <p:nvSpPr>
+          <p:cNvPr id="16" name="Text 10"/>
+          <p:cNvSpPr txBox="1"/>
+          <p:nvPr/>
+        </p:nvSpPr>
+        <p:spPr>
+          <a:xfrm>
+            <a:off x="594360" y="4572000"/>
+            <a:ext cx="10972800" cy="640080"/>
+          </a:xfrm>
+          <a:prstGeom prst="rect">
+            <a:avLst/>
+          </a:prstGeom>
+          <a:noFill/>
+        </p:spPr>
+        <p:txBody>
+          <a:bodyPr wrap="square" lIns="0" tIns="0" rIns="0" bIns="0" anchor="ctr">
+            <a:spAutoFit/>
+          </a:bodyPr>
+          <a:lstStyle/>
+          <a:p>
+            <a:pPr>
+              <a:lnSpc>
+                <a:spcPct val="120000"/>
+              </a:lnSpc>
+            </a:pPr>
+            <a:r>
+              <a:rPr sz="1350" b="0">
+                <a:solidFill>
+                  <a:srgbClr val="5D6B75"/>
+                </a:solidFill>
+                <a:latin typeface="Calibri"/>
+              </a:rPr>
+              <a:t>Versions figées dans </a:t>
+            </a:r>
+            <a:r>
+              <a:rPr sz="1300" b="0">
+                <a:solidFill>
+                  <a:srgbClr val="16232B"/>
+                </a:solidFill>
+                <a:latin typeface="Consolas"/>
+              </a:rPr>
+              <a:t>requirements.txt</a:t>
+            </a:r>
+            <a:r>
+              <a:rPr sz="1350" b="0">
+                <a:solidFill>
+                  <a:srgbClr val="5D6B75"/>
+                </a:solidFill>
+                <a:latin typeface="Calibri"/>
+              </a:rPr>
+              <a:t>. Les types compacts imposés à pandas ramènent la mémoire de 3,2 Go à 1,0 Go.</a:t>
+            </a:r>
+          </a:p>
+        </p:txBody>
+      </p:sp>
+    </p:spTree>
+  </p:cSld>
+  <p:clrMapOvr>
+    <a:masterClrMapping/>
+  </p:clrMapOvr>
+</p:sld>
+</file>
+
+<file path=ppt/slides/slide4.xml><?xml version="1.0" encoding="utf-8"?>
+<p:sld xmlns:a="http://schemas.openxmlformats.org/drawingml/2006/main" xmlns:r="http://schemas.openxmlformats.org/officeDocument/2006/relationships" xmlns:p="http://schemas.openxmlformats.org/presentationml/2006/main">
   <p:cSld name="Slide 3">
     <p:bg>
       <p:bgPr>
@@ -5927,7 +6356,7 @@
 </p:sld>
 </file>
 
-<file path=ppt/slides/slide4.xml><?xml version="1.0" encoding="utf-8"?>
+<file path=ppt/slides/slide5.xml><?xml version="1.0" encoding="utf-8"?>
 <p:sld xmlns:a="http://schemas.openxmlformats.org/drawingml/2006/main" xmlns:r="http://schemas.openxmlformats.org/officeDocument/2006/relationships" xmlns:p="http://schemas.openxmlformats.org/presentationml/2006/main">
   <p:cSld name="Slide 4">
     <p:bg>
@@ -6255,7 +6684,7 @@
 </p:sld>
 </file>
 
-<file path=ppt/slides/slide5.xml><?xml version="1.0" encoding="utf-8"?>
+<file path=ppt/slides/slide6.xml><?xml version="1.0" encoding="utf-8"?>
 <p:sld xmlns:a="http://schemas.openxmlformats.org/drawingml/2006/main" xmlns:r="http://schemas.openxmlformats.org/officeDocument/2006/relationships" xmlns:p="http://schemas.openxmlformats.org/presentationml/2006/main">
   <p:cSld name="Slide 5">
     <p:bg>
@@ -6583,7 +7012,7 @@
 </p:sld>
 </file>
 
-<file path=ppt/slides/slide6.xml><?xml version="1.0" encoding="utf-8"?>
+<file path=ppt/slides/slide7.xml><?xml version="1.0" encoding="utf-8"?>
 <p:sld xmlns:a="http://schemas.openxmlformats.org/drawingml/2006/main" xmlns:r="http://schemas.openxmlformats.org/officeDocument/2006/relationships" xmlns:p="http://schemas.openxmlformats.org/presentationml/2006/main">
   <p:cSld name="Slide 6">
     <p:bg>
@@ -6911,7 +7340,7 @@
 </p:sld>
 </file>
 
-<file path=ppt/slides/slide7.xml><?xml version="1.0" encoding="utf-8"?>
+<file path=ppt/slides/slide8.xml><?xml version="1.0" encoding="utf-8"?>
 <p:sld xmlns:a="http://schemas.openxmlformats.org/drawingml/2006/main" xmlns:r="http://schemas.openxmlformats.org/officeDocument/2006/relationships" xmlns:p="http://schemas.openxmlformats.org/presentationml/2006/main">
   <p:cSld name="Slide 7">
     <p:bg>
@@ -7239,7 +7668,7 @@
 </p:sld>
 </file>
 
-<file path=ppt/slides/slide8.xml><?xml version="1.0" encoding="utf-8"?>
+<file path=ppt/slides/slide9.xml><?xml version="1.0" encoding="utf-8"?>
 <p:sld xmlns:a="http://schemas.openxmlformats.org/drawingml/2006/main" xmlns:r="http://schemas.openxmlformats.org/officeDocument/2006/relationships" xmlns:p="http://schemas.openxmlformats.org/presentationml/2006/main">
   <p:cSld name="Slide 8">
     <p:bg>
@@ -7554,334 +7983,6 @@
                 <a:cs typeface="Cambria" pitchFamily="34" charset="-120"/>
               </a:rPr>
               <a:t>5</a:t>
-            </a:r>
-            <a:endParaRPr lang="en-US" sz="3400" dirty="0"/>
-          </a:p>
-        </p:txBody>
-      </p:sp>
-    </p:spTree>
-  </p:cSld>
-  <p:clrMapOvr>
-    <a:masterClrMapping/>
-  </p:clrMapOvr>
-</p:sld>
-</file>
-
-<file path=ppt/slides/slide9.xml><?xml version="1.0" encoding="utf-8"?>
-<p:sld xmlns:a="http://schemas.openxmlformats.org/drawingml/2006/main" xmlns:r="http://schemas.openxmlformats.org/officeDocument/2006/relationships" xmlns:p="http://schemas.openxmlformats.org/presentationml/2006/main">
-  <p:cSld name="Slide 9">
-    <p:bg>
-      <p:bgPr>
-        <a:solidFill>
-          <a:srgbClr val="FFFFFF"/>
-        </a:solidFill>
-        <a:effectLst/>
-      </p:bgPr>
-    </p:bg>
-    <p:spTree>
-      <p:nvGrpSpPr>
-        <p:cNvPr id="1" name=""/>
-        <p:cNvGrpSpPr/>
-        <p:nvPr/>
-      </p:nvGrpSpPr>
-      <p:grpSpPr>
-        <a:xfrm>
-          <a:off x="0" y="0"/>
-          <a:ext cx="0" cy="0"/>
-          <a:chOff x="0" y="0"/>
-          <a:chExt cx="0" cy="0"/>
-        </a:xfrm>
-      </p:grpSpPr>
-      <p:sp>
-        <p:nvSpPr>
-          <p:cNvPr id="2" name="Text 0"/>
-          <p:cNvSpPr txBox="1"/>
-          <p:nvPr/>
-        </p:nvSpPr>
-        <p:spPr>
-          <a:xfrm>
-            <a:off x="594360" y="182880"/>
-            <a:ext cx="10972800" cy="219456"/>
-          </a:xfrm>
-          <a:prstGeom prst="rect">
-            <a:avLst/>
-          </a:prstGeom>
-          <a:noFill/>
-          <a:ln/>
-        </p:spPr>
-        <p:txBody>
-          <a:bodyPr wrap="square" lIns="0" tIns="0" rIns="0" bIns="0" rtlCol="0" anchor="ctr"/>
-          <a:lstStyle/>
-          <a:p>
-            <a:pPr marL="0" indent="0">
-              <a:buNone/>
-            </a:pPr>
-            <a:r>
-              <a:rPr lang="en-US" sz="1050" b="1" kern="0" spc="160" dirty="0">
-                <a:solidFill>
-                  <a:srgbClr val="0E7C86"/>
-                </a:solidFill>
-                <a:latin typeface="Calibri" pitchFamily="34" charset="0"/>
-                <a:ea typeface="Calibri" pitchFamily="34" charset="-122"/>
-                <a:cs typeface="Calibri" pitchFamily="34" charset="-120"/>
-              </a:rPr>
-              <a:t>DÉMONSTRATION 6</a:t>
-            </a:r>
-            <a:endParaRPr lang="en-US" sz="1050" dirty="0"/>
-          </a:p>
-        </p:txBody>
-      </p:sp>
-      <p:sp>
-        <p:nvSpPr>
-          <p:cNvPr id="3" name="Text 1"/>
-          <p:cNvSpPr txBox="1"/>
-          <p:nvPr/>
-        </p:nvSpPr>
-        <p:spPr>
-          <a:xfrm>
-            <a:off x="594360" y="384048"/>
-            <a:ext cx="10972800" cy="658368"/>
-          </a:xfrm>
-          <a:prstGeom prst="rect">
-            <a:avLst/>
-          </a:prstGeom>
-          <a:noFill/>
-          <a:ln/>
-        </p:spPr>
-        <p:txBody>
-          <a:bodyPr wrap="square" lIns="0" tIns="0" rIns="0" bIns="0" rtlCol="0" anchor="ctr"/>
-          <a:lstStyle/>
-          <a:p>
-            <a:pPr marL="0" indent="0">
-              <a:buNone/>
-            </a:pPr>
-            <a:r>
-              <a:rPr lang="en-US" sz="2700" b="1" dirty="0">
-                <a:solidFill>
-                  <a:srgbClr val="16232B"/>
-                </a:solidFill>
-                <a:latin typeface="Cambria" pitchFamily="34" charset="0"/>
-                <a:ea typeface="Cambria" pitchFamily="34" charset="-122"/>
-                <a:cs typeface="Cambria" pitchFamily="34" charset="-120"/>
-              </a:rPr>
-              <a:t>Le week-end ne gonfle pas les paniers, il les déplace</a:t>
-            </a:r>
-            <a:endParaRPr lang="en-US" sz="2700" dirty="0"/>
-          </a:p>
-        </p:txBody>
-      </p:sp>
-      <p:pic>
-        <p:nvPicPr>
-          <p:cNvPr id="4" name="Image 0" descr="02_projet\_ppt\fig06.png"/>
-          <p:cNvPicPr>
-            <a:picLocks noChangeAspect="1"/>
-          </p:cNvPicPr>
-          <p:nvPr/>
-        </p:nvPicPr>
-        <p:blipFill>
-          <a:blip r:embed="rId3"/>
-          <a:stretch>
-            <a:fillRect/>
-          </a:stretch>
-        </p:blipFill>
-        <p:spPr>
-          <a:xfrm>
-            <a:off x="594360" y="1481726"/>
-            <a:ext cx="6903720" cy="3565364"/>
-          </a:xfrm>
-          <a:prstGeom prst="rect">
-            <a:avLst/>
-          </a:prstGeom>
-        </p:spPr>
-      </p:pic>
-      <p:sp>
-        <p:nvSpPr>
-          <p:cNvPr id="5" name="Text 2"/>
-          <p:cNvSpPr txBox="1"/>
-          <p:nvPr/>
-        </p:nvSpPr>
-        <p:spPr>
-          <a:xfrm>
-            <a:off x="594360" y="5440680"/>
-            <a:ext cx="6903720" cy="457200"/>
-          </a:xfrm>
-          <a:prstGeom prst="rect">
-            <a:avLst/>
-          </a:prstGeom>
-          <a:noFill/>
-          <a:ln/>
-        </p:spPr>
-        <p:txBody>
-          <a:bodyPr wrap="square" lIns="0" tIns="0" rIns="0" bIns="0" rtlCol="0" anchor="t"/>
-          <a:lstStyle/>
-          <a:p>
-            <a:pPr marL="0" indent="0">
-              <a:buNone/>
-            </a:pPr>
-            <a:r>
-              <a:rPr lang="en-US" sz="1100" i="1" dirty="0">
-                <a:solidFill>
-                  <a:srgbClr val="5D6B75"/>
-                </a:solidFill>
-                <a:latin typeface="Calibri" pitchFamily="34" charset="0"/>
-                <a:ea typeface="Calibri" pitchFamily="34" charset="-122"/>
-                <a:cs typeface="Calibri" pitchFamily="34" charset="-120"/>
-              </a:rPr>
-              <a:t>Les petits paniers reculent de 7 points au profit des gros.</a:t>
-            </a:r>
-            <a:endParaRPr lang="en-US" sz="1100" dirty="0"/>
-          </a:p>
-        </p:txBody>
-      </p:sp>
-      <p:sp>
-        <p:nvSpPr>
-          <p:cNvPr id="6" name="Shape 3"/>
-          <p:cNvSpPr/>
-          <p:nvPr/>
-        </p:nvSpPr>
-        <p:spPr>
-          <a:xfrm>
-            <a:off x="7818120" y="1207008"/>
-            <a:ext cx="3749040" cy="3200400"/>
-          </a:xfrm>
-          <a:prstGeom prst="roundRect">
-            <a:avLst>
-              <a:gd name="adj" fmla="val 1714"/>
-            </a:avLst>
-          </a:prstGeom>
-          <a:solidFill>
-            <a:srgbClr val="EAF3F4"/>
-          </a:solidFill>
-          <a:ln w="12700">
-            <a:solidFill>
-              <a:srgbClr val="D3E5E7"/>
-            </a:solidFill>
-            <a:prstDash val="solid"/>
-          </a:ln>
-        </p:spPr>
-        <p:txBody>
-          <a:bodyPr/>
-          <a:lstStyle/>
-          <a:p>
-            <a:endParaRPr lang="fr-FR"/>
-          </a:p>
-        </p:txBody>
-      </p:sp>
-      <p:sp>
-        <p:nvSpPr>
-          <p:cNvPr id="7" name="Text 4"/>
-          <p:cNvSpPr txBox="1"/>
-          <p:nvPr/>
-        </p:nvSpPr>
-        <p:spPr>
-          <a:xfrm>
-            <a:off x="8074152" y="1389888"/>
-            <a:ext cx="3236976" cy="219456"/>
-          </a:xfrm>
-          <a:prstGeom prst="rect">
-            <a:avLst/>
-          </a:prstGeom>
-          <a:noFill/>
-          <a:ln/>
-        </p:spPr>
-        <p:txBody>
-          <a:bodyPr wrap="square" lIns="0" tIns="0" rIns="0" bIns="0" rtlCol="0" anchor="ctr"/>
-          <a:lstStyle/>
-          <a:p>
-            <a:pPr marL="0" indent="0">
-              <a:buNone/>
-            </a:pPr>
-            <a:r>
-              <a:rPr lang="en-US" sz="950" b="1" kern="0" spc="120" dirty="0">
-                <a:solidFill>
-                  <a:srgbClr val="0E7C86"/>
-                </a:solidFill>
-                <a:latin typeface="Calibri" pitchFamily="34" charset="0"/>
-                <a:ea typeface="Calibri" pitchFamily="34" charset="-122"/>
-                <a:cs typeface="Calibri" pitchFamily="34" charset="-120"/>
-              </a:rPr>
-              <a:t>CE QUE NOUS PROPOSONS</a:t>
-            </a:r>
-            <a:endParaRPr lang="en-US" sz="950" dirty="0"/>
-          </a:p>
-        </p:txBody>
-      </p:sp>
-      <p:sp>
-        <p:nvSpPr>
-          <p:cNvPr id="8" name="Text 5"/>
-          <p:cNvSpPr txBox="1"/>
-          <p:nvPr/>
-        </p:nvSpPr>
-        <p:spPr>
-          <a:xfrm>
-            <a:off x="8074152" y="1682496"/>
-            <a:ext cx="3236976" cy="2505456"/>
-          </a:xfrm>
-          <a:prstGeom prst="rect">
-            <a:avLst/>
-          </a:prstGeom>
-          <a:noFill/>
-          <a:ln/>
-        </p:spPr>
-        <p:txBody>
-          <a:bodyPr wrap="square" lIns="0" tIns="0" rIns="0" bIns="0" rtlCol="0" anchor="t"/>
-          <a:lstStyle/>
-          <a:p>
-            <a:pPr marL="0" indent="0">
-              <a:lnSpc>
-                <a:spcPct val="110000"/>
-              </a:lnSpc>
-              <a:buNone/>
-            </a:pPr>
-            <a:r>
-              <a:rPr lang="en-US" sz="1300" dirty="0">
-                <a:solidFill>
-                  <a:srgbClr val="16232B"/>
-                </a:solidFill>
-                <a:latin typeface="Calibri" pitchFamily="34" charset="0"/>
-                <a:ea typeface="Calibri" pitchFamily="34" charset="-122"/>
-                <a:cs typeface="Calibri" pitchFamily="34" charset="-120"/>
-              </a:rPr>
-              <a:t>Placer les offres à seuil — « livraison offerte dès X articles » — le week-end, où les gros paniers sont déjà la norme.</a:t>
-            </a:r>
-            <a:endParaRPr lang="en-US" sz="1300" dirty="0"/>
-          </a:p>
-        </p:txBody>
-      </p:sp>
-      <p:sp>
-        <p:nvSpPr>
-          <p:cNvPr id="9" name="Text 6"/>
-          <p:cNvSpPr txBox="1"/>
-          <p:nvPr/>
-        </p:nvSpPr>
-        <p:spPr>
-          <a:xfrm>
-            <a:off x="7818120" y="4663440"/>
-            <a:ext cx="548640" cy="548640"/>
-          </a:xfrm>
-          <a:prstGeom prst="rect">
-            <a:avLst/>
-          </a:prstGeom>
-          <a:noFill/>
-          <a:ln/>
-        </p:spPr>
-        <p:txBody>
-          <a:bodyPr wrap="square" lIns="0" tIns="0" rIns="0" bIns="0" rtlCol="0" anchor="ctr"/>
-          <a:lstStyle/>
-          <a:p>
-            <a:pPr marL="0" indent="0">
-              <a:buNone/>
-            </a:pPr>
-            <a:r>
-              <a:rPr lang="en-US" sz="3400" b="1" dirty="0">
-                <a:solidFill>
-                  <a:srgbClr val="D8E4E6"/>
-                </a:solidFill>
-                <a:latin typeface="Cambria" pitchFamily="34" charset="0"/>
-                <a:ea typeface="Cambria" pitchFamily="34" charset="-122"/>
-                <a:cs typeface="Cambria" pitchFamily="34" charset="-120"/>
-              </a:rPr>
-              <a:t>6</a:t>
             </a:r>
             <a:endParaRPr lang="en-US" sz="3400" dirty="0"/>
           </a:p>

</xml_diff>